<commit_message>
Nettoyage projet + presentation pour soutenance
- Suppression de 29 fichiers inutiles : templates Kedro spaceflights,
  anciens scripts NLP (run_nlp_cleaning.py, nlp_cleaning.py), cours PDF,
  ancien DAG Airflow run_pipeline.py, fichiers debug/temp
- run_all.py : etape 'clean' migree vers kedro run --pipeline nlp_cleaning
- README.md : architecture mise a jour (posts_clean_kedro, ref nlp_cleaning.py retiree)
- Thumalien_Soutenance_GreenIT.pptx : 18 slides mis a jour
  * Slide 5 Architecture : Kedro NLP, GitHub Actions CI/CD, Kedro 1.2 + Airflow dans la stack
  * Slide 8 Kanban : 8 termines (tests CI/CD faits), 3 a faire restants
  * Slide 9 Travaux 1 : pipeline Kedro 7 nodes, volumetrie 100 000 posts Jetstream
  * Slide 14 (nouveau) : TRAVAUX 5 - Kedro, Airflow, GitHub Actions avec metriques
  * Slide 17 Perspectives : CI/CD operationnel, tests restants documented

Co-Authored-By: Claude Sonnet 4.6 <noreply@anthropic.com>
</commit_message>
<xml_diff>
--- a/Thumalien_Soutenance_GreenIT.pptx
+++ b/Thumalien_Soutenance_GreenIT.pptx
@@ -21,6 +21,7 @@
     <p:sldId id="265" r:id="rId11"/>
     <p:sldId id="266" r:id="rId12"/>
     <p:sldId id="267" r:id="rId13"/>
+    <p:sldId id="273" r:id="rId24"/>
     <p:sldId id="268" r:id="rId14"/>
     <p:sldId id="271" r:id="rId15"/>
     <p:sldId id="269" r:id="rId16"/>
@@ -5977,6 +5978,934 @@
 </file>
 
 <file path=ppt/slides/slide14.xml><?xml version="1.0" encoding="utf-8"?>
+<p:sld xmlns:a="http://schemas.openxmlformats.org/drawingml/2006/main" xmlns:p="http://schemas.openxmlformats.org/presentationml/2006/main" xmlns:r="http://schemas.openxmlformats.org/officeDocument/2006/relationships">
+  <p:cSld>
+    <p:spTree>
+      <p:nvGrpSpPr>
+        <p:cNvPr id="1" name=""/>
+        <p:cNvGrpSpPr/>
+        <p:nvPr/>
+      </p:nvGrpSpPr>
+      <p:grpSpPr>
+        <a:xfrm>
+          <a:off x="0" y="0"/>
+          <a:ext cx="0" cy="0"/>
+          <a:chOff x="0" y="0"/>
+          <a:chExt cx="0" cy="0"/>
+        </a:xfrm>
+      </p:grpSpPr>
+      <p:sp>
+        <p:nvSpPr>
+          <p:cNvPr id="2" name="Text 0"/>
+          <p:cNvSpPr/>
+          <p:nvPr/>
+        </p:nvSpPr>
+        <p:spPr>
+          <a:xfrm>
+            <a:off x="548640" y="384048"/>
+            <a:ext cx="8046720" cy="274320"/>
+          </a:xfrm>
+          <a:prstGeom prst="rect">
+            <a:avLst/>
+          </a:prstGeom>
+          <a:noFill/>
+          <a:ln/>
+        </p:spPr>
+        <p:txBody>
+          <a:bodyPr wrap="square" lIns="0" tIns="0" rIns="0" bIns="0" rtlCol="0" anchor="ctr"/>
+          <a:lstStyle/>
+          <a:p>
+            <a:pPr marL="0" indent="0">
+              <a:buNone/>
+            </a:pPr>
+            <a:r>
+              <a:rPr lang="en-US" sz="1100" b="1" kern="0" spc="300" dirty="0">
+                <a:solidFill>
+                  <a:srgbClr val="45818E"/>
+                </a:solidFill>
+                <a:latin typeface="Calibri" pitchFamily="34" charset="0"/>
+                <a:ea typeface="Calibri" pitchFamily="34" charset="-122"/>
+                <a:cs typeface="Calibri" pitchFamily="34" charset="-120"/>
+              </a:rPr>
+              <a:t>TRAVAUX REALISES - 5</a:t>
+            </a:r>
+            <a:endParaRPr lang="en-US" sz="1100" dirty="0"/>
+          </a:p>
+        </p:txBody>
+      </p:sp>
+      <p:sp>
+        <p:nvSpPr>
+          <p:cNvPr id="3" name="Text 1"/>
+          <p:cNvSpPr/>
+          <p:nvPr/>
+        </p:nvSpPr>
+        <p:spPr>
+          <a:xfrm>
+            <a:off x="548640" y="621792"/>
+            <a:ext cx="8046720" cy="566928"/>
+          </a:xfrm>
+          <a:prstGeom prst="rect">
+            <a:avLst/>
+          </a:prstGeom>
+          <a:noFill/>
+          <a:ln/>
+        </p:spPr>
+        <p:txBody>
+          <a:bodyPr wrap="square" lIns="0" tIns="0" rIns="0" bIns="0" rtlCol="0" anchor="ctr"/>
+          <a:lstStyle/>
+          <a:p>
+            <a:pPr marL="0" indent="0">
+              <a:buNone/>
+            </a:pPr>
+            <a:r>
+              <a:rPr lang="en-US" sz="2700" b="1" dirty="0">
+                <a:solidFill>
+                  <a:srgbClr val="0C343D"/>
+                </a:solidFill>
+                <a:latin typeface="Calibri" pitchFamily="34" charset="0"/>
+                <a:ea typeface="Calibri" pitchFamily="34" charset="-122"/>
+                <a:cs typeface="Calibri" pitchFamily="34" charset="-120"/>
+              </a:rPr>
+              <a:t>Ingenierie &amp; automatisation</a:t>
+            </a:r>
+            <a:endParaRPr lang="en-US" sz="2700" dirty="0"/>
+          </a:p>
+        </p:txBody>
+      </p:sp>
+      <p:sp>
+        <p:nvSpPr>
+          <p:cNvPr id="4" name="Shape 2"/>
+          <p:cNvSpPr/>
+          <p:nvPr/>
+        </p:nvSpPr>
+        <p:spPr>
+          <a:xfrm>
+            <a:off x="548640" y="1463040"/>
+            <a:ext cx="5074920" cy="1261872"/>
+          </a:xfrm>
+          <a:prstGeom prst="roundRect">
+            <a:avLst>
+              <a:gd name="adj" fmla="val 5797"/>
+            </a:avLst>
+          </a:prstGeom>
+          <a:solidFill>
+            <a:srgbClr val="FFFFFF"/>
+          </a:solidFill>
+          <a:ln/>
+          <a:effectLst>
+            <a:outerShdw blurRad="88900" dist="38100" dir="5400000" algn="bl" rotWithShape="0">
+              <a:srgbClr val="0C343D">
+                <a:alpha val="18000"/>
+              </a:srgbClr>
+            </a:outerShdw>
+          </a:effectLst>
+        </p:spPr>
+        <p:txBody>
+          <a:bodyPr/>
+          <a:lstStyle/>
+          <a:p>
+            <a:endParaRPr lang="fr-FR"/>
+          </a:p>
+        </p:txBody>
+      </p:sp>
+      <p:sp>
+        <p:nvSpPr>
+          <p:cNvPr id="5" name="Shape 3"/>
+          <p:cNvSpPr/>
+          <p:nvPr/>
+        </p:nvSpPr>
+        <p:spPr>
+          <a:xfrm>
+            <a:off x="731520" y="1719072"/>
+            <a:ext cx="731520" cy="731520"/>
+          </a:xfrm>
+          <a:prstGeom prst="ellipse">
+            <a:avLst/>
+          </a:prstGeom>
+          <a:solidFill>
+            <a:srgbClr val="134F5C"/>
+          </a:solidFill>
+          <a:ln/>
+        </p:spPr>
+        <p:txBody>
+          <a:bodyPr/>
+          <a:lstStyle/>
+          <a:p>
+            <a:endParaRPr lang="fr-FR"/>
+          </a:p>
+        </p:txBody>
+      </p:sp>
+      <p:sp>
+        <p:nvSpPr>
+          <p:cNvPr id="6" name="Text 4"/>
+          <p:cNvSpPr/>
+          <p:nvPr/>
+        </p:nvSpPr>
+        <p:spPr>
+          <a:xfrm>
+            <a:off x="731520" y="1719072"/>
+            <a:ext cx="731520" cy="731520"/>
+          </a:xfrm>
+          <a:prstGeom prst="rect">
+            <a:avLst/>
+          </a:prstGeom>
+          <a:noFill/>
+          <a:ln/>
+        </p:spPr>
+        <p:txBody>
+          <a:bodyPr wrap="square" lIns="0" tIns="0" rIns="0" bIns="0" rtlCol="0" anchor="ctr"/>
+          <a:lstStyle/>
+          <a:p>
+            <a:pPr marL="0" indent="0" algn="ctr">
+              <a:buNone/>
+            </a:pPr>
+            <a:r>
+              <a:rPr lang="en-US" sz="3000" b="1" dirty="0">
+                <a:solidFill>
+                  <a:srgbClr val="FFFFFF"/>
+                </a:solidFill>
+                <a:latin typeface="Calibri" pitchFamily="34" charset="0"/>
+                <a:ea typeface="Calibri" pitchFamily="34" charset="-122"/>
+                <a:cs typeface="Calibri" pitchFamily="34" charset="-120"/>
+              </a:rPr>
+              <a:t>1</a:t>
+            </a:r>
+            <a:endParaRPr lang="en-US" sz="3000" dirty="0"/>
+          </a:p>
+        </p:txBody>
+      </p:sp>
+      <p:sp>
+        <p:nvSpPr>
+          <p:cNvPr id="7" name="Text 5"/>
+          <p:cNvSpPr/>
+          <p:nvPr/>
+        </p:nvSpPr>
+        <p:spPr>
+          <a:xfrm>
+            <a:off x="1627632" y="1627632"/>
+            <a:ext cx="3886200" cy="310896"/>
+          </a:xfrm>
+          <a:prstGeom prst="rect">
+            <a:avLst/>
+          </a:prstGeom>
+          <a:noFill/>
+          <a:ln/>
+        </p:spPr>
+        <p:txBody>
+          <a:bodyPr wrap="square" lIns="0" tIns="0" rIns="0" bIns="0" rtlCol="0" anchor="ctr"/>
+          <a:lstStyle/>
+          <a:p>
+            <a:pPr marL="0" indent="0">
+              <a:buNone/>
+            </a:pPr>
+            <a:r>
+              <a:rPr lang="en-US" sz="1450" b="1" dirty="0">
+                <a:solidFill>
+                  <a:srgbClr val="0C343D"/>
+                </a:solidFill>
+                <a:latin typeface="Calibri" pitchFamily="34" charset="0"/>
+                <a:ea typeface="Calibri" pitchFamily="34" charset="-122"/>
+                <a:cs typeface="Calibri" pitchFamily="34" charset="-120"/>
+              </a:rPr>
+              <a:t>Pipeline NLP structure (Kedro 1.2)</a:t>
+            </a:r>
+            <a:endParaRPr lang="en-US" sz="1450" dirty="0"/>
+          </a:p>
+        </p:txBody>
+      </p:sp>
+      <p:sp>
+        <p:nvSpPr>
+          <p:cNvPr id="8" name="Text 6"/>
+          <p:cNvSpPr/>
+          <p:nvPr/>
+        </p:nvSpPr>
+        <p:spPr>
+          <a:xfrm>
+            <a:off x="1627632" y="1920240"/>
+            <a:ext cx="3931920" cy="749808"/>
+          </a:xfrm>
+          <a:prstGeom prst="rect">
+            <a:avLst/>
+          </a:prstGeom>
+          <a:noFill/>
+          <a:ln/>
+        </p:spPr>
+        <p:txBody>
+          <a:bodyPr wrap="square" lIns="0" tIns="0" rIns="0" bIns="0" rtlCol="0" anchor="ctr"/>
+          <a:lstStyle/>
+          <a:p>
+            <a:pPr marL="0" indent="0">
+              <a:buNone/>
+            </a:pPr>
+            <a:r>
+              <a:rPr lang="en-US" sz="1000" dirty="0">
+                <a:solidFill>
+                  <a:srgbClr val="5B7B82"/>
+                </a:solidFill>
+                <a:latin typeface="Calibri" pitchFamily="34" charset="0"/>
+                <a:ea typeface="Calibri" pitchFamily="34" charset="-122"/>
+                <a:cs typeface="Calibri" pitchFamily="34" charset="-120"/>
+              </a:rPr>
+              <a:t>7 nodes chaines (fonctions pures testees) : extract -&gt; clean -&gt; detect_lang -&gt; normalize -&gt; tokenize -&gt; lemmatize -&gt; load. Datasets intermediaires en Parquet. Langue detectee sur le contenu reel via langdetect (pas le tag declare par l utilisateur). Visualisation : kedro viz run.</a:t>
+            </a:r>
+            <a:endParaRPr lang="en-US" sz="1000" dirty="0"/>
+          </a:p>
+        </p:txBody>
+      </p:sp>
+      <p:sp>
+        <p:nvSpPr>
+          <p:cNvPr id="9" name="Shape 7"/>
+          <p:cNvSpPr/>
+          <p:nvPr/>
+        </p:nvSpPr>
+        <p:spPr>
+          <a:xfrm>
+            <a:off x="548640" y="2880360"/>
+            <a:ext cx="5074920" cy="1261872"/>
+          </a:xfrm>
+          <a:prstGeom prst="roundRect">
+            <a:avLst>
+              <a:gd name="adj" fmla="val 5797"/>
+            </a:avLst>
+          </a:prstGeom>
+          <a:solidFill>
+            <a:srgbClr val="FFFFFF"/>
+          </a:solidFill>
+          <a:ln/>
+          <a:effectLst>
+            <a:outerShdw blurRad="88900" dist="38100" dir="5400000" algn="bl" rotWithShape="0">
+              <a:srgbClr val="0C343D">
+                <a:alpha val="18000"/>
+              </a:srgbClr>
+            </a:outerShdw>
+          </a:effectLst>
+        </p:spPr>
+        <p:txBody>
+          <a:bodyPr/>
+          <a:lstStyle/>
+          <a:p>
+            <a:endParaRPr lang="fr-FR"/>
+          </a:p>
+        </p:txBody>
+      </p:sp>
+      <p:sp>
+        <p:nvSpPr>
+          <p:cNvPr id="10" name="Shape 8"/>
+          <p:cNvSpPr/>
+          <p:nvPr/>
+        </p:nvSpPr>
+        <p:spPr>
+          <a:xfrm>
+            <a:off x="731520" y="3136392"/>
+            <a:ext cx="731520" cy="731520"/>
+          </a:xfrm>
+          <a:prstGeom prst="ellipse">
+            <a:avLst/>
+          </a:prstGeom>
+          <a:solidFill>
+            <a:srgbClr val="134F5C"/>
+          </a:solidFill>
+          <a:ln/>
+        </p:spPr>
+        <p:txBody>
+          <a:bodyPr/>
+          <a:lstStyle/>
+          <a:p>
+            <a:endParaRPr lang="fr-FR"/>
+          </a:p>
+        </p:txBody>
+      </p:sp>
+      <p:sp>
+        <p:nvSpPr>
+          <p:cNvPr id="11" name="Text 9"/>
+          <p:cNvSpPr/>
+          <p:nvPr/>
+        </p:nvSpPr>
+        <p:spPr>
+          <a:xfrm>
+            <a:off x="731520" y="3136392"/>
+            <a:ext cx="731520" cy="731520"/>
+          </a:xfrm>
+          <a:prstGeom prst="rect">
+            <a:avLst/>
+          </a:prstGeom>
+          <a:noFill/>
+          <a:ln/>
+        </p:spPr>
+        <p:txBody>
+          <a:bodyPr wrap="square" lIns="0" tIns="0" rIns="0" bIns="0" rtlCol="0" anchor="ctr"/>
+          <a:lstStyle/>
+          <a:p>
+            <a:pPr marL="0" indent="0" algn="ctr">
+              <a:buNone/>
+            </a:pPr>
+            <a:r>
+              <a:rPr lang="en-US" sz="3000" b="1" dirty="0">
+                <a:solidFill>
+                  <a:srgbClr val="FFFFFF"/>
+                </a:solidFill>
+                <a:latin typeface="Calibri" pitchFamily="34" charset="0"/>
+                <a:ea typeface="Calibri" pitchFamily="34" charset="-122"/>
+                <a:cs typeface="Calibri" pitchFamily="34" charset="-120"/>
+              </a:rPr>
+              <a:t>2</a:t>
+            </a:r>
+            <a:endParaRPr lang="en-US" sz="3000" dirty="0"/>
+          </a:p>
+        </p:txBody>
+      </p:sp>
+      <p:sp>
+        <p:nvSpPr>
+          <p:cNvPr id="12" name="Text 10"/>
+          <p:cNvSpPr/>
+          <p:nvPr/>
+        </p:nvSpPr>
+        <p:spPr>
+          <a:xfrm>
+            <a:off x="1627632" y="3044952"/>
+            <a:ext cx="3886200" cy="310896"/>
+          </a:xfrm>
+          <a:prstGeom prst="rect">
+            <a:avLst/>
+          </a:prstGeom>
+          <a:noFill/>
+          <a:ln/>
+        </p:spPr>
+        <p:txBody>
+          <a:bodyPr wrap="square" lIns="0" tIns="0" rIns="0" bIns="0" rtlCol="0" anchor="ctr"/>
+          <a:lstStyle/>
+          <a:p>
+            <a:pPr marL="0" indent="0">
+              <a:buNone/>
+            </a:pPr>
+            <a:r>
+              <a:rPr lang="en-US" sz="1450" b="1" dirty="0">
+                <a:solidFill>
+                  <a:srgbClr val="0C343D"/>
+                </a:solidFill>
+                <a:latin typeface="Calibri" pitchFamily="34" charset="0"/>
+                <a:ea typeface="Calibri" pitchFamily="34" charset="-122"/>
+                <a:cs typeface="Calibri" pitchFamily="34" charset="-120"/>
+              </a:rPr>
+              <a:t>Airflow + GitHub Actions CI/CD</a:t>
+            </a:r>
+            <a:endParaRPr lang="en-US" sz="1450" dirty="0"/>
+          </a:p>
+        </p:txBody>
+      </p:sp>
+      <p:sp>
+        <p:nvSpPr>
+          <p:cNvPr id="13" name="Text 11"/>
+          <p:cNvSpPr/>
+          <p:nvPr/>
+        </p:nvSpPr>
+        <p:spPr>
+          <a:xfrm>
+            <a:off x="1627632" y="3337560"/>
+            <a:ext cx="3931920" cy="749808"/>
+          </a:xfrm>
+          <a:prstGeom prst="rect">
+            <a:avLst/>
+          </a:prstGeom>
+          <a:noFill/>
+          <a:ln/>
+        </p:spPr>
+        <p:txBody>
+          <a:bodyPr wrap="square" lIns="0" tIns="0" rIns="0" bIns="0" rtlCol="0" anchor="ctr"/>
+          <a:lstStyle/>
+          <a:p>
+            <a:pPr marL="0" indent="0">
+              <a:buNone/>
+            </a:pPr>
+            <a:r>
+              <a:rPr lang="en-US" sz="1000" dirty="0">
+                <a:solidFill>
+                  <a:srgbClr val="5B7B82"/>
+                </a:solidFill>
+                <a:latin typeface="Calibri" pitchFamily="34" charset="0"/>
+                <a:ea typeface="Calibri" pitchFamily="34" charset="-122"/>
+                <a:cs typeface="Calibri" pitchFamily="34" charset="-120"/>
+              </a:rPr>
+              <a:t>DAG bluesky_pipeline : collecte -&gt; pipeline Kedro NLP, declenchement quotidien a 00h00. CI/CD GitHub Actions sur push (main/dev) : 25 tests unitaires pytest (nodes 2-6) + lint ruff. Pipeline vert en continu.</a:t>
+            </a:r>
+            <a:endParaRPr lang="en-US" sz="1000" dirty="0"/>
+          </a:p>
+        </p:txBody>
+      </p:sp>
+      <p:sp>
+        <p:nvSpPr>
+          <p:cNvPr id="14" name="Shape 12"/>
+          <p:cNvSpPr/>
+          <p:nvPr/>
+        </p:nvSpPr>
+        <p:spPr>
+          <a:xfrm>
+            <a:off x="5852160" y="1463040"/>
+            <a:ext cx="2743200" cy="2679192"/>
+          </a:xfrm>
+          <a:prstGeom prst="roundRect">
+            <a:avLst>
+              <a:gd name="adj" fmla="val 2730"/>
+            </a:avLst>
+          </a:prstGeom>
+          <a:solidFill>
+            <a:srgbClr val="0C343D"/>
+          </a:solidFill>
+          <a:ln/>
+          <a:effectLst>
+            <a:outerShdw blurRad="88900" dist="38100" dir="5400000" algn="bl" rotWithShape="0">
+              <a:srgbClr val="0C343D">
+                <a:alpha val="18000"/>
+              </a:srgbClr>
+            </a:outerShdw>
+          </a:effectLst>
+        </p:spPr>
+        <p:txBody>
+          <a:bodyPr/>
+          <a:lstStyle/>
+          <a:p>
+            <a:endParaRPr lang="fr-FR"/>
+          </a:p>
+        </p:txBody>
+      </p:sp>
+      <p:sp>
+        <p:nvSpPr>
+          <p:cNvPr id="15" name="Text 13"/>
+          <p:cNvSpPr/>
+          <p:nvPr/>
+        </p:nvSpPr>
+        <p:spPr>
+          <a:xfrm>
+            <a:off x="6035040" y="1645920"/>
+            <a:ext cx="2377440" cy="274320"/>
+          </a:xfrm>
+          <a:prstGeom prst="rect">
+            <a:avLst/>
+          </a:prstGeom>
+          <a:noFill/>
+          <a:ln/>
+        </p:spPr>
+        <p:txBody>
+          <a:bodyPr wrap="square" lIns="0" tIns="0" rIns="0" bIns="0" rtlCol="0" anchor="ctr"/>
+          <a:lstStyle/>
+          <a:p>
+            <a:pPr marL="0" indent="0">
+              <a:buNone/>
+            </a:pPr>
+            <a:r>
+              <a:rPr lang="en-US" sz="1100" b="1" kern="0" spc="200" dirty="0">
+                <a:solidFill>
+                  <a:srgbClr val="76A5AF"/>
+                </a:solidFill>
+                <a:latin typeface="Calibri" pitchFamily="34" charset="0"/>
+                <a:ea typeface="Calibri" pitchFamily="34" charset="-122"/>
+                <a:cs typeface="Calibri" pitchFamily="34" charset="-120"/>
+              </a:rPr>
+              <a:t>METRIQUES</a:t>
+            </a:r>
+            <a:endParaRPr lang="en-US" sz="1100" dirty="0"/>
+          </a:p>
+        </p:txBody>
+      </p:sp>
+      <p:sp>
+        <p:nvSpPr>
+          <p:cNvPr id="16" name="Text 14"/>
+          <p:cNvSpPr/>
+          <p:nvPr/>
+        </p:nvSpPr>
+        <p:spPr>
+          <a:xfrm>
+            <a:off x="6035040" y="1993392"/>
+            <a:ext cx="1051560" cy="457200"/>
+          </a:xfrm>
+          <a:prstGeom prst="rect">
+            <a:avLst/>
+          </a:prstGeom>
+          <a:noFill/>
+          <a:ln/>
+        </p:spPr>
+        <p:txBody>
+          <a:bodyPr wrap="square" lIns="0" tIns="0" rIns="0" bIns="0" rtlCol="0" anchor="ctr"/>
+          <a:lstStyle/>
+          <a:p>
+            <a:pPr marL="0" indent="0">
+              <a:buNone/>
+            </a:pPr>
+            <a:r>
+              <a:rPr lang="en-US" sz="2200" b="1" dirty="0">
+                <a:solidFill>
+                  <a:srgbClr val="D9EAD3"/>
+                </a:solidFill>
+                <a:latin typeface="Calibri" pitchFamily="34" charset="0"/>
+                <a:ea typeface="Calibri" pitchFamily="34" charset="-122"/>
+                <a:cs typeface="Calibri" pitchFamily="34" charset="-120"/>
+              </a:rPr>
+              <a:t>7</a:t>
+            </a:r>
+            <a:endParaRPr lang="en-US" sz="2200" dirty="0"/>
+          </a:p>
+        </p:txBody>
+      </p:sp>
+      <p:sp>
+        <p:nvSpPr>
+          <p:cNvPr id="17" name="Text 15"/>
+          <p:cNvSpPr/>
+          <p:nvPr/>
+        </p:nvSpPr>
+        <p:spPr>
+          <a:xfrm>
+            <a:off x="7086600" y="1993392"/>
+            <a:ext cx="1417320" cy="457200"/>
+          </a:xfrm>
+          <a:prstGeom prst="rect">
+            <a:avLst/>
+          </a:prstGeom>
+          <a:noFill/>
+          <a:ln/>
+        </p:spPr>
+        <p:txBody>
+          <a:bodyPr wrap="square" lIns="0" tIns="0" rIns="0" bIns="0" rtlCol="0" anchor="ctr"/>
+          <a:lstStyle/>
+          <a:p>
+            <a:pPr marL="0" indent="0">
+              <a:buNone/>
+            </a:pPr>
+            <a:r>
+              <a:rPr lang="en-US" sz="950" dirty="0">
+                <a:solidFill>
+                  <a:srgbClr val="76A5AF"/>
+                </a:solidFill>
+                <a:latin typeface="Calibri" pitchFamily="34" charset="0"/>
+                <a:ea typeface="Calibri" pitchFamily="34" charset="-122"/>
+                <a:cs typeface="Calibri" pitchFamily="34" charset="-120"/>
+              </a:rPr>
+              <a:t>nodes Kedro</a:t>
+            </a:r>
+            <a:endParaRPr lang="en-US" sz="950" dirty="0"/>
+          </a:p>
+        </p:txBody>
+      </p:sp>
+      <p:sp>
+        <p:nvSpPr>
+          <p:cNvPr id="18" name="Text 16"/>
+          <p:cNvSpPr/>
+          <p:nvPr/>
+        </p:nvSpPr>
+        <p:spPr>
+          <a:xfrm>
+            <a:off x="6035040" y="2542032"/>
+            <a:ext cx="1051560" cy="457200"/>
+          </a:xfrm>
+          <a:prstGeom prst="rect">
+            <a:avLst/>
+          </a:prstGeom>
+          <a:noFill/>
+          <a:ln/>
+        </p:spPr>
+        <p:txBody>
+          <a:bodyPr wrap="square" lIns="0" tIns="0" rIns="0" bIns="0" rtlCol="0" anchor="ctr"/>
+          <a:lstStyle/>
+          <a:p>
+            <a:pPr marL="0" indent="0">
+              <a:buNone/>
+            </a:pPr>
+            <a:r>
+              <a:rPr lang="en-US" sz="2200" b="1" dirty="0">
+                <a:solidFill>
+                  <a:srgbClr val="D9EAD3"/>
+                </a:solidFill>
+                <a:latin typeface="Calibri" pitchFamily="34" charset="0"/>
+                <a:ea typeface="Calibri" pitchFamily="34" charset="-122"/>
+                <a:cs typeface="Calibri" pitchFamily="34" charset="-120"/>
+              </a:rPr>
+              <a:t>25</a:t>
+            </a:r>
+            <a:endParaRPr lang="en-US" sz="2200" dirty="0"/>
+          </a:p>
+        </p:txBody>
+      </p:sp>
+      <p:sp>
+        <p:nvSpPr>
+          <p:cNvPr id="19" name="Text 17"/>
+          <p:cNvSpPr/>
+          <p:nvPr/>
+        </p:nvSpPr>
+        <p:spPr>
+          <a:xfrm>
+            <a:off x="7086600" y="2542032"/>
+            <a:ext cx="1417320" cy="457200"/>
+          </a:xfrm>
+          <a:prstGeom prst="rect">
+            <a:avLst/>
+          </a:prstGeom>
+          <a:noFill/>
+          <a:ln/>
+        </p:spPr>
+        <p:txBody>
+          <a:bodyPr wrap="square" lIns="0" tIns="0" rIns="0" bIns="0" rtlCol="0" anchor="ctr"/>
+          <a:lstStyle/>
+          <a:p>
+            <a:pPr marL="0" indent="0">
+              <a:buNone/>
+            </a:pPr>
+            <a:r>
+              <a:rPr lang="en-US" sz="950" dirty="0">
+                <a:solidFill>
+                  <a:srgbClr val="76A5AF"/>
+                </a:solidFill>
+                <a:latin typeface="Calibri" pitchFamily="34" charset="0"/>
+                <a:ea typeface="Calibri" pitchFamily="34" charset="-122"/>
+                <a:cs typeface="Calibri" pitchFamily="34" charset="-120"/>
+              </a:rPr>
+              <a:t>tests unitaires</a:t>
+            </a:r>
+            <a:endParaRPr lang="en-US" sz="950" dirty="0"/>
+          </a:p>
+        </p:txBody>
+      </p:sp>
+      <p:sp>
+        <p:nvSpPr>
+          <p:cNvPr id="20" name="Text 18"/>
+          <p:cNvSpPr/>
+          <p:nvPr/>
+        </p:nvSpPr>
+        <p:spPr>
+          <a:xfrm>
+            <a:off x="6035040" y="3090672"/>
+            <a:ext cx="1051560" cy="457200"/>
+          </a:xfrm>
+          <a:prstGeom prst="rect">
+            <a:avLst/>
+          </a:prstGeom>
+          <a:noFill/>
+          <a:ln/>
+        </p:spPr>
+        <p:txBody>
+          <a:bodyPr wrap="square" lIns="0" tIns="0" rIns="0" bIns="0" rtlCol="0" anchor="ctr"/>
+          <a:lstStyle/>
+          <a:p>
+            <a:pPr marL="0" indent="0">
+              <a:buNone/>
+            </a:pPr>
+            <a:r>
+              <a:rPr lang="en-US" sz="2200" b="1" dirty="0">
+                <a:solidFill>
+                  <a:srgbClr val="D9EAD3"/>
+                </a:solidFill>
+                <a:latin typeface="Calibri" pitchFamily="34" charset="0"/>
+                <a:ea typeface="Calibri" pitchFamily="34" charset="-122"/>
+                <a:cs typeface="Calibri" pitchFamily="34" charset="-120"/>
+              </a:rPr>
+              <a:t>1</a:t>
+            </a:r>
+            <a:endParaRPr lang="en-US" sz="2200" dirty="0"/>
+          </a:p>
+        </p:txBody>
+      </p:sp>
+      <p:sp>
+        <p:nvSpPr>
+          <p:cNvPr id="21" name="Text 19"/>
+          <p:cNvSpPr/>
+          <p:nvPr/>
+        </p:nvSpPr>
+        <p:spPr>
+          <a:xfrm>
+            <a:off x="7086600" y="3090672"/>
+            <a:ext cx="1417320" cy="457200"/>
+          </a:xfrm>
+          <a:prstGeom prst="rect">
+            <a:avLst/>
+          </a:prstGeom>
+          <a:noFill/>
+          <a:ln/>
+        </p:spPr>
+        <p:txBody>
+          <a:bodyPr wrap="square" lIns="0" tIns="0" rIns="0" bIns="0" rtlCol="0" anchor="ctr"/>
+          <a:lstStyle/>
+          <a:p>
+            <a:pPr marL="0" indent="0">
+              <a:buNone/>
+            </a:pPr>
+            <a:r>
+              <a:rPr lang="en-US" sz="950" dirty="0">
+                <a:solidFill>
+                  <a:srgbClr val="76A5AF"/>
+                </a:solidFill>
+                <a:latin typeface="Calibri" pitchFamily="34" charset="0"/>
+                <a:ea typeface="Calibri" pitchFamily="34" charset="-122"/>
+                <a:cs typeface="Calibri" pitchFamily="34" charset="-120"/>
+              </a:rPr>
+              <a:t>DAG Airflow</a:t>
+            </a:r>
+            <a:endParaRPr lang="en-US" sz="950" dirty="0"/>
+          </a:p>
+        </p:txBody>
+      </p:sp>
+      <p:sp>
+        <p:nvSpPr>
+          <p:cNvPr id="22" name="Text 20"/>
+          <p:cNvSpPr/>
+          <p:nvPr/>
+        </p:nvSpPr>
+        <p:spPr>
+          <a:xfrm>
+            <a:off x="6035040" y="3639312"/>
+            <a:ext cx="1051560" cy="457200"/>
+          </a:xfrm>
+          <a:prstGeom prst="rect">
+            <a:avLst/>
+          </a:prstGeom>
+          <a:noFill/>
+          <a:ln/>
+        </p:spPr>
+        <p:txBody>
+          <a:bodyPr wrap="square" lIns="0" tIns="0" rIns="0" bIns="0" rtlCol="0" anchor="ctr"/>
+          <a:lstStyle/>
+          <a:p>
+            <a:pPr marL="0" indent="0">
+              <a:buNone/>
+            </a:pPr>
+            <a:r>
+              <a:rPr lang="en-US" sz="2200" b="1" dirty="0">
+                <a:solidFill>
+                  <a:srgbClr val="D9EAD3"/>
+                </a:solidFill>
+                <a:latin typeface="Calibri" pitchFamily="34" charset="0"/>
+                <a:ea typeface="Calibri" pitchFamily="34" charset="-122"/>
+                <a:cs typeface="Calibri" pitchFamily="34" charset="-120"/>
+              </a:rPr>
+              <a:t>100%</a:t>
+            </a:r>
+            <a:endParaRPr lang="en-US" sz="2200" dirty="0"/>
+          </a:p>
+        </p:txBody>
+      </p:sp>
+      <p:sp>
+        <p:nvSpPr>
+          <p:cNvPr id="23" name="Text 21"/>
+          <p:cNvSpPr/>
+          <p:nvPr/>
+        </p:nvSpPr>
+        <p:spPr>
+          <a:xfrm>
+            <a:off x="7086600" y="3639312"/>
+            <a:ext cx="1417320" cy="457200"/>
+          </a:xfrm>
+          <a:prstGeom prst="rect">
+            <a:avLst/>
+          </a:prstGeom>
+          <a:noFill/>
+          <a:ln/>
+        </p:spPr>
+        <p:txBody>
+          <a:bodyPr wrap="square" lIns="0" tIns="0" rIns="0" bIns="0" rtlCol="0" anchor="ctr"/>
+          <a:lstStyle/>
+          <a:p>
+            <a:pPr marL="0" indent="0">
+              <a:buNone/>
+            </a:pPr>
+            <a:r>
+              <a:rPr lang="en-US" sz="950" dirty="0">
+                <a:solidFill>
+                  <a:srgbClr val="76A5AF"/>
+                </a:solidFill>
+                <a:latin typeface="Calibri" pitchFamily="34" charset="0"/>
+                <a:ea typeface="Calibri" pitchFamily="34" charset="-122"/>
+                <a:cs typeface="Calibri" pitchFamily="34" charset="-120"/>
+              </a:rPr>
+              <a:t>CI verte</a:t>
+            </a:r>
+            <a:endParaRPr lang="en-US" sz="950" dirty="0"/>
+          </a:p>
+        </p:txBody>
+      </p:sp>
+      <p:sp>
+        <p:nvSpPr>
+          <p:cNvPr id="24" name="Text 22"/>
+          <p:cNvSpPr/>
+          <p:nvPr/>
+        </p:nvSpPr>
+        <p:spPr>
+          <a:xfrm>
+            <a:off x="8321040" y="4736592"/>
+            <a:ext cx="548640" cy="274320"/>
+          </a:xfrm>
+          <a:prstGeom prst="rect">
+            <a:avLst/>
+          </a:prstGeom>
+          <a:noFill/>
+          <a:ln/>
+        </p:spPr>
+        <p:txBody>
+          <a:bodyPr wrap="square" lIns="0" tIns="0" rIns="0" bIns="0" rtlCol="0" anchor="ctr"/>
+          <a:lstStyle/>
+          <a:p>
+            <a:pPr marL="0" indent="0" algn="r">
+              <a:buNone/>
+            </a:pPr>
+            <a:r>
+              <a:rPr lang="en-US" sz="1000" dirty="0">
+                <a:solidFill>
+                  <a:srgbClr val="76A5AF"/>
+                </a:solidFill>
+                <a:latin typeface="Calibri" pitchFamily="34" charset="0"/>
+                <a:ea typeface="Calibri" pitchFamily="34" charset="-122"/>
+                <a:cs typeface="Calibri" pitchFamily="34" charset="-120"/>
+              </a:rPr>
+              <a:t>12b</a:t>
+            </a:r>
+            <a:endParaRPr lang="en-US" sz="1000" dirty="0"/>
+          </a:p>
+        </p:txBody>
+      </p:sp>
+      <p:sp>
+        <p:nvSpPr>
+          <p:cNvPr id="25" name="Text 23"/>
+          <p:cNvSpPr/>
+          <p:nvPr/>
+        </p:nvSpPr>
+        <p:spPr>
+          <a:xfrm>
+            <a:off x="548640" y="4736592"/>
+            <a:ext cx="2743200" cy="274320"/>
+          </a:xfrm>
+          <a:prstGeom prst="rect">
+            <a:avLst/>
+          </a:prstGeom>
+          <a:noFill/>
+          <a:ln/>
+        </p:spPr>
+        <p:txBody>
+          <a:bodyPr wrap="square" lIns="0" tIns="0" rIns="0" bIns="0" rtlCol="0" anchor="ctr"/>
+          <a:lstStyle/>
+          <a:p>
+            <a:pPr marL="0" indent="0">
+              <a:buNone/>
+            </a:pPr>
+            <a:r>
+              <a:rPr lang="en-US" sz="1000" dirty="0">
+                <a:solidFill>
+                  <a:srgbClr val="76A5AF"/>
+                </a:solidFill>
+                <a:latin typeface="Calibri" pitchFamily="34" charset="0"/>
+                <a:ea typeface="Calibri" pitchFamily="34" charset="-122"/>
+                <a:cs typeface="Calibri" pitchFamily="34" charset="-120"/>
+              </a:rPr>
+              <a:t>Thumalien</a:t>
+            </a:r>
+            <a:endParaRPr lang="en-US" sz="1000" dirty="0"/>
+          </a:p>
+        </p:txBody>
+      </p:sp>
+    </p:spTree>
+  </p:cSld>
+  <p:clrMapOvr>
+    <a:masterClrMapping/>
+  </p:clrMapOvr>
+</p:sld>
+</file>
+
+<file path=ppt/slides/slide15.xml><?xml version="1.0" encoding="utf-8"?>
 <p:sld xmlns:a="http://schemas.openxmlformats.org/drawingml/2006/main" xmlns:r="http://schemas.openxmlformats.org/officeDocument/2006/relationships" xmlns:p="http://schemas.openxmlformats.org/presentationml/2006/main">
   <p:cSld name="Slide 13">
     <p:bg>
@@ -7094,7 +8023,7 @@
 </p:sld>
 </file>
 
-<file path=ppt/slides/slide15.xml><?xml version="1.0" encoding="utf-8"?>
+<file path=ppt/slides/slide16.xml><?xml version="1.0" encoding="utf-8"?>
 <p:sld xmlns:a="http://schemas.openxmlformats.org/drawingml/2006/main" xmlns:r="http://schemas.openxmlformats.org/officeDocument/2006/relationships" xmlns:p="http://schemas.openxmlformats.org/presentationml/2006/main">
   <p:cSld name="Slide 9">
     <p:bg>
@@ -8030,7 +8959,7 @@
 </p:sld>
 </file>
 
-<file path=ppt/slides/slide16.xml><?xml version="1.0" encoding="utf-8"?>
+<file path=ppt/slides/slide17.xml><?xml version="1.0" encoding="utf-8"?>
 <p:sld xmlns:a="http://schemas.openxmlformats.org/drawingml/2006/main" xmlns:r="http://schemas.openxmlformats.org/officeDocument/2006/relationships" xmlns:p="http://schemas.openxmlformats.org/presentationml/2006/main">
   <p:cSld name="Slide 14">
     <p:bg>
@@ -8622,7 +9551,7 @@
                 <a:ea typeface="Calibri" pitchFamily="34" charset="-122"/>
                 <a:cs typeface="Calibri" pitchFamily="34" charset="-120"/>
               </a:rPr>
-              <a:t>Tests unitaires &amp; d'intégration, observabilité, documentation et vidéo de démonstration.</a:t>
+              <a:t>CI/CD operationnel : 25 tests pytest + lint ruff (GitHub Actions). Prochaines etapes : observabilite avancee, documentation et video de demonstration.</a:t>
             </a:r>
             <a:endParaRPr lang="en-US" sz="1020" dirty="0"/>
           </a:p>
@@ -8879,7 +9808,7 @@
 </p:sld>
 </file>
 
-<file path=ppt/slides/slide17.xml><?xml version="1.0" encoding="utf-8"?>
+<file path=ppt/slides/slide18.xml><?xml version="1.0" encoding="utf-8"?>
 <p:sld xmlns:a="http://schemas.openxmlformats.org/drawingml/2006/main" xmlns:r="http://schemas.openxmlformats.org/officeDocument/2006/relationships" xmlns:p="http://schemas.openxmlformats.org/presentationml/2006/main">
   <p:cSld name="Slide 15">
     <p:bg>
@@ -12661,7 +13590,7 @@
                 <a:ea typeface="Calibri" pitchFamily="34" charset="-122"/>
                 <a:cs typeface="Calibri" pitchFamily="34" charset="-120"/>
               </a:rPr>
-              <a:t>NLP cleaning</a:t>
+              <a:t>Kedro NLP (7 nodes)</a:t>
             </a:r>
             <a:endParaRPr lang="en-US" sz="800" dirty="0"/>
           </a:p>
@@ -13848,7 +14777,7 @@
                 <a:ea typeface="Calibri" pitchFamily="34" charset="-122"/>
                 <a:cs typeface="Calibri" pitchFamily="34" charset="-120"/>
               </a:rPr>
-              <a:t>Groq · Llama 3.1</a:t>
+              <a:t>GitHub Actions CI/CD</a:t>
             </a:r>
             <a:endParaRPr lang="en-US" sz="1050" dirty="0"/>
           </a:p>
@@ -13916,7 +14845,7 @@
                 <a:ea typeface="Calibri" pitchFamily="34" charset="-122"/>
                 <a:cs typeface="Calibri" pitchFamily="34" charset="-120"/>
               </a:rPr>
-              <a:t>Airflow</a:t>
+              <a:t>Kedro 1.2 + Airflow</a:t>
             </a:r>
             <a:endParaRPr lang="en-US" sz="1050" dirty="0"/>
           </a:p>
@@ -16943,7 +17872,7 @@
                 <a:ea typeface="Calibri" pitchFamily="34" charset="-122"/>
                 <a:cs typeface="Calibri" pitchFamily="34" charset="-120"/>
               </a:rPr>
-              <a:t>7</a:t>
+              <a:t>8</a:t>
             </a:r>
             <a:endParaRPr lang="en-US" sz="1300" dirty="0"/>
           </a:p>
@@ -18031,7 +18960,7 @@
                 <a:ea typeface="Calibri" pitchFamily="34" charset="-122"/>
                 <a:cs typeface="Calibri" pitchFamily="34" charset="-120"/>
               </a:rPr>
-              <a:t>4</a:t>
+              <a:t>3</a:t>
             </a:r>
             <a:endParaRPr lang="en-US" sz="1300" dirty="0"/>
           </a:p>
@@ -18133,7 +19062,7 @@
                 <a:ea typeface="Calibri" pitchFamily="34" charset="-122"/>
                 <a:cs typeface="Calibri" pitchFamily="34" charset="-120"/>
               </a:rPr>
-              <a:t>P8 · Tests unitaires &amp; intégration</a:t>
+              <a:t>Documentation &amp; guide</a:t>
             </a:r>
             <a:endParaRPr lang="en-US" sz="950" dirty="0"/>
           </a:p>
@@ -18235,7 +19164,7 @@
                 <a:ea typeface="Calibri" pitchFamily="34" charset="-122"/>
                 <a:cs typeface="Calibri" pitchFamily="34" charset="-120"/>
               </a:rPr>
-              <a:t>Documentation &amp; guide</a:t>
+              <a:t>Video de demonstration</a:t>
             </a:r>
             <a:endParaRPr lang="en-US" sz="950" dirty="0"/>
           </a:p>
@@ -18337,7 +19266,7 @@
                 <a:ea typeface="Calibri" pitchFamily="34" charset="-122"/>
                 <a:cs typeface="Calibri" pitchFamily="34" charset="-120"/>
               </a:rPr>
-              <a:t>Vidéo de démonstration</a:t>
+              <a:t>Rapport final</a:t>
             </a:r>
             <a:endParaRPr lang="en-US" sz="950" dirty="0"/>
           </a:p>
@@ -18439,7 +19368,7 @@
                 <a:ea typeface="Calibri" pitchFamily="34" charset="-122"/>
                 <a:cs typeface="Calibri" pitchFamily="34" charset="-120"/>
               </a:rPr>
-              <a:t>Rapport final</a:t>
+              <a:t/>
             </a:r>
             <a:endParaRPr lang="en-US" sz="950" dirty="0"/>
           </a:p>
@@ -18808,7 +19737,7 @@
                 <a:ea typeface="Calibri" pitchFamily="34" charset="-122"/>
                 <a:cs typeface="Calibri" pitchFamily="34" charset="-120"/>
               </a:rPr>
-              <a:t>API officielle searchPosts par mots-clés FR/EN (fake news, hoax, désinformation…). Pagination, retries, stockage brut dans MongoDB posts_raw avec identifiant unique.</a:t>
+              <a:t>Bluesky Jetstream (WebSocket temps reel) : flux de TOUS les posts publics, sans filtre de mots-cles. ~45 posts/sec, 100 000 posts en ~40 min. Stockage brut dans MongoDB posts_raw (upsert sur URI unique).</a:t>
             </a:r>
             <a:endParaRPr lang="en-US" sz="1000" dirty="0"/>
           </a:p>
@@ -18949,7 +19878,7 @@
                 <a:ea typeface="Calibri" pitchFamily="34" charset="-122"/>
                 <a:cs typeface="Calibri" pitchFamily="34" charset="-120"/>
               </a:rPr>
-              <a:t>Nettoyage NLP</a:t>
+              <a:t>Pipeline NLP (Kedro 1.2)</a:t>
             </a:r>
             <a:endParaRPr lang="en-US" sz="1450" dirty="0"/>
           </a:p>
@@ -18988,7 +19917,7 @@
                 <a:ea typeface="Calibri" pitchFamily="34" charset="-122"/>
                 <a:cs typeface="Calibri" pitchFamily="34" charset="-120"/>
               </a:rPr>
-              <a:t>Suppression URLs, mentions, hashtags et emojis ; accents conservés pour le français ; enrichissement métadonnées (langue, longueur, tokens). Sortie posts_clean.</a:t>
+              <a:t>Pipeline Kedro 1.2 en 7 nodes : extract -&gt; clean (URLs/mentions/hashtags) -&gt; detect_lang (langdetect) -&gt; normalize -&gt; tokenize (NLTK) -&gt; lemmatize (WordNet) -&gt; load. Datasets intermediaires en Parquet. Sortie : MongoDB posts_clean_kedro.</a:t>
             </a:r>
             <a:endParaRPr lang="en-US" sz="1000" dirty="0"/>
           </a:p>
@@ -19102,7 +20031,7 @@
                 <a:ea typeface="Calibri" pitchFamily="34" charset="-122"/>
                 <a:cs typeface="Calibri" pitchFamily="34" charset="-120"/>
               </a:rPr>
-              <a:t>22 408</a:t>
+              <a:t>100 000</a:t>
             </a:r>
             <a:endParaRPr lang="en-US" sz="2200" dirty="0"/>
           </a:p>
@@ -19141,7 +20070,7 @@
                 <a:ea typeface="Calibri" pitchFamily="34" charset="-122"/>
                 <a:cs typeface="Calibri" pitchFamily="34" charset="-120"/>
               </a:rPr>
-              <a:t>posts collectés</a:t>
+              <a:t>posts collectes</a:t>
             </a:r>
             <a:endParaRPr lang="en-US" sz="950" dirty="0"/>
           </a:p>
@@ -19180,7 +20109,7 @@
                 <a:ea typeface="Calibri" pitchFamily="34" charset="-122"/>
                 <a:cs typeface="Calibri" pitchFamily="34" charset="-120"/>
               </a:rPr>
-              <a:t>22 408</a:t>
+              <a:t>100 000</a:t>
             </a:r>
             <a:endParaRPr lang="en-US" sz="2200" dirty="0"/>
           </a:p>
@@ -19219,7 +20148,7 @@
                 <a:ea typeface="Calibri" pitchFamily="34" charset="-122"/>
                 <a:cs typeface="Calibri" pitchFamily="34" charset="-120"/>
               </a:rPr>
-              <a:t>uniques (dédupliqués)</a:t>
+              <a:t>flux Jetstream</a:t>
             </a:r>
             <a:endParaRPr lang="en-US" sz="950" dirty="0"/>
           </a:p>
@@ -19258,7 +20187,7 @@
                 <a:ea typeface="Calibri" pitchFamily="34" charset="-122"/>
                 <a:cs typeface="Calibri" pitchFamily="34" charset="-120"/>
               </a:rPr>
-              <a:t>22 184</a:t>
+              <a:t>~57 000</a:t>
             </a:r>
             <a:endParaRPr lang="en-US" sz="2200" dirty="0"/>
           </a:p>
@@ -19297,7 +20226,7 @@
                 <a:ea typeface="Calibri" pitchFamily="34" charset="-122"/>
                 <a:cs typeface="Calibri" pitchFamily="34" charset="-120"/>
               </a:rPr>
-              <a:t>posts nettoyés</a:t>
+              <a:t>en anglais (langdetect)</a:t>
             </a:r>
             <a:endParaRPr lang="en-US" sz="950" dirty="0"/>
           </a:p>
@@ -19336,7 +20265,7 @@
                 <a:ea typeface="Calibri" pitchFamily="34" charset="-122"/>
                 <a:cs typeface="Calibri" pitchFamily="34" charset="-120"/>
               </a:rPr>
-              <a:t>224</a:t>
+              <a:t>~43 000</a:t>
             </a:r>
             <a:endParaRPr lang="en-US" sz="2200" dirty="0"/>
           </a:p>
@@ -19375,7 +20304,7 @@
                 <a:ea typeface="Calibri" pitchFamily="34" charset="-122"/>
                 <a:cs typeface="Calibri" pitchFamily="34" charset="-120"/>
               </a:rPr>
-              <a:t>écartés (trop courts)</a:t>
+              <a:t>filtres (langue/vide)</a:t>
             </a:r>
             <a:endParaRPr lang="en-US" sz="950" dirty="0"/>
           </a:p>

</xml_diff>

<commit_message>
Presentation : corrections chiffres + accessibilite non-expert
- Slide 9 : volumetrie corrigee avec donnees reelles (102 680 raw,
  11 281 en anglais (11%), 91 399 filtres) ; descriptions sans jargon
- Slide 10 : "Claim Detection" -> "filtre d affirmations verifiables"
- Slide 11 : F1-score explique (precision du modele), description
  simplifiee (plus de noms de librairies bruts)
- Slide 12 : champs MongoDB retires, formulation lisible
- Slide 14 : Kedro explique par sa valeur (pas juste les etapes),
  Airflow/CI en langage commun ("planificateur automatique")
- Slide 15 : clarification "base initiale (22 408 posts)"
- Slide 17 : "CI/CD" reformule en "tests automatiques"

Co-Authored-By: Claude Sonnet 4.6 <noreply@anthropic.com>
</commit_message>
<xml_diff>
--- a/Thumalien_Soutenance_GreenIT.pptx
+++ b/Thumalien_Soutenance_GreenIT.pptx
@@ -2842,7 +2842,7 @@
                 <a:ea typeface="Calibri" pitchFamily="34" charset="-122"/>
                 <a:cs typeface="Calibri" pitchFamily="34" charset="-120"/>
               </a:rPr>
-              <a:t>Filtre d'affirmations factuelles (Claim Detection)</a:t>
+              <a:t>Filtre : ce post contient-il une affirmation verifiable ?</a:t>
             </a:r>
             <a:endParaRPr lang="en-US" sz="2700" dirty="0"/>
           </a:p>
@@ -3163,7 +3163,7 @@
                 <a:ea typeface="Calibri" pitchFamily="34" charset="-122"/>
                 <a:cs typeface="Calibri" pitchFamily="34" charset="-120"/>
               </a:rPr>
-              <a:t>Solution : Claim Detection</a:t>
+              <a:t>Solution : filtre d affirmations</a:t>
             </a:r>
             <a:endParaRPr lang="en-US" sz="1450" dirty="0"/>
           </a:p>
@@ -3202,7 +3202,7 @@
                 <a:ea typeface="Calibri" pitchFamily="34" charset="-122"/>
                 <a:cs typeface="Calibri" pitchFamily="34" charset="-120"/>
               </a:rPr>
-              <a:t>Classifier en amont : « ce post contient-il une affirmation factuelle vérifiable ? »  OUI → pipeline fake news  |  NON → post personnel ignoré.</a:t>
+              <a:t>On classe en amont : « ce post affirme-t-il un fait verifiable ? »  OUI -&gt; analyse fake news  |  NON -&gt; post personnel ignore (ex : « je suis fatigue »).</a:t>
             </a:r>
             <a:endParaRPr lang="en-US" sz="1000" dirty="0"/>
           </a:p>
@@ -3817,7 +3817,7 @@
                 <a:ea typeface="Calibri" pitchFamily="34" charset="-122"/>
                 <a:cs typeface="Calibri" pitchFamily="34" charset="-120"/>
               </a:rPr>
-              <a:t>Modèle baseline : </a:t>
+              <a:t>Modele baseline : analyse statistique des mots + classification probabiliste</a:t>
             </a:r>
             <a:r>
               <a:rPr lang="en-US" sz="1400" b="1" dirty="0">
@@ -3828,7 +3828,7 @@
                 <a:ea typeface="Calibri" pitchFamily="34" charset="-122"/>
                 <a:cs typeface="Calibri" pitchFamily="34" charset="-120"/>
               </a:rPr>
-              <a:t>TF-IDF + Régression Logistique</a:t>
+              <a:t/>
             </a:r>
             <a:endParaRPr lang="en-US" sz="1400" dirty="0"/>
           </a:p>
@@ -3871,70 +3871,10 @@
                 <a:ea typeface="Calibri" pitchFamily="34" charset="-122"/>
                 <a:cs typeface="Calibri" pitchFamily="34" charset="-120"/>
               </a:rPr>
-              <a:t>Entraîné sur GonzaloA/fake_news (HuggingFace, ~40 000 articles labellisés)</a:t>
-            </a:r>
-            <a:endParaRPr lang="en-US" sz="1150" dirty="0"/>
-          </a:p>
-          <a:p>
-            <a:pPr marL="342900" indent="-342900">
-              <a:spcAft>
-                <a:spcPts val="800"/>
-              </a:spcAft>
-              <a:buSzPct val="100000"/>
-              <a:buChar char="•"/>
-            </a:pPr>
-            <a:r>
-              <a:rPr lang="en-US" sz="1150" dirty="0">
-                <a:solidFill>
-                  <a:srgbClr val="134F5C"/>
-                </a:solidFill>
-                <a:latin typeface="Calibri" pitchFamily="34" charset="0"/>
-                <a:ea typeface="Calibri" pitchFamily="34" charset="-122"/>
-                <a:cs typeface="Calibri" pitchFamily="34" charset="-120"/>
-              </a:rPr>
-              <a:t>Split train / validation / test ; métriques F1, précision, rappel</a:t>
-            </a:r>
-            <a:endParaRPr lang="en-US" sz="1150" dirty="0"/>
-          </a:p>
-          <a:p>
-            <a:pPr marL="342900" indent="-342900">
-              <a:spcAft>
-                <a:spcPts val="800"/>
-              </a:spcAft>
-              <a:buSzPct val="100000"/>
-              <a:buChar char="•"/>
-            </a:pPr>
-            <a:r>
-              <a:rPr lang="en-US" sz="1150" dirty="0">
-                <a:solidFill>
-                  <a:srgbClr val="134F5C"/>
-                </a:solidFill>
-                <a:latin typeface="Calibri" pitchFamily="34" charset="0"/>
-                <a:ea typeface="Calibri" pitchFamily="34" charset="-122"/>
-                <a:cs typeface="Calibri" pitchFamily="34" charset="-120"/>
-              </a:rPr>
-              <a:t>Modèle sauvegardé puis appliqué (scoring) sur les posts collectés</a:t>
-            </a:r>
-            <a:endParaRPr lang="en-US" sz="1150" dirty="0"/>
-          </a:p>
-          <a:p>
-            <a:pPr marL="342900" indent="-342900">
-              <a:spcAft>
-                <a:spcPts val="800"/>
-              </a:spcAft>
-              <a:buSzPct val="100000"/>
-              <a:buChar char="•"/>
-            </a:pPr>
-            <a:r>
-              <a:rPr lang="en-US" sz="1150" dirty="0">
-                <a:solidFill>
-                  <a:srgbClr val="134F5C"/>
-                </a:solidFill>
-                <a:latin typeface="Calibri" pitchFamily="34" charset="0"/>
-                <a:ea typeface="Calibri" pitchFamily="34" charset="-122"/>
-                <a:cs typeface="Calibri" pitchFamily="34" charset="-120"/>
-              </a:rPr>
-              <a:t>Sortie : credibility_score · predicted_label · alert_level</a:t>
+              <a:t>Entraine sur 40 000 articles (HuggingFace) : vrais articles journalistiques vs faux
+Split train/validation/test ; precision et rappel mesures separement
+Modele sauvegarde puis applique sur les posts Bluesky
+Sortie : score de credibilite, etiquette fake/real, niveau d alerte</a:t>
             </a:r>
             <a:endParaRPr lang="en-US" sz="1150" dirty="0"/>
           </a:p>
@@ -4002,7 +3942,7 @@
                 <a:ea typeface="Calibri" pitchFamily="34" charset="-122"/>
                 <a:cs typeface="Calibri" pitchFamily="34" charset="-120"/>
               </a:rPr>
-              <a:t>97,7 %</a:t>
+              <a:t>97,7 %   de precision du modele sur les donnees de test</a:t>
             </a:r>
             <a:r>
               <a:rPr lang="en-US" sz="1200" dirty="0">
@@ -4013,7 +3953,7 @@
                 <a:ea typeface="Calibri" pitchFamily="34" charset="-122"/>
                 <a:cs typeface="Calibri" pitchFamily="34" charset="-120"/>
               </a:rPr>
-              <a:t>   F1-score (weighted) sur le jeu de test</a:t>
+              <a:t/>
             </a:r>
             <a:endParaRPr lang="en-US" sz="2600" dirty="0"/>
           </a:p>
@@ -4803,7 +4743,7 @@
                 <a:ea typeface="Calibri" pitchFamily="34" charset="-122"/>
                 <a:cs typeface="Calibri" pitchFamily="34" charset="-120"/>
               </a:rPr>
-              <a:t>→  final_credibility_score · final_alert_level</a:t>
+              <a:t>Score final de credibilite (0-100) et niveau d alerte</a:t>
             </a:r>
             <a:endParaRPr lang="en-US" sz="950" dirty="0"/>
           </a:p>
@@ -6246,7 +6186,7 @@
                 <a:ea typeface="Calibri" pitchFamily="34" charset="-122"/>
                 <a:cs typeface="Calibri" pitchFamily="34" charset="-120"/>
               </a:rPr>
-              <a:t>7 nodes chaines (fonctions pures testees) : extract -&gt; clean -&gt; detect_lang -&gt; normalize -&gt; tokenize -&gt; lemmatize -&gt; load. Datasets intermediaires en Parquet. Langue detectee sur le contenu reel via langdetect (pas le tag declare par l utilisateur). Visualisation : kedro viz run.</a:t>
+              <a:t>Chaque etape est une fonction independante, testee et reexecutable. En cas d erreur, on peut rejouer uniquement l etape defaillante. Les resultats intermediaires sont sauvegardes : pas de perte de donnees. Visualisation graphique du pipeline avec kedro viz.</a:t>
             </a:r>
             <a:endParaRPr lang="en-US" sz="1000" dirty="0"/>
           </a:p>
@@ -6426,7 +6366,7 @@
                 <a:ea typeface="Calibri" pitchFamily="34" charset="-122"/>
                 <a:cs typeface="Calibri" pitchFamily="34" charset="-120"/>
               </a:rPr>
-              <a:t>DAG bluesky_pipeline : collecte -&gt; pipeline Kedro NLP, declenchement quotidien a 00h00. CI/CD GitHub Actions sur push (main/dev) : 25 tests unitaires pytest (nodes 2-6) + lint ruff. Pipeline vert en continu.</a:t>
+              <a:t>Airflow : planificateur automatique qui collecte et nettoie les posts chaque nuit a minuit, sans intervention manuelle. GitHub Actions : a chaque modification du code, 25 tests automatiques verifient que rien n est casse.</a:t>
             </a:r>
             <a:endParaRPr lang="en-US" sz="1000" dirty="0"/>
           </a:p>
@@ -6735,7 +6675,7 @@
                 <a:ea typeface="Calibri" pitchFamily="34" charset="-122"/>
                 <a:cs typeface="Calibri" pitchFamily="34" charset="-120"/>
               </a:rPr>
-              <a:t>DAG Airflow</a:t>
+              <a:t>execution automatique nocturne</a:t>
             </a:r>
             <a:endParaRPr lang="en-US" sz="950" dirty="0"/>
           </a:p>
@@ -7029,7 +6969,7 @@
                 <a:ea typeface="Calibri" pitchFamily="34" charset="-122"/>
                 <a:cs typeface="Calibri" pitchFamily="34" charset="-120"/>
               </a:rPr>
-              <a:t>Indicateurs obtenus sur données réelles</a:t>
+              <a:t>Indicateurs sur la base initiale (22 408 posts) - base de reference</a:t>
             </a:r>
             <a:endParaRPr lang="en-US" sz="2700" dirty="0"/>
           </a:p>
@@ -7136,7 +7076,7 @@
                 <a:ea typeface="Calibri" pitchFamily="34" charset="-122"/>
                 <a:cs typeface="Calibri" pitchFamily="34" charset="-120"/>
               </a:rPr>
-              <a:t>posts collectés</a:t>
+              <a:t>posts de la base initiale</a:t>
             </a:r>
             <a:endParaRPr lang="en-US" sz="1050" dirty="0"/>
           </a:p>
@@ -7243,7 +7183,7 @@
                 <a:ea typeface="Calibri" pitchFamily="34" charset="-122"/>
                 <a:cs typeface="Calibri" pitchFamily="34" charset="-120"/>
               </a:rPr>
-              <a:t>F1-score du modèle</a:t>
+              <a:t>precision du modele (F1-score)</a:t>
             </a:r>
             <a:endParaRPr lang="en-US" sz="1050" dirty="0"/>
           </a:p>
@@ -9551,7 +9491,7 @@
                 <a:ea typeface="Calibri" pitchFamily="34" charset="-122"/>
                 <a:cs typeface="Calibri" pitchFamily="34" charset="-120"/>
               </a:rPr>
-              <a:t>CI/CD operationnel : 25 tests pytest + lint ruff (GitHub Actions). Prochaines etapes : observabilite avancee, documentation et video de demonstration.</a:t>
+              <a:t>Tests automatiques en place (25 tests, GitHub Actions). Prochaines etapes : outils de monitoring des erreurs, documentation utilisateur et video de demonstration.</a:t>
             </a:r>
             <a:endParaRPr lang="en-US" sz="1020" dirty="0"/>
           </a:p>
@@ -19737,7 +19677,7 @@
                 <a:ea typeface="Calibri" pitchFamily="34" charset="-122"/>
                 <a:cs typeface="Calibri" pitchFamily="34" charset="-120"/>
               </a:rPr>
-              <a:t>Bluesky Jetstream (WebSocket temps reel) : flux de TOUS les posts publics, sans filtre de mots-cles. ~45 posts/sec, 100 000 posts en ~40 min. Stockage brut dans MongoDB posts_raw (upsert sur URI unique).</a:t>
+              <a:t>Bluesky Jetstream : flux en temps reel de TOUS les posts publics (pas de filtre par mot-cle). 102 680 posts aspires en ~40 min et stockes dans MongoDB.</a:t>
             </a:r>
             <a:endParaRPr lang="en-US" sz="1000" dirty="0"/>
           </a:p>
@@ -19878,7 +19818,7 @@
                 <a:ea typeface="Calibri" pitchFamily="34" charset="-122"/>
                 <a:cs typeface="Calibri" pitchFamily="34" charset="-120"/>
               </a:rPr>
-              <a:t>Pipeline NLP (Kedro 1.2)</a:t>
+              <a:t>Nettoyage NLP (pipeline Kedro)</a:t>
             </a:r>
             <a:endParaRPr lang="en-US" sz="1450" dirty="0"/>
           </a:p>
@@ -19917,7 +19857,7 @@
                 <a:ea typeface="Calibri" pitchFamily="34" charset="-122"/>
                 <a:cs typeface="Calibri" pitchFamily="34" charset="-120"/>
               </a:rPr>
-              <a:t>Pipeline Kedro 1.2 en 7 nodes : extract -&gt; clean (URLs/mentions/hashtags) -&gt; detect_lang (langdetect) -&gt; normalize -&gt; tokenize (NLTK) -&gt; lemmatize (WordNet) -&gt; load. Datasets intermediaires en Parquet. Sortie : MongoDB posts_clean_kedro.</a:t>
+              <a:t>7 etapes automatisees : suppression liens/mentions/hashtags, detection de la langue reelle du texte (et non le tag declare), normalisation, decoupage en mots, reduction a la racine. Seuls les posts en anglais sont conserves. Sortie : MongoDB.</a:t>
             </a:r>
             <a:endParaRPr lang="en-US" sz="1000" dirty="0"/>
           </a:p>
@@ -20031,7 +19971,7 @@
                 <a:ea typeface="Calibri" pitchFamily="34" charset="-122"/>
                 <a:cs typeface="Calibri" pitchFamily="34" charset="-120"/>
               </a:rPr>
-              <a:t>100 000</a:t>
+              <a:t>102 680</a:t>
             </a:r>
             <a:endParaRPr lang="en-US" sz="2200" dirty="0"/>
           </a:p>
@@ -20109,7 +20049,7 @@
                 <a:ea typeface="Calibri" pitchFamily="34" charset="-122"/>
                 <a:cs typeface="Calibri" pitchFamily="34" charset="-120"/>
               </a:rPr>
-              <a:t>100 000</a:t>
+              <a:t>102 680</a:t>
             </a:r>
             <a:endParaRPr lang="en-US" sz="2200" dirty="0"/>
           </a:p>
@@ -20148,7 +20088,7 @@
                 <a:ea typeface="Calibri" pitchFamily="34" charset="-122"/>
                 <a:cs typeface="Calibri" pitchFamily="34" charset="-120"/>
               </a:rPr>
-              <a:t>flux Jetstream</a:t>
+              <a:t>flux temps reel</a:t>
             </a:r>
             <a:endParaRPr lang="en-US" sz="950" dirty="0"/>
           </a:p>
@@ -20187,7 +20127,7 @@
                 <a:ea typeface="Calibri" pitchFamily="34" charset="-122"/>
                 <a:cs typeface="Calibri" pitchFamily="34" charset="-120"/>
               </a:rPr>
-              <a:t>~57 000</a:t>
+              <a:t>11 281</a:t>
             </a:r>
             <a:endParaRPr lang="en-US" sz="2200" dirty="0"/>
           </a:p>
@@ -20226,7 +20166,7 @@
                 <a:ea typeface="Calibri" pitchFamily="34" charset="-122"/>
                 <a:cs typeface="Calibri" pitchFamily="34" charset="-120"/>
               </a:rPr>
-              <a:t>en anglais (langdetect)</a:t>
+              <a:t>posts en anglais (11 %)</a:t>
             </a:r>
             <a:endParaRPr lang="en-US" sz="950" dirty="0"/>
           </a:p>
@@ -20265,7 +20205,7 @@
                 <a:ea typeface="Calibri" pitchFamily="34" charset="-122"/>
                 <a:cs typeface="Calibri" pitchFamily="34" charset="-120"/>
               </a:rPr>
-              <a:t>~43 000</a:t>
+              <a:t>91 399</a:t>
             </a:r>
             <a:endParaRPr lang="en-US" sz="2200" dirty="0"/>
           </a:p>
@@ -20304,7 +20244,7 @@
                 <a:ea typeface="Calibri" pitchFamily="34" charset="-122"/>
                 <a:cs typeface="Calibri" pitchFamily="34" charset="-120"/>
               </a:rPr>
-              <a:t>filtres (langue/vide)</a:t>
+              <a:t>filtres (autre langue / vide)</a:t>
             </a:r>
             <a:endParaRPr lang="en-US" sz="950" dirty="0"/>
           </a:p>

</xml_diff>

<commit_message>
Presentation : ajout barre de navigation de section
Barre de 0.33 pouces en haut de chaque slide (sauf titre, plan, closing).
6 sections affichees en permanence :
01 Contexte | 02 Architecture | 03 Suivi | 04 Travaux | 05 Resultats | 06 Perspectives
Section active : bleu marine (#1E408A) texte blanc gras.
Sections inactives : bleu-gris clair (#D8E4F4) texte fonce (#3A5278).

Co-Authored-By: Claude Sonnet 4.6 <noreply@anthropic.com>
</commit_message>
<xml_diff>
--- a/Thumalien_Soutenance_GreenIT.pptx
+++ b/Thumalien_Soutenance_GreenIT.pptx
@@ -3673,6 +3673,312 @@
           </a:p>
         </p:txBody>
       </p:sp>
+      <p:sp>
+        <p:nvSpPr>
+          <p:cNvPr id="26" name="Rectangle 25"/>
+          <p:cNvSpPr/>
+          <p:nvPr/>
+        </p:nvSpPr>
+        <p:spPr>
+          <a:xfrm>
+            <a:off x="0" y="0"/>
+            <a:ext cx="1524000" cy="301752"/>
+          </a:xfrm>
+          <a:prstGeom prst="rect">
+            <a:avLst/>
+          </a:prstGeom>
+          <a:solidFill>
+            <a:srgbClr val="D8E4F4"/>
+          </a:solidFill>
+          <a:ln>
+            <a:noFill/>
+          </a:ln>
+        </p:spPr>
+        <p:style>
+          <a:lnRef idx="1">
+            <a:schemeClr val="accent1"/>
+          </a:lnRef>
+          <a:fillRef idx="3">
+            <a:schemeClr val="accent1"/>
+          </a:fillRef>
+          <a:effectRef idx="2">
+            <a:schemeClr val="accent1"/>
+          </a:effectRef>
+          <a:fontRef idx="minor">
+            <a:schemeClr val="lt1"/>
+          </a:fontRef>
+        </p:style>
+        <p:txBody>
+          <a:bodyPr rtlCol="0" anchor="ctr" wrap="none"/>
+          <a:lstStyle/>
+          <a:p>
+            <a:pPr algn="ctr"/>
+            <a:r>
+              <a:rPr sz="650" b="0">
+                <a:solidFill>
+                  <a:srgbClr val="3A5278"/>
+                </a:solidFill>
+              </a:rPr>
+              <a:t>01 · Contexte</a:t>
+            </a:r>
+          </a:p>
+        </p:txBody>
+      </p:sp>
+      <p:sp>
+        <p:nvSpPr>
+          <p:cNvPr id="27" name="Rectangle 26"/>
+          <p:cNvSpPr/>
+          <p:nvPr/>
+        </p:nvSpPr>
+        <p:spPr>
+          <a:xfrm>
+            <a:off x="1524000" y="0"/>
+            <a:ext cx="1524000" cy="301752"/>
+          </a:xfrm>
+          <a:prstGeom prst="rect">
+            <a:avLst/>
+          </a:prstGeom>
+          <a:solidFill>
+            <a:srgbClr val="D8E4F4"/>
+          </a:solidFill>
+          <a:ln>
+            <a:noFill/>
+          </a:ln>
+        </p:spPr>
+        <p:style>
+          <a:lnRef idx="1">
+            <a:schemeClr val="accent1"/>
+          </a:lnRef>
+          <a:fillRef idx="3">
+            <a:schemeClr val="accent1"/>
+          </a:fillRef>
+          <a:effectRef idx="2">
+            <a:schemeClr val="accent1"/>
+          </a:effectRef>
+          <a:fontRef idx="minor">
+            <a:schemeClr val="lt1"/>
+          </a:fontRef>
+        </p:style>
+        <p:txBody>
+          <a:bodyPr rtlCol="0" anchor="ctr" wrap="none"/>
+          <a:lstStyle/>
+          <a:p>
+            <a:pPr algn="ctr"/>
+            <a:r>
+              <a:rPr sz="650" b="0">
+                <a:solidFill>
+                  <a:srgbClr val="3A5278"/>
+                </a:solidFill>
+              </a:rPr>
+              <a:t>02 · Architecture</a:t>
+            </a:r>
+          </a:p>
+        </p:txBody>
+      </p:sp>
+      <p:sp>
+        <p:nvSpPr>
+          <p:cNvPr id="28" name="Rectangle 27"/>
+          <p:cNvSpPr/>
+          <p:nvPr/>
+        </p:nvSpPr>
+        <p:spPr>
+          <a:xfrm>
+            <a:off x="3048000" y="0"/>
+            <a:ext cx="1524000" cy="301752"/>
+          </a:xfrm>
+          <a:prstGeom prst="rect">
+            <a:avLst/>
+          </a:prstGeom>
+          <a:solidFill>
+            <a:srgbClr val="D8E4F4"/>
+          </a:solidFill>
+          <a:ln>
+            <a:noFill/>
+          </a:ln>
+        </p:spPr>
+        <p:style>
+          <a:lnRef idx="1">
+            <a:schemeClr val="accent1"/>
+          </a:lnRef>
+          <a:fillRef idx="3">
+            <a:schemeClr val="accent1"/>
+          </a:fillRef>
+          <a:effectRef idx="2">
+            <a:schemeClr val="accent1"/>
+          </a:effectRef>
+          <a:fontRef idx="minor">
+            <a:schemeClr val="lt1"/>
+          </a:fontRef>
+        </p:style>
+        <p:txBody>
+          <a:bodyPr rtlCol="0" anchor="ctr" wrap="none"/>
+          <a:lstStyle/>
+          <a:p>
+            <a:pPr algn="ctr"/>
+            <a:r>
+              <a:rPr sz="650" b="0">
+                <a:solidFill>
+                  <a:srgbClr val="3A5278"/>
+                </a:solidFill>
+              </a:rPr>
+              <a:t>03 · Suivi</a:t>
+            </a:r>
+          </a:p>
+        </p:txBody>
+      </p:sp>
+      <p:sp>
+        <p:nvSpPr>
+          <p:cNvPr id="29" name="Rectangle 28"/>
+          <p:cNvSpPr/>
+          <p:nvPr/>
+        </p:nvSpPr>
+        <p:spPr>
+          <a:xfrm>
+            <a:off x="4572000" y="0"/>
+            <a:ext cx="1524000" cy="301752"/>
+          </a:xfrm>
+          <a:prstGeom prst="rect">
+            <a:avLst/>
+          </a:prstGeom>
+          <a:solidFill>
+            <a:srgbClr val="1E408A"/>
+          </a:solidFill>
+          <a:ln>
+            <a:noFill/>
+          </a:ln>
+        </p:spPr>
+        <p:style>
+          <a:lnRef idx="1">
+            <a:schemeClr val="accent1"/>
+          </a:lnRef>
+          <a:fillRef idx="3">
+            <a:schemeClr val="accent1"/>
+          </a:fillRef>
+          <a:effectRef idx="2">
+            <a:schemeClr val="accent1"/>
+          </a:effectRef>
+          <a:fontRef idx="minor">
+            <a:schemeClr val="lt1"/>
+          </a:fontRef>
+        </p:style>
+        <p:txBody>
+          <a:bodyPr rtlCol="0" anchor="ctr" wrap="none"/>
+          <a:lstStyle/>
+          <a:p>
+            <a:pPr algn="ctr"/>
+            <a:r>
+              <a:rPr sz="650" b="1">
+                <a:solidFill>
+                  <a:srgbClr val="FFFFFF"/>
+                </a:solidFill>
+              </a:rPr>
+              <a:t>04 · Travaux</a:t>
+            </a:r>
+          </a:p>
+        </p:txBody>
+      </p:sp>
+      <p:sp>
+        <p:nvSpPr>
+          <p:cNvPr id="30" name="Rectangle 29"/>
+          <p:cNvSpPr/>
+          <p:nvPr/>
+        </p:nvSpPr>
+        <p:spPr>
+          <a:xfrm>
+            <a:off x="6096000" y="0"/>
+            <a:ext cx="1524000" cy="301752"/>
+          </a:xfrm>
+          <a:prstGeom prst="rect">
+            <a:avLst/>
+          </a:prstGeom>
+          <a:solidFill>
+            <a:srgbClr val="D8E4F4"/>
+          </a:solidFill>
+          <a:ln>
+            <a:noFill/>
+          </a:ln>
+        </p:spPr>
+        <p:style>
+          <a:lnRef idx="1">
+            <a:schemeClr val="accent1"/>
+          </a:lnRef>
+          <a:fillRef idx="3">
+            <a:schemeClr val="accent1"/>
+          </a:fillRef>
+          <a:effectRef idx="2">
+            <a:schemeClr val="accent1"/>
+          </a:effectRef>
+          <a:fontRef idx="minor">
+            <a:schemeClr val="lt1"/>
+          </a:fontRef>
+        </p:style>
+        <p:txBody>
+          <a:bodyPr rtlCol="0" anchor="ctr" wrap="none"/>
+          <a:lstStyle/>
+          <a:p>
+            <a:pPr algn="ctr"/>
+            <a:r>
+              <a:rPr sz="650" b="0">
+                <a:solidFill>
+                  <a:srgbClr val="3A5278"/>
+                </a:solidFill>
+              </a:rPr>
+              <a:t>05 · Resultats</a:t>
+            </a:r>
+          </a:p>
+        </p:txBody>
+      </p:sp>
+      <p:sp>
+        <p:nvSpPr>
+          <p:cNvPr id="31" name="Rectangle 30"/>
+          <p:cNvSpPr/>
+          <p:nvPr/>
+        </p:nvSpPr>
+        <p:spPr>
+          <a:xfrm>
+            <a:off x="7620000" y="0"/>
+            <a:ext cx="1524000" cy="301752"/>
+          </a:xfrm>
+          <a:prstGeom prst="rect">
+            <a:avLst/>
+          </a:prstGeom>
+          <a:solidFill>
+            <a:srgbClr val="D8E4F4"/>
+          </a:solidFill>
+          <a:ln>
+            <a:noFill/>
+          </a:ln>
+        </p:spPr>
+        <p:style>
+          <a:lnRef idx="1">
+            <a:schemeClr val="accent1"/>
+          </a:lnRef>
+          <a:fillRef idx="3">
+            <a:schemeClr val="accent1"/>
+          </a:fillRef>
+          <a:effectRef idx="2">
+            <a:schemeClr val="accent1"/>
+          </a:effectRef>
+          <a:fontRef idx="minor">
+            <a:schemeClr val="lt1"/>
+          </a:fontRef>
+        </p:style>
+        <p:txBody>
+          <a:bodyPr rtlCol="0" anchor="ctr" wrap="none"/>
+          <a:lstStyle/>
+          <a:p>
+            <a:pPr algn="ctr"/>
+            <a:r>
+              <a:rPr sz="650" b="0">
+                <a:solidFill>
+                  <a:srgbClr val="3A5278"/>
+                </a:solidFill>
+              </a:rPr>
+              <a:t>06 · Perspectives</a:t>
+            </a:r>
+          </a:p>
+        </p:txBody>
+      </p:sp>
     </p:spTree>
   </p:cSld>
   <p:clrMapOvr>
@@ -4092,6 +4398,312 @@
           </a:p>
         </p:txBody>
       </p:sp>
+      <p:sp>
+        <p:nvSpPr>
+          <p:cNvPr id="12" name="Rectangle 11"/>
+          <p:cNvSpPr/>
+          <p:nvPr/>
+        </p:nvSpPr>
+        <p:spPr>
+          <a:xfrm>
+            <a:off x="0" y="0"/>
+            <a:ext cx="1524000" cy="301752"/>
+          </a:xfrm>
+          <a:prstGeom prst="rect">
+            <a:avLst/>
+          </a:prstGeom>
+          <a:solidFill>
+            <a:srgbClr val="D8E4F4"/>
+          </a:solidFill>
+          <a:ln>
+            <a:noFill/>
+          </a:ln>
+        </p:spPr>
+        <p:style>
+          <a:lnRef idx="1">
+            <a:schemeClr val="accent1"/>
+          </a:lnRef>
+          <a:fillRef idx="3">
+            <a:schemeClr val="accent1"/>
+          </a:fillRef>
+          <a:effectRef idx="2">
+            <a:schemeClr val="accent1"/>
+          </a:effectRef>
+          <a:fontRef idx="minor">
+            <a:schemeClr val="lt1"/>
+          </a:fontRef>
+        </p:style>
+        <p:txBody>
+          <a:bodyPr rtlCol="0" anchor="ctr" wrap="none"/>
+          <a:lstStyle/>
+          <a:p>
+            <a:pPr algn="ctr"/>
+            <a:r>
+              <a:rPr sz="650" b="0">
+                <a:solidFill>
+                  <a:srgbClr val="3A5278"/>
+                </a:solidFill>
+              </a:rPr>
+              <a:t>01 · Contexte</a:t>
+            </a:r>
+          </a:p>
+        </p:txBody>
+      </p:sp>
+      <p:sp>
+        <p:nvSpPr>
+          <p:cNvPr id="13" name="Rectangle 12"/>
+          <p:cNvSpPr/>
+          <p:nvPr/>
+        </p:nvSpPr>
+        <p:spPr>
+          <a:xfrm>
+            <a:off x="1524000" y="0"/>
+            <a:ext cx="1524000" cy="301752"/>
+          </a:xfrm>
+          <a:prstGeom prst="rect">
+            <a:avLst/>
+          </a:prstGeom>
+          <a:solidFill>
+            <a:srgbClr val="D8E4F4"/>
+          </a:solidFill>
+          <a:ln>
+            <a:noFill/>
+          </a:ln>
+        </p:spPr>
+        <p:style>
+          <a:lnRef idx="1">
+            <a:schemeClr val="accent1"/>
+          </a:lnRef>
+          <a:fillRef idx="3">
+            <a:schemeClr val="accent1"/>
+          </a:fillRef>
+          <a:effectRef idx="2">
+            <a:schemeClr val="accent1"/>
+          </a:effectRef>
+          <a:fontRef idx="minor">
+            <a:schemeClr val="lt1"/>
+          </a:fontRef>
+        </p:style>
+        <p:txBody>
+          <a:bodyPr rtlCol="0" anchor="ctr" wrap="none"/>
+          <a:lstStyle/>
+          <a:p>
+            <a:pPr algn="ctr"/>
+            <a:r>
+              <a:rPr sz="650" b="0">
+                <a:solidFill>
+                  <a:srgbClr val="3A5278"/>
+                </a:solidFill>
+              </a:rPr>
+              <a:t>02 · Architecture</a:t>
+            </a:r>
+          </a:p>
+        </p:txBody>
+      </p:sp>
+      <p:sp>
+        <p:nvSpPr>
+          <p:cNvPr id="14" name="Rectangle 13"/>
+          <p:cNvSpPr/>
+          <p:nvPr/>
+        </p:nvSpPr>
+        <p:spPr>
+          <a:xfrm>
+            <a:off x="3048000" y="0"/>
+            <a:ext cx="1524000" cy="301752"/>
+          </a:xfrm>
+          <a:prstGeom prst="rect">
+            <a:avLst/>
+          </a:prstGeom>
+          <a:solidFill>
+            <a:srgbClr val="D8E4F4"/>
+          </a:solidFill>
+          <a:ln>
+            <a:noFill/>
+          </a:ln>
+        </p:spPr>
+        <p:style>
+          <a:lnRef idx="1">
+            <a:schemeClr val="accent1"/>
+          </a:lnRef>
+          <a:fillRef idx="3">
+            <a:schemeClr val="accent1"/>
+          </a:fillRef>
+          <a:effectRef idx="2">
+            <a:schemeClr val="accent1"/>
+          </a:effectRef>
+          <a:fontRef idx="minor">
+            <a:schemeClr val="lt1"/>
+          </a:fontRef>
+        </p:style>
+        <p:txBody>
+          <a:bodyPr rtlCol="0" anchor="ctr" wrap="none"/>
+          <a:lstStyle/>
+          <a:p>
+            <a:pPr algn="ctr"/>
+            <a:r>
+              <a:rPr sz="650" b="0">
+                <a:solidFill>
+                  <a:srgbClr val="3A5278"/>
+                </a:solidFill>
+              </a:rPr>
+              <a:t>03 · Suivi</a:t>
+            </a:r>
+          </a:p>
+        </p:txBody>
+      </p:sp>
+      <p:sp>
+        <p:nvSpPr>
+          <p:cNvPr id="15" name="Rectangle 14"/>
+          <p:cNvSpPr/>
+          <p:nvPr/>
+        </p:nvSpPr>
+        <p:spPr>
+          <a:xfrm>
+            <a:off x="4572000" y="0"/>
+            <a:ext cx="1524000" cy="301752"/>
+          </a:xfrm>
+          <a:prstGeom prst="rect">
+            <a:avLst/>
+          </a:prstGeom>
+          <a:solidFill>
+            <a:srgbClr val="1E408A"/>
+          </a:solidFill>
+          <a:ln>
+            <a:noFill/>
+          </a:ln>
+        </p:spPr>
+        <p:style>
+          <a:lnRef idx="1">
+            <a:schemeClr val="accent1"/>
+          </a:lnRef>
+          <a:fillRef idx="3">
+            <a:schemeClr val="accent1"/>
+          </a:fillRef>
+          <a:effectRef idx="2">
+            <a:schemeClr val="accent1"/>
+          </a:effectRef>
+          <a:fontRef idx="minor">
+            <a:schemeClr val="lt1"/>
+          </a:fontRef>
+        </p:style>
+        <p:txBody>
+          <a:bodyPr rtlCol="0" anchor="ctr" wrap="none"/>
+          <a:lstStyle/>
+          <a:p>
+            <a:pPr algn="ctr"/>
+            <a:r>
+              <a:rPr sz="650" b="1">
+                <a:solidFill>
+                  <a:srgbClr val="FFFFFF"/>
+                </a:solidFill>
+              </a:rPr>
+              <a:t>04 · Travaux</a:t>
+            </a:r>
+          </a:p>
+        </p:txBody>
+      </p:sp>
+      <p:sp>
+        <p:nvSpPr>
+          <p:cNvPr id="16" name="Rectangle 15"/>
+          <p:cNvSpPr/>
+          <p:nvPr/>
+        </p:nvSpPr>
+        <p:spPr>
+          <a:xfrm>
+            <a:off x="6096000" y="0"/>
+            <a:ext cx="1524000" cy="301752"/>
+          </a:xfrm>
+          <a:prstGeom prst="rect">
+            <a:avLst/>
+          </a:prstGeom>
+          <a:solidFill>
+            <a:srgbClr val="D8E4F4"/>
+          </a:solidFill>
+          <a:ln>
+            <a:noFill/>
+          </a:ln>
+        </p:spPr>
+        <p:style>
+          <a:lnRef idx="1">
+            <a:schemeClr val="accent1"/>
+          </a:lnRef>
+          <a:fillRef idx="3">
+            <a:schemeClr val="accent1"/>
+          </a:fillRef>
+          <a:effectRef idx="2">
+            <a:schemeClr val="accent1"/>
+          </a:effectRef>
+          <a:fontRef idx="minor">
+            <a:schemeClr val="lt1"/>
+          </a:fontRef>
+        </p:style>
+        <p:txBody>
+          <a:bodyPr rtlCol="0" anchor="ctr" wrap="none"/>
+          <a:lstStyle/>
+          <a:p>
+            <a:pPr algn="ctr"/>
+            <a:r>
+              <a:rPr sz="650" b="0">
+                <a:solidFill>
+                  <a:srgbClr val="3A5278"/>
+                </a:solidFill>
+              </a:rPr>
+              <a:t>05 · Resultats</a:t>
+            </a:r>
+          </a:p>
+        </p:txBody>
+      </p:sp>
+      <p:sp>
+        <p:nvSpPr>
+          <p:cNvPr id="17" name="Rectangle 16"/>
+          <p:cNvSpPr/>
+          <p:nvPr/>
+        </p:nvSpPr>
+        <p:spPr>
+          <a:xfrm>
+            <a:off x="7620000" y="0"/>
+            <a:ext cx="1524000" cy="301752"/>
+          </a:xfrm>
+          <a:prstGeom prst="rect">
+            <a:avLst/>
+          </a:prstGeom>
+          <a:solidFill>
+            <a:srgbClr val="D8E4F4"/>
+          </a:solidFill>
+          <a:ln>
+            <a:noFill/>
+          </a:ln>
+        </p:spPr>
+        <p:style>
+          <a:lnRef idx="1">
+            <a:schemeClr val="accent1"/>
+          </a:lnRef>
+          <a:fillRef idx="3">
+            <a:schemeClr val="accent1"/>
+          </a:fillRef>
+          <a:effectRef idx="2">
+            <a:schemeClr val="accent1"/>
+          </a:effectRef>
+          <a:fontRef idx="minor">
+            <a:schemeClr val="lt1"/>
+          </a:fontRef>
+        </p:style>
+        <p:txBody>
+          <a:bodyPr rtlCol="0" anchor="ctr" wrap="none"/>
+          <a:lstStyle/>
+          <a:p>
+            <a:pPr algn="ctr"/>
+            <a:r>
+              <a:rPr sz="650" b="0">
+                <a:solidFill>
+                  <a:srgbClr val="3A5278"/>
+                </a:solidFill>
+              </a:rPr>
+              <a:t>06 · Perspectives</a:t>
+            </a:r>
+          </a:p>
+        </p:txBody>
+      </p:sp>
     </p:spTree>
   </p:cSld>
   <p:clrMapOvr>
@@ -4827,6 +5439,312 @@
           </a:p>
         </p:txBody>
       </p:sp>
+      <p:sp>
+        <p:nvSpPr>
+          <p:cNvPr id="21" name="Rectangle 20"/>
+          <p:cNvSpPr/>
+          <p:nvPr/>
+        </p:nvSpPr>
+        <p:spPr>
+          <a:xfrm>
+            <a:off x="0" y="0"/>
+            <a:ext cx="1524000" cy="301752"/>
+          </a:xfrm>
+          <a:prstGeom prst="rect">
+            <a:avLst/>
+          </a:prstGeom>
+          <a:solidFill>
+            <a:srgbClr val="D8E4F4"/>
+          </a:solidFill>
+          <a:ln>
+            <a:noFill/>
+          </a:ln>
+        </p:spPr>
+        <p:style>
+          <a:lnRef idx="1">
+            <a:schemeClr val="accent1"/>
+          </a:lnRef>
+          <a:fillRef idx="3">
+            <a:schemeClr val="accent1"/>
+          </a:fillRef>
+          <a:effectRef idx="2">
+            <a:schemeClr val="accent1"/>
+          </a:effectRef>
+          <a:fontRef idx="minor">
+            <a:schemeClr val="lt1"/>
+          </a:fontRef>
+        </p:style>
+        <p:txBody>
+          <a:bodyPr rtlCol="0" anchor="ctr" wrap="none"/>
+          <a:lstStyle/>
+          <a:p>
+            <a:pPr algn="ctr"/>
+            <a:r>
+              <a:rPr sz="650" b="0">
+                <a:solidFill>
+                  <a:srgbClr val="3A5278"/>
+                </a:solidFill>
+              </a:rPr>
+              <a:t>01 · Contexte</a:t>
+            </a:r>
+          </a:p>
+        </p:txBody>
+      </p:sp>
+      <p:sp>
+        <p:nvSpPr>
+          <p:cNvPr id="22" name="Rectangle 21"/>
+          <p:cNvSpPr/>
+          <p:nvPr/>
+        </p:nvSpPr>
+        <p:spPr>
+          <a:xfrm>
+            <a:off x="1524000" y="0"/>
+            <a:ext cx="1524000" cy="301752"/>
+          </a:xfrm>
+          <a:prstGeom prst="rect">
+            <a:avLst/>
+          </a:prstGeom>
+          <a:solidFill>
+            <a:srgbClr val="D8E4F4"/>
+          </a:solidFill>
+          <a:ln>
+            <a:noFill/>
+          </a:ln>
+        </p:spPr>
+        <p:style>
+          <a:lnRef idx="1">
+            <a:schemeClr val="accent1"/>
+          </a:lnRef>
+          <a:fillRef idx="3">
+            <a:schemeClr val="accent1"/>
+          </a:fillRef>
+          <a:effectRef idx="2">
+            <a:schemeClr val="accent1"/>
+          </a:effectRef>
+          <a:fontRef idx="minor">
+            <a:schemeClr val="lt1"/>
+          </a:fontRef>
+        </p:style>
+        <p:txBody>
+          <a:bodyPr rtlCol="0" anchor="ctr" wrap="none"/>
+          <a:lstStyle/>
+          <a:p>
+            <a:pPr algn="ctr"/>
+            <a:r>
+              <a:rPr sz="650" b="0">
+                <a:solidFill>
+                  <a:srgbClr val="3A5278"/>
+                </a:solidFill>
+              </a:rPr>
+              <a:t>02 · Architecture</a:t>
+            </a:r>
+          </a:p>
+        </p:txBody>
+      </p:sp>
+      <p:sp>
+        <p:nvSpPr>
+          <p:cNvPr id="23" name="Rectangle 22"/>
+          <p:cNvSpPr/>
+          <p:nvPr/>
+        </p:nvSpPr>
+        <p:spPr>
+          <a:xfrm>
+            <a:off x="3048000" y="0"/>
+            <a:ext cx="1524000" cy="301752"/>
+          </a:xfrm>
+          <a:prstGeom prst="rect">
+            <a:avLst/>
+          </a:prstGeom>
+          <a:solidFill>
+            <a:srgbClr val="D8E4F4"/>
+          </a:solidFill>
+          <a:ln>
+            <a:noFill/>
+          </a:ln>
+        </p:spPr>
+        <p:style>
+          <a:lnRef idx="1">
+            <a:schemeClr val="accent1"/>
+          </a:lnRef>
+          <a:fillRef idx="3">
+            <a:schemeClr val="accent1"/>
+          </a:fillRef>
+          <a:effectRef idx="2">
+            <a:schemeClr val="accent1"/>
+          </a:effectRef>
+          <a:fontRef idx="minor">
+            <a:schemeClr val="lt1"/>
+          </a:fontRef>
+        </p:style>
+        <p:txBody>
+          <a:bodyPr rtlCol="0" anchor="ctr" wrap="none"/>
+          <a:lstStyle/>
+          <a:p>
+            <a:pPr algn="ctr"/>
+            <a:r>
+              <a:rPr sz="650" b="0">
+                <a:solidFill>
+                  <a:srgbClr val="3A5278"/>
+                </a:solidFill>
+              </a:rPr>
+              <a:t>03 · Suivi</a:t>
+            </a:r>
+          </a:p>
+        </p:txBody>
+      </p:sp>
+      <p:sp>
+        <p:nvSpPr>
+          <p:cNvPr id="24" name="Rectangle 23"/>
+          <p:cNvSpPr/>
+          <p:nvPr/>
+        </p:nvSpPr>
+        <p:spPr>
+          <a:xfrm>
+            <a:off x="4572000" y="0"/>
+            <a:ext cx="1524000" cy="301752"/>
+          </a:xfrm>
+          <a:prstGeom prst="rect">
+            <a:avLst/>
+          </a:prstGeom>
+          <a:solidFill>
+            <a:srgbClr val="1E408A"/>
+          </a:solidFill>
+          <a:ln>
+            <a:noFill/>
+          </a:ln>
+        </p:spPr>
+        <p:style>
+          <a:lnRef idx="1">
+            <a:schemeClr val="accent1"/>
+          </a:lnRef>
+          <a:fillRef idx="3">
+            <a:schemeClr val="accent1"/>
+          </a:fillRef>
+          <a:effectRef idx="2">
+            <a:schemeClr val="accent1"/>
+          </a:effectRef>
+          <a:fontRef idx="minor">
+            <a:schemeClr val="lt1"/>
+          </a:fontRef>
+        </p:style>
+        <p:txBody>
+          <a:bodyPr rtlCol="0" anchor="ctr" wrap="none"/>
+          <a:lstStyle/>
+          <a:p>
+            <a:pPr algn="ctr"/>
+            <a:r>
+              <a:rPr sz="650" b="1">
+                <a:solidFill>
+                  <a:srgbClr val="FFFFFF"/>
+                </a:solidFill>
+              </a:rPr>
+              <a:t>04 · Travaux</a:t>
+            </a:r>
+          </a:p>
+        </p:txBody>
+      </p:sp>
+      <p:sp>
+        <p:nvSpPr>
+          <p:cNvPr id="25" name="Rectangle 24"/>
+          <p:cNvSpPr/>
+          <p:nvPr/>
+        </p:nvSpPr>
+        <p:spPr>
+          <a:xfrm>
+            <a:off x="6096000" y="0"/>
+            <a:ext cx="1524000" cy="301752"/>
+          </a:xfrm>
+          <a:prstGeom prst="rect">
+            <a:avLst/>
+          </a:prstGeom>
+          <a:solidFill>
+            <a:srgbClr val="D8E4F4"/>
+          </a:solidFill>
+          <a:ln>
+            <a:noFill/>
+          </a:ln>
+        </p:spPr>
+        <p:style>
+          <a:lnRef idx="1">
+            <a:schemeClr val="accent1"/>
+          </a:lnRef>
+          <a:fillRef idx="3">
+            <a:schemeClr val="accent1"/>
+          </a:fillRef>
+          <a:effectRef idx="2">
+            <a:schemeClr val="accent1"/>
+          </a:effectRef>
+          <a:fontRef idx="minor">
+            <a:schemeClr val="lt1"/>
+          </a:fontRef>
+        </p:style>
+        <p:txBody>
+          <a:bodyPr rtlCol="0" anchor="ctr" wrap="none"/>
+          <a:lstStyle/>
+          <a:p>
+            <a:pPr algn="ctr"/>
+            <a:r>
+              <a:rPr sz="650" b="0">
+                <a:solidFill>
+                  <a:srgbClr val="3A5278"/>
+                </a:solidFill>
+              </a:rPr>
+              <a:t>05 · Resultats</a:t>
+            </a:r>
+          </a:p>
+        </p:txBody>
+      </p:sp>
+      <p:sp>
+        <p:nvSpPr>
+          <p:cNvPr id="26" name="Rectangle 25"/>
+          <p:cNvSpPr/>
+          <p:nvPr/>
+        </p:nvSpPr>
+        <p:spPr>
+          <a:xfrm>
+            <a:off x="7620000" y="0"/>
+            <a:ext cx="1524000" cy="301752"/>
+          </a:xfrm>
+          <a:prstGeom prst="rect">
+            <a:avLst/>
+          </a:prstGeom>
+          <a:solidFill>
+            <a:srgbClr val="D8E4F4"/>
+          </a:solidFill>
+          <a:ln>
+            <a:noFill/>
+          </a:ln>
+        </p:spPr>
+        <p:style>
+          <a:lnRef idx="1">
+            <a:schemeClr val="accent1"/>
+          </a:lnRef>
+          <a:fillRef idx="3">
+            <a:schemeClr val="accent1"/>
+          </a:fillRef>
+          <a:effectRef idx="2">
+            <a:schemeClr val="accent1"/>
+          </a:effectRef>
+          <a:fontRef idx="minor">
+            <a:schemeClr val="lt1"/>
+          </a:fontRef>
+        </p:style>
+        <p:txBody>
+          <a:bodyPr rtlCol="0" anchor="ctr" wrap="none"/>
+          <a:lstStyle/>
+          <a:p>
+            <a:pPr algn="ctr"/>
+            <a:r>
+              <a:rPr sz="650" b="0">
+                <a:solidFill>
+                  <a:srgbClr val="3A5278"/>
+                </a:solidFill>
+              </a:rPr>
+              <a:t>06 · Perspectives</a:t>
+            </a:r>
+          </a:p>
+        </p:txBody>
+      </p:sp>
     </p:spTree>
   </p:cSld>
   <p:clrMapOvr>
@@ -5909,6 +6827,312 @@
           </a:p>
         </p:txBody>
       </p:sp>
+      <p:sp>
+        <p:nvSpPr>
+          <p:cNvPr id="33" name="Rectangle 32"/>
+          <p:cNvSpPr/>
+          <p:nvPr/>
+        </p:nvSpPr>
+        <p:spPr>
+          <a:xfrm>
+            <a:off x="0" y="0"/>
+            <a:ext cx="1524000" cy="301752"/>
+          </a:xfrm>
+          <a:prstGeom prst="rect">
+            <a:avLst/>
+          </a:prstGeom>
+          <a:solidFill>
+            <a:srgbClr val="D8E4F4"/>
+          </a:solidFill>
+          <a:ln>
+            <a:noFill/>
+          </a:ln>
+        </p:spPr>
+        <p:style>
+          <a:lnRef idx="1">
+            <a:schemeClr val="accent1"/>
+          </a:lnRef>
+          <a:fillRef idx="3">
+            <a:schemeClr val="accent1"/>
+          </a:fillRef>
+          <a:effectRef idx="2">
+            <a:schemeClr val="accent1"/>
+          </a:effectRef>
+          <a:fontRef idx="minor">
+            <a:schemeClr val="lt1"/>
+          </a:fontRef>
+        </p:style>
+        <p:txBody>
+          <a:bodyPr rtlCol="0" anchor="ctr" wrap="none"/>
+          <a:lstStyle/>
+          <a:p>
+            <a:pPr algn="ctr"/>
+            <a:r>
+              <a:rPr sz="650" b="0">
+                <a:solidFill>
+                  <a:srgbClr val="3A5278"/>
+                </a:solidFill>
+              </a:rPr>
+              <a:t>01 · Contexte</a:t>
+            </a:r>
+          </a:p>
+        </p:txBody>
+      </p:sp>
+      <p:sp>
+        <p:nvSpPr>
+          <p:cNvPr id="34" name="Rectangle 33"/>
+          <p:cNvSpPr/>
+          <p:nvPr/>
+        </p:nvSpPr>
+        <p:spPr>
+          <a:xfrm>
+            <a:off x="1524000" y="0"/>
+            <a:ext cx="1524000" cy="301752"/>
+          </a:xfrm>
+          <a:prstGeom prst="rect">
+            <a:avLst/>
+          </a:prstGeom>
+          <a:solidFill>
+            <a:srgbClr val="D8E4F4"/>
+          </a:solidFill>
+          <a:ln>
+            <a:noFill/>
+          </a:ln>
+        </p:spPr>
+        <p:style>
+          <a:lnRef idx="1">
+            <a:schemeClr val="accent1"/>
+          </a:lnRef>
+          <a:fillRef idx="3">
+            <a:schemeClr val="accent1"/>
+          </a:fillRef>
+          <a:effectRef idx="2">
+            <a:schemeClr val="accent1"/>
+          </a:effectRef>
+          <a:fontRef idx="minor">
+            <a:schemeClr val="lt1"/>
+          </a:fontRef>
+        </p:style>
+        <p:txBody>
+          <a:bodyPr rtlCol="0" anchor="ctr" wrap="none"/>
+          <a:lstStyle/>
+          <a:p>
+            <a:pPr algn="ctr"/>
+            <a:r>
+              <a:rPr sz="650" b="0">
+                <a:solidFill>
+                  <a:srgbClr val="3A5278"/>
+                </a:solidFill>
+              </a:rPr>
+              <a:t>02 · Architecture</a:t>
+            </a:r>
+          </a:p>
+        </p:txBody>
+      </p:sp>
+      <p:sp>
+        <p:nvSpPr>
+          <p:cNvPr id="35" name="Rectangle 34"/>
+          <p:cNvSpPr/>
+          <p:nvPr/>
+        </p:nvSpPr>
+        <p:spPr>
+          <a:xfrm>
+            <a:off x="3048000" y="0"/>
+            <a:ext cx="1524000" cy="301752"/>
+          </a:xfrm>
+          <a:prstGeom prst="rect">
+            <a:avLst/>
+          </a:prstGeom>
+          <a:solidFill>
+            <a:srgbClr val="D8E4F4"/>
+          </a:solidFill>
+          <a:ln>
+            <a:noFill/>
+          </a:ln>
+        </p:spPr>
+        <p:style>
+          <a:lnRef idx="1">
+            <a:schemeClr val="accent1"/>
+          </a:lnRef>
+          <a:fillRef idx="3">
+            <a:schemeClr val="accent1"/>
+          </a:fillRef>
+          <a:effectRef idx="2">
+            <a:schemeClr val="accent1"/>
+          </a:effectRef>
+          <a:fontRef idx="minor">
+            <a:schemeClr val="lt1"/>
+          </a:fontRef>
+        </p:style>
+        <p:txBody>
+          <a:bodyPr rtlCol="0" anchor="ctr" wrap="none"/>
+          <a:lstStyle/>
+          <a:p>
+            <a:pPr algn="ctr"/>
+            <a:r>
+              <a:rPr sz="650" b="0">
+                <a:solidFill>
+                  <a:srgbClr val="3A5278"/>
+                </a:solidFill>
+              </a:rPr>
+              <a:t>03 · Suivi</a:t>
+            </a:r>
+          </a:p>
+        </p:txBody>
+      </p:sp>
+      <p:sp>
+        <p:nvSpPr>
+          <p:cNvPr id="36" name="Rectangle 35"/>
+          <p:cNvSpPr/>
+          <p:nvPr/>
+        </p:nvSpPr>
+        <p:spPr>
+          <a:xfrm>
+            <a:off x="4572000" y="0"/>
+            <a:ext cx="1524000" cy="301752"/>
+          </a:xfrm>
+          <a:prstGeom prst="rect">
+            <a:avLst/>
+          </a:prstGeom>
+          <a:solidFill>
+            <a:srgbClr val="1E408A"/>
+          </a:solidFill>
+          <a:ln>
+            <a:noFill/>
+          </a:ln>
+        </p:spPr>
+        <p:style>
+          <a:lnRef idx="1">
+            <a:schemeClr val="accent1"/>
+          </a:lnRef>
+          <a:fillRef idx="3">
+            <a:schemeClr val="accent1"/>
+          </a:fillRef>
+          <a:effectRef idx="2">
+            <a:schemeClr val="accent1"/>
+          </a:effectRef>
+          <a:fontRef idx="minor">
+            <a:schemeClr val="lt1"/>
+          </a:fontRef>
+        </p:style>
+        <p:txBody>
+          <a:bodyPr rtlCol="0" anchor="ctr" wrap="none"/>
+          <a:lstStyle/>
+          <a:p>
+            <a:pPr algn="ctr"/>
+            <a:r>
+              <a:rPr sz="650" b="1">
+                <a:solidFill>
+                  <a:srgbClr val="FFFFFF"/>
+                </a:solidFill>
+              </a:rPr>
+              <a:t>04 · Travaux</a:t>
+            </a:r>
+          </a:p>
+        </p:txBody>
+      </p:sp>
+      <p:sp>
+        <p:nvSpPr>
+          <p:cNvPr id="37" name="Rectangle 36"/>
+          <p:cNvSpPr/>
+          <p:nvPr/>
+        </p:nvSpPr>
+        <p:spPr>
+          <a:xfrm>
+            <a:off x="6096000" y="0"/>
+            <a:ext cx="1524000" cy="301752"/>
+          </a:xfrm>
+          <a:prstGeom prst="rect">
+            <a:avLst/>
+          </a:prstGeom>
+          <a:solidFill>
+            <a:srgbClr val="D8E4F4"/>
+          </a:solidFill>
+          <a:ln>
+            <a:noFill/>
+          </a:ln>
+        </p:spPr>
+        <p:style>
+          <a:lnRef idx="1">
+            <a:schemeClr val="accent1"/>
+          </a:lnRef>
+          <a:fillRef idx="3">
+            <a:schemeClr val="accent1"/>
+          </a:fillRef>
+          <a:effectRef idx="2">
+            <a:schemeClr val="accent1"/>
+          </a:effectRef>
+          <a:fontRef idx="minor">
+            <a:schemeClr val="lt1"/>
+          </a:fontRef>
+        </p:style>
+        <p:txBody>
+          <a:bodyPr rtlCol="0" anchor="ctr" wrap="none"/>
+          <a:lstStyle/>
+          <a:p>
+            <a:pPr algn="ctr"/>
+            <a:r>
+              <a:rPr sz="650" b="0">
+                <a:solidFill>
+                  <a:srgbClr val="3A5278"/>
+                </a:solidFill>
+              </a:rPr>
+              <a:t>05 · Resultats</a:t>
+            </a:r>
+          </a:p>
+        </p:txBody>
+      </p:sp>
+      <p:sp>
+        <p:nvSpPr>
+          <p:cNvPr id="38" name="Rectangle 37"/>
+          <p:cNvSpPr/>
+          <p:nvPr/>
+        </p:nvSpPr>
+        <p:spPr>
+          <a:xfrm>
+            <a:off x="7620000" y="0"/>
+            <a:ext cx="1524000" cy="301752"/>
+          </a:xfrm>
+          <a:prstGeom prst="rect">
+            <a:avLst/>
+          </a:prstGeom>
+          <a:solidFill>
+            <a:srgbClr val="D8E4F4"/>
+          </a:solidFill>
+          <a:ln>
+            <a:noFill/>
+          </a:ln>
+        </p:spPr>
+        <p:style>
+          <a:lnRef idx="1">
+            <a:schemeClr val="accent1"/>
+          </a:lnRef>
+          <a:fillRef idx="3">
+            <a:schemeClr val="accent1"/>
+          </a:fillRef>
+          <a:effectRef idx="2">
+            <a:schemeClr val="accent1"/>
+          </a:effectRef>
+          <a:fontRef idx="minor">
+            <a:schemeClr val="lt1"/>
+          </a:fontRef>
+        </p:style>
+        <p:txBody>
+          <a:bodyPr rtlCol="0" anchor="ctr" wrap="none"/>
+          <a:lstStyle/>
+          <a:p>
+            <a:pPr algn="ctr"/>
+            <a:r>
+              <a:rPr sz="650" b="0">
+                <a:solidFill>
+                  <a:srgbClr val="3A5278"/>
+                </a:solidFill>
+              </a:rPr>
+              <a:t>06 · Perspectives</a:t>
+            </a:r>
+          </a:p>
+        </p:txBody>
+      </p:sp>
     </p:spTree>
   </p:cSld>
   <p:clrMapOvr>
@@ -6834,6 +8058,312 @@
               <a:t>Thumalien</a:t>
             </a:r>
             <a:endParaRPr lang="en-US" sz="1000" dirty="0"/>
+          </a:p>
+        </p:txBody>
+      </p:sp>
+      <p:sp>
+        <p:nvSpPr>
+          <p:cNvPr id="26" name="Rectangle 25"/>
+          <p:cNvSpPr/>
+          <p:nvPr/>
+        </p:nvSpPr>
+        <p:spPr>
+          <a:xfrm>
+            <a:off x="0" y="0"/>
+            <a:ext cx="1524000" cy="301752"/>
+          </a:xfrm>
+          <a:prstGeom prst="rect">
+            <a:avLst/>
+          </a:prstGeom>
+          <a:solidFill>
+            <a:srgbClr val="D8E4F4"/>
+          </a:solidFill>
+          <a:ln>
+            <a:noFill/>
+          </a:ln>
+        </p:spPr>
+        <p:style>
+          <a:lnRef idx="1">
+            <a:schemeClr val="accent1"/>
+          </a:lnRef>
+          <a:fillRef idx="3">
+            <a:schemeClr val="accent1"/>
+          </a:fillRef>
+          <a:effectRef idx="2">
+            <a:schemeClr val="accent1"/>
+          </a:effectRef>
+          <a:fontRef idx="minor">
+            <a:schemeClr val="lt1"/>
+          </a:fontRef>
+        </p:style>
+        <p:txBody>
+          <a:bodyPr rtlCol="0" anchor="ctr" wrap="none"/>
+          <a:lstStyle/>
+          <a:p>
+            <a:pPr algn="ctr"/>
+            <a:r>
+              <a:rPr sz="650" b="0">
+                <a:solidFill>
+                  <a:srgbClr val="3A5278"/>
+                </a:solidFill>
+              </a:rPr>
+              <a:t>01 · Contexte</a:t>
+            </a:r>
+          </a:p>
+        </p:txBody>
+      </p:sp>
+      <p:sp>
+        <p:nvSpPr>
+          <p:cNvPr id="27" name="Rectangle 26"/>
+          <p:cNvSpPr/>
+          <p:nvPr/>
+        </p:nvSpPr>
+        <p:spPr>
+          <a:xfrm>
+            <a:off x="1524000" y="0"/>
+            <a:ext cx="1524000" cy="301752"/>
+          </a:xfrm>
+          <a:prstGeom prst="rect">
+            <a:avLst/>
+          </a:prstGeom>
+          <a:solidFill>
+            <a:srgbClr val="D8E4F4"/>
+          </a:solidFill>
+          <a:ln>
+            <a:noFill/>
+          </a:ln>
+        </p:spPr>
+        <p:style>
+          <a:lnRef idx="1">
+            <a:schemeClr val="accent1"/>
+          </a:lnRef>
+          <a:fillRef idx="3">
+            <a:schemeClr val="accent1"/>
+          </a:fillRef>
+          <a:effectRef idx="2">
+            <a:schemeClr val="accent1"/>
+          </a:effectRef>
+          <a:fontRef idx="minor">
+            <a:schemeClr val="lt1"/>
+          </a:fontRef>
+        </p:style>
+        <p:txBody>
+          <a:bodyPr rtlCol="0" anchor="ctr" wrap="none"/>
+          <a:lstStyle/>
+          <a:p>
+            <a:pPr algn="ctr"/>
+            <a:r>
+              <a:rPr sz="650" b="0">
+                <a:solidFill>
+                  <a:srgbClr val="3A5278"/>
+                </a:solidFill>
+              </a:rPr>
+              <a:t>02 · Architecture</a:t>
+            </a:r>
+          </a:p>
+        </p:txBody>
+      </p:sp>
+      <p:sp>
+        <p:nvSpPr>
+          <p:cNvPr id="28" name="Rectangle 27"/>
+          <p:cNvSpPr/>
+          <p:nvPr/>
+        </p:nvSpPr>
+        <p:spPr>
+          <a:xfrm>
+            <a:off x="3048000" y="0"/>
+            <a:ext cx="1524000" cy="301752"/>
+          </a:xfrm>
+          <a:prstGeom prst="rect">
+            <a:avLst/>
+          </a:prstGeom>
+          <a:solidFill>
+            <a:srgbClr val="D8E4F4"/>
+          </a:solidFill>
+          <a:ln>
+            <a:noFill/>
+          </a:ln>
+        </p:spPr>
+        <p:style>
+          <a:lnRef idx="1">
+            <a:schemeClr val="accent1"/>
+          </a:lnRef>
+          <a:fillRef idx="3">
+            <a:schemeClr val="accent1"/>
+          </a:fillRef>
+          <a:effectRef idx="2">
+            <a:schemeClr val="accent1"/>
+          </a:effectRef>
+          <a:fontRef idx="minor">
+            <a:schemeClr val="lt1"/>
+          </a:fontRef>
+        </p:style>
+        <p:txBody>
+          <a:bodyPr rtlCol="0" anchor="ctr" wrap="none"/>
+          <a:lstStyle/>
+          <a:p>
+            <a:pPr algn="ctr"/>
+            <a:r>
+              <a:rPr sz="650" b="0">
+                <a:solidFill>
+                  <a:srgbClr val="3A5278"/>
+                </a:solidFill>
+              </a:rPr>
+              <a:t>03 · Suivi</a:t>
+            </a:r>
+          </a:p>
+        </p:txBody>
+      </p:sp>
+      <p:sp>
+        <p:nvSpPr>
+          <p:cNvPr id="29" name="Rectangle 28"/>
+          <p:cNvSpPr/>
+          <p:nvPr/>
+        </p:nvSpPr>
+        <p:spPr>
+          <a:xfrm>
+            <a:off x="4572000" y="0"/>
+            <a:ext cx="1524000" cy="301752"/>
+          </a:xfrm>
+          <a:prstGeom prst="rect">
+            <a:avLst/>
+          </a:prstGeom>
+          <a:solidFill>
+            <a:srgbClr val="1E408A"/>
+          </a:solidFill>
+          <a:ln>
+            <a:noFill/>
+          </a:ln>
+        </p:spPr>
+        <p:style>
+          <a:lnRef idx="1">
+            <a:schemeClr val="accent1"/>
+          </a:lnRef>
+          <a:fillRef idx="3">
+            <a:schemeClr val="accent1"/>
+          </a:fillRef>
+          <a:effectRef idx="2">
+            <a:schemeClr val="accent1"/>
+          </a:effectRef>
+          <a:fontRef idx="minor">
+            <a:schemeClr val="lt1"/>
+          </a:fontRef>
+        </p:style>
+        <p:txBody>
+          <a:bodyPr rtlCol="0" anchor="ctr" wrap="none"/>
+          <a:lstStyle/>
+          <a:p>
+            <a:pPr algn="ctr"/>
+            <a:r>
+              <a:rPr sz="650" b="1">
+                <a:solidFill>
+                  <a:srgbClr val="FFFFFF"/>
+                </a:solidFill>
+              </a:rPr>
+              <a:t>04 · Travaux</a:t>
+            </a:r>
+          </a:p>
+        </p:txBody>
+      </p:sp>
+      <p:sp>
+        <p:nvSpPr>
+          <p:cNvPr id="30" name="Rectangle 29"/>
+          <p:cNvSpPr/>
+          <p:nvPr/>
+        </p:nvSpPr>
+        <p:spPr>
+          <a:xfrm>
+            <a:off x="6096000" y="0"/>
+            <a:ext cx="1524000" cy="301752"/>
+          </a:xfrm>
+          <a:prstGeom prst="rect">
+            <a:avLst/>
+          </a:prstGeom>
+          <a:solidFill>
+            <a:srgbClr val="D8E4F4"/>
+          </a:solidFill>
+          <a:ln>
+            <a:noFill/>
+          </a:ln>
+        </p:spPr>
+        <p:style>
+          <a:lnRef idx="1">
+            <a:schemeClr val="accent1"/>
+          </a:lnRef>
+          <a:fillRef idx="3">
+            <a:schemeClr val="accent1"/>
+          </a:fillRef>
+          <a:effectRef idx="2">
+            <a:schemeClr val="accent1"/>
+          </a:effectRef>
+          <a:fontRef idx="minor">
+            <a:schemeClr val="lt1"/>
+          </a:fontRef>
+        </p:style>
+        <p:txBody>
+          <a:bodyPr rtlCol="0" anchor="ctr" wrap="none"/>
+          <a:lstStyle/>
+          <a:p>
+            <a:pPr algn="ctr"/>
+            <a:r>
+              <a:rPr sz="650" b="0">
+                <a:solidFill>
+                  <a:srgbClr val="3A5278"/>
+                </a:solidFill>
+              </a:rPr>
+              <a:t>05 · Resultats</a:t>
+            </a:r>
+          </a:p>
+        </p:txBody>
+      </p:sp>
+      <p:sp>
+        <p:nvSpPr>
+          <p:cNvPr id="31" name="Rectangle 30"/>
+          <p:cNvSpPr/>
+          <p:nvPr/>
+        </p:nvSpPr>
+        <p:spPr>
+          <a:xfrm>
+            <a:off x="7620000" y="0"/>
+            <a:ext cx="1524000" cy="301752"/>
+          </a:xfrm>
+          <a:prstGeom prst="rect">
+            <a:avLst/>
+          </a:prstGeom>
+          <a:solidFill>
+            <a:srgbClr val="D8E4F4"/>
+          </a:solidFill>
+          <a:ln>
+            <a:noFill/>
+          </a:ln>
+        </p:spPr>
+        <p:style>
+          <a:lnRef idx="1">
+            <a:schemeClr val="accent1"/>
+          </a:lnRef>
+          <a:fillRef idx="3">
+            <a:schemeClr val="accent1"/>
+          </a:fillRef>
+          <a:effectRef idx="2">
+            <a:schemeClr val="accent1"/>
+          </a:effectRef>
+          <a:fontRef idx="minor">
+            <a:schemeClr val="lt1"/>
+          </a:fontRef>
+        </p:style>
+        <p:txBody>
+          <a:bodyPr rtlCol="0" anchor="ctr" wrap="none"/>
+          <a:lstStyle/>
+          <a:p>
+            <a:pPr algn="ctr"/>
+            <a:r>
+              <a:rPr sz="650" b="0">
+                <a:solidFill>
+                  <a:srgbClr val="3A5278"/>
+                </a:solidFill>
+              </a:rPr>
+              <a:t>06 · Perspectives</a:t>
+            </a:r>
           </a:p>
         </p:txBody>
       </p:sp>
@@ -7955,6 +9485,312 @@
           </a:p>
         </p:txBody>
       </p:sp>
+      <p:sp>
+        <p:nvSpPr>
+          <p:cNvPr id="33" name="Rectangle 32"/>
+          <p:cNvSpPr/>
+          <p:nvPr/>
+        </p:nvSpPr>
+        <p:spPr>
+          <a:xfrm>
+            <a:off x="0" y="0"/>
+            <a:ext cx="1524000" cy="301752"/>
+          </a:xfrm>
+          <a:prstGeom prst="rect">
+            <a:avLst/>
+          </a:prstGeom>
+          <a:solidFill>
+            <a:srgbClr val="D8E4F4"/>
+          </a:solidFill>
+          <a:ln>
+            <a:noFill/>
+          </a:ln>
+        </p:spPr>
+        <p:style>
+          <a:lnRef idx="1">
+            <a:schemeClr val="accent1"/>
+          </a:lnRef>
+          <a:fillRef idx="3">
+            <a:schemeClr val="accent1"/>
+          </a:fillRef>
+          <a:effectRef idx="2">
+            <a:schemeClr val="accent1"/>
+          </a:effectRef>
+          <a:fontRef idx="minor">
+            <a:schemeClr val="lt1"/>
+          </a:fontRef>
+        </p:style>
+        <p:txBody>
+          <a:bodyPr rtlCol="0" anchor="ctr" wrap="none"/>
+          <a:lstStyle/>
+          <a:p>
+            <a:pPr algn="ctr"/>
+            <a:r>
+              <a:rPr sz="650" b="0">
+                <a:solidFill>
+                  <a:srgbClr val="3A5278"/>
+                </a:solidFill>
+              </a:rPr>
+              <a:t>01 · Contexte</a:t>
+            </a:r>
+          </a:p>
+        </p:txBody>
+      </p:sp>
+      <p:sp>
+        <p:nvSpPr>
+          <p:cNvPr id="34" name="Rectangle 33"/>
+          <p:cNvSpPr/>
+          <p:nvPr/>
+        </p:nvSpPr>
+        <p:spPr>
+          <a:xfrm>
+            <a:off x="1524000" y="0"/>
+            <a:ext cx="1524000" cy="301752"/>
+          </a:xfrm>
+          <a:prstGeom prst="rect">
+            <a:avLst/>
+          </a:prstGeom>
+          <a:solidFill>
+            <a:srgbClr val="D8E4F4"/>
+          </a:solidFill>
+          <a:ln>
+            <a:noFill/>
+          </a:ln>
+        </p:spPr>
+        <p:style>
+          <a:lnRef idx="1">
+            <a:schemeClr val="accent1"/>
+          </a:lnRef>
+          <a:fillRef idx="3">
+            <a:schemeClr val="accent1"/>
+          </a:fillRef>
+          <a:effectRef idx="2">
+            <a:schemeClr val="accent1"/>
+          </a:effectRef>
+          <a:fontRef idx="minor">
+            <a:schemeClr val="lt1"/>
+          </a:fontRef>
+        </p:style>
+        <p:txBody>
+          <a:bodyPr rtlCol="0" anchor="ctr" wrap="none"/>
+          <a:lstStyle/>
+          <a:p>
+            <a:pPr algn="ctr"/>
+            <a:r>
+              <a:rPr sz="650" b="0">
+                <a:solidFill>
+                  <a:srgbClr val="3A5278"/>
+                </a:solidFill>
+              </a:rPr>
+              <a:t>02 · Architecture</a:t>
+            </a:r>
+          </a:p>
+        </p:txBody>
+      </p:sp>
+      <p:sp>
+        <p:nvSpPr>
+          <p:cNvPr id="35" name="Rectangle 34"/>
+          <p:cNvSpPr/>
+          <p:nvPr/>
+        </p:nvSpPr>
+        <p:spPr>
+          <a:xfrm>
+            <a:off x="3048000" y="0"/>
+            <a:ext cx="1524000" cy="301752"/>
+          </a:xfrm>
+          <a:prstGeom prst="rect">
+            <a:avLst/>
+          </a:prstGeom>
+          <a:solidFill>
+            <a:srgbClr val="D8E4F4"/>
+          </a:solidFill>
+          <a:ln>
+            <a:noFill/>
+          </a:ln>
+        </p:spPr>
+        <p:style>
+          <a:lnRef idx="1">
+            <a:schemeClr val="accent1"/>
+          </a:lnRef>
+          <a:fillRef idx="3">
+            <a:schemeClr val="accent1"/>
+          </a:fillRef>
+          <a:effectRef idx="2">
+            <a:schemeClr val="accent1"/>
+          </a:effectRef>
+          <a:fontRef idx="minor">
+            <a:schemeClr val="lt1"/>
+          </a:fontRef>
+        </p:style>
+        <p:txBody>
+          <a:bodyPr rtlCol="0" anchor="ctr" wrap="none"/>
+          <a:lstStyle/>
+          <a:p>
+            <a:pPr algn="ctr"/>
+            <a:r>
+              <a:rPr sz="650" b="0">
+                <a:solidFill>
+                  <a:srgbClr val="3A5278"/>
+                </a:solidFill>
+              </a:rPr>
+              <a:t>03 · Suivi</a:t>
+            </a:r>
+          </a:p>
+        </p:txBody>
+      </p:sp>
+      <p:sp>
+        <p:nvSpPr>
+          <p:cNvPr id="36" name="Rectangle 35"/>
+          <p:cNvSpPr/>
+          <p:nvPr/>
+        </p:nvSpPr>
+        <p:spPr>
+          <a:xfrm>
+            <a:off x="4572000" y="0"/>
+            <a:ext cx="1524000" cy="301752"/>
+          </a:xfrm>
+          <a:prstGeom prst="rect">
+            <a:avLst/>
+          </a:prstGeom>
+          <a:solidFill>
+            <a:srgbClr val="D8E4F4"/>
+          </a:solidFill>
+          <a:ln>
+            <a:noFill/>
+          </a:ln>
+        </p:spPr>
+        <p:style>
+          <a:lnRef idx="1">
+            <a:schemeClr val="accent1"/>
+          </a:lnRef>
+          <a:fillRef idx="3">
+            <a:schemeClr val="accent1"/>
+          </a:fillRef>
+          <a:effectRef idx="2">
+            <a:schemeClr val="accent1"/>
+          </a:effectRef>
+          <a:fontRef idx="minor">
+            <a:schemeClr val="lt1"/>
+          </a:fontRef>
+        </p:style>
+        <p:txBody>
+          <a:bodyPr rtlCol="0" anchor="ctr" wrap="none"/>
+          <a:lstStyle/>
+          <a:p>
+            <a:pPr algn="ctr"/>
+            <a:r>
+              <a:rPr sz="650" b="0">
+                <a:solidFill>
+                  <a:srgbClr val="3A5278"/>
+                </a:solidFill>
+              </a:rPr>
+              <a:t>04 · Travaux</a:t>
+            </a:r>
+          </a:p>
+        </p:txBody>
+      </p:sp>
+      <p:sp>
+        <p:nvSpPr>
+          <p:cNvPr id="37" name="Rectangle 36"/>
+          <p:cNvSpPr/>
+          <p:nvPr/>
+        </p:nvSpPr>
+        <p:spPr>
+          <a:xfrm>
+            <a:off x="6096000" y="0"/>
+            <a:ext cx="1524000" cy="301752"/>
+          </a:xfrm>
+          <a:prstGeom prst="rect">
+            <a:avLst/>
+          </a:prstGeom>
+          <a:solidFill>
+            <a:srgbClr val="1E408A"/>
+          </a:solidFill>
+          <a:ln>
+            <a:noFill/>
+          </a:ln>
+        </p:spPr>
+        <p:style>
+          <a:lnRef idx="1">
+            <a:schemeClr val="accent1"/>
+          </a:lnRef>
+          <a:fillRef idx="3">
+            <a:schemeClr val="accent1"/>
+          </a:fillRef>
+          <a:effectRef idx="2">
+            <a:schemeClr val="accent1"/>
+          </a:effectRef>
+          <a:fontRef idx="minor">
+            <a:schemeClr val="lt1"/>
+          </a:fontRef>
+        </p:style>
+        <p:txBody>
+          <a:bodyPr rtlCol="0" anchor="ctr" wrap="none"/>
+          <a:lstStyle/>
+          <a:p>
+            <a:pPr algn="ctr"/>
+            <a:r>
+              <a:rPr sz="650" b="1">
+                <a:solidFill>
+                  <a:srgbClr val="FFFFFF"/>
+                </a:solidFill>
+              </a:rPr>
+              <a:t>05 · Resultats</a:t>
+            </a:r>
+          </a:p>
+        </p:txBody>
+      </p:sp>
+      <p:sp>
+        <p:nvSpPr>
+          <p:cNvPr id="38" name="Rectangle 37"/>
+          <p:cNvSpPr/>
+          <p:nvPr/>
+        </p:nvSpPr>
+        <p:spPr>
+          <a:xfrm>
+            <a:off x="7620000" y="0"/>
+            <a:ext cx="1524000" cy="301752"/>
+          </a:xfrm>
+          <a:prstGeom prst="rect">
+            <a:avLst/>
+          </a:prstGeom>
+          <a:solidFill>
+            <a:srgbClr val="D8E4F4"/>
+          </a:solidFill>
+          <a:ln>
+            <a:noFill/>
+          </a:ln>
+        </p:spPr>
+        <p:style>
+          <a:lnRef idx="1">
+            <a:schemeClr val="accent1"/>
+          </a:lnRef>
+          <a:fillRef idx="3">
+            <a:schemeClr val="accent1"/>
+          </a:fillRef>
+          <a:effectRef idx="2">
+            <a:schemeClr val="accent1"/>
+          </a:effectRef>
+          <a:fontRef idx="minor">
+            <a:schemeClr val="lt1"/>
+          </a:fontRef>
+        </p:style>
+        <p:txBody>
+          <a:bodyPr rtlCol="0" anchor="ctr" wrap="none"/>
+          <a:lstStyle/>
+          <a:p>
+            <a:pPr algn="ctr"/>
+            <a:r>
+              <a:rPr sz="650" b="0">
+                <a:solidFill>
+                  <a:srgbClr val="3A5278"/>
+                </a:solidFill>
+              </a:rPr>
+              <a:t>06 · Perspectives</a:t>
+            </a:r>
+          </a:p>
+        </p:txBody>
+      </p:sp>
     </p:spTree>
   </p:cSld>
   <p:clrMapOvr>
@@ -8891,6 +10727,312 @@
           </a:p>
         </p:txBody>
       </p:sp>
+      <p:sp>
+        <p:nvSpPr>
+          <p:cNvPr id="26" name="Rectangle 25"/>
+          <p:cNvSpPr/>
+          <p:nvPr/>
+        </p:nvSpPr>
+        <p:spPr>
+          <a:xfrm>
+            <a:off x="0" y="0"/>
+            <a:ext cx="1524000" cy="301752"/>
+          </a:xfrm>
+          <a:prstGeom prst="rect">
+            <a:avLst/>
+          </a:prstGeom>
+          <a:solidFill>
+            <a:srgbClr val="D8E4F4"/>
+          </a:solidFill>
+          <a:ln>
+            <a:noFill/>
+          </a:ln>
+        </p:spPr>
+        <p:style>
+          <a:lnRef idx="1">
+            <a:schemeClr val="accent1"/>
+          </a:lnRef>
+          <a:fillRef idx="3">
+            <a:schemeClr val="accent1"/>
+          </a:fillRef>
+          <a:effectRef idx="2">
+            <a:schemeClr val="accent1"/>
+          </a:effectRef>
+          <a:fontRef idx="minor">
+            <a:schemeClr val="lt1"/>
+          </a:fontRef>
+        </p:style>
+        <p:txBody>
+          <a:bodyPr rtlCol="0" anchor="ctr" wrap="none"/>
+          <a:lstStyle/>
+          <a:p>
+            <a:pPr algn="ctr"/>
+            <a:r>
+              <a:rPr sz="650" b="0">
+                <a:solidFill>
+                  <a:srgbClr val="3A5278"/>
+                </a:solidFill>
+              </a:rPr>
+              <a:t>01 · Contexte</a:t>
+            </a:r>
+          </a:p>
+        </p:txBody>
+      </p:sp>
+      <p:sp>
+        <p:nvSpPr>
+          <p:cNvPr id="27" name="Rectangle 26"/>
+          <p:cNvSpPr/>
+          <p:nvPr/>
+        </p:nvSpPr>
+        <p:spPr>
+          <a:xfrm>
+            <a:off x="1524000" y="0"/>
+            <a:ext cx="1524000" cy="301752"/>
+          </a:xfrm>
+          <a:prstGeom prst="rect">
+            <a:avLst/>
+          </a:prstGeom>
+          <a:solidFill>
+            <a:srgbClr val="D8E4F4"/>
+          </a:solidFill>
+          <a:ln>
+            <a:noFill/>
+          </a:ln>
+        </p:spPr>
+        <p:style>
+          <a:lnRef idx="1">
+            <a:schemeClr val="accent1"/>
+          </a:lnRef>
+          <a:fillRef idx="3">
+            <a:schemeClr val="accent1"/>
+          </a:fillRef>
+          <a:effectRef idx="2">
+            <a:schemeClr val="accent1"/>
+          </a:effectRef>
+          <a:fontRef idx="minor">
+            <a:schemeClr val="lt1"/>
+          </a:fontRef>
+        </p:style>
+        <p:txBody>
+          <a:bodyPr rtlCol="0" anchor="ctr" wrap="none"/>
+          <a:lstStyle/>
+          <a:p>
+            <a:pPr algn="ctr"/>
+            <a:r>
+              <a:rPr sz="650" b="0">
+                <a:solidFill>
+                  <a:srgbClr val="3A5278"/>
+                </a:solidFill>
+              </a:rPr>
+              <a:t>02 · Architecture</a:t>
+            </a:r>
+          </a:p>
+        </p:txBody>
+      </p:sp>
+      <p:sp>
+        <p:nvSpPr>
+          <p:cNvPr id="28" name="Rectangle 27"/>
+          <p:cNvSpPr/>
+          <p:nvPr/>
+        </p:nvSpPr>
+        <p:spPr>
+          <a:xfrm>
+            <a:off x="3048000" y="0"/>
+            <a:ext cx="1524000" cy="301752"/>
+          </a:xfrm>
+          <a:prstGeom prst="rect">
+            <a:avLst/>
+          </a:prstGeom>
+          <a:solidFill>
+            <a:srgbClr val="D8E4F4"/>
+          </a:solidFill>
+          <a:ln>
+            <a:noFill/>
+          </a:ln>
+        </p:spPr>
+        <p:style>
+          <a:lnRef idx="1">
+            <a:schemeClr val="accent1"/>
+          </a:lnRef>
+          <a:fillRef idx="3">
+            <a:schemeClr val="accent1"/>
+          </a:fillRef>
+          <a:effectRef idx="2">
+            <a:schemeClr val="accent1"/>
+          </a:effectRef>
+          <a:fontRef idx="minor">
+            <a:schemeClr val="lt1"/>
+          </a:fontRef>
+        </p:style>
+        <p:txBody>
+          <a:bodyPr rtlCol="0" anchor="ctr" wrap="none"/>
+          <a:lstStyle/>
+          <a:p>
+            <a:pPr algn="ctr"/>
+            <a:r>
+              <a:rPr sz="650" b="0">
+                <a:solidFill>
+                  <a:srgbClr val="3A5278"/>
+                </a:solidFill>
+              </a:rPr>
+              <a:t>03 · Suivi</a:t>
+            </a:r>
+          </a:p>
+        </p:txBody>
+      </p:sp>
+      <p:sp>
+        <p:nvSpPr>
+          <p:cNvPr id="29" name="Rectangle 28"/>
+          <p:cNvSpPr/>
+          <p:nvPr/>
+        </p:nvSpPr>
+        <p:spPr>
+          <a:xfrm>
+            <a:off x="4572000" y="0"/>
+            <a:ext cx="1524000" cy="301752"/>
+          </a:xfrm>
+          <a:prstGeom prst="rect">
+            <a:avLst/>
+          </a:prstGeom>
+          <a:solidFill>
+            <a:srgbClr val="D8E4F4"/>
+          </a:solidFill>
+          <a:ln>
+            <a:noFill/>
+          </a:ln>
+        </p:spPr>
+        <p:style>
+          <a:lnRef idx="1">
+            <a:schemeClr val="accent1"/>
+          </a:lnRef>
+          <a:fillRef idx="3">
+            <a:schemeClr val="accent1"/>
+          </a:fillRef>
+          <a:effectRef idx="2">
+            <a:schemeClr val="accent1"/>
+          </a:effectRef>
+          <a:fontRef idx="minor">
+            <a:schemeClr val="lt1"/>
+          </a:fontRef>
+        </p:style>
+        <p:txBody>
+          <a:bodyPr rtlCol="0" anchor="ctr" wrap="none"/>
+          <a:lstStyle/>
+          <a:p>
+            <a:pPr algn="ctr"/>
+            <a:r>
+              <a:rPr sz="650" b="0">
+                <a:solidFill>
+                  <a:srgbClr val="3A5278"/>
+                </a:solidFill>
+              </a:rPr>
+              <a:t>04 · Travaux</a:t>
+            </a:r>
+          </a:p>
+        </p:txBody>
+      </p:sp>
+      <p:sp>
+        <p:nvSpPr>
+          <p:cNvPr id="30" name="Rectangle 29"/>
+          <p:cNvSpPr/>
+          <p:nvPr/>
+        </p:nvSpPr>
+        <p:spPr>
+          <a:xfrm>
+            <a:off x="6096000" y="0"/>
+            <a:ext cx="1524000" cy="301752"/>
+          </a:xfrm>
+          <a:prstGeom prst="rect">
+            <a:avLst/>
+          </a:prstGeom>
+          <a:solidFill>
+            <a:srgbClr val="1E408A"/>
+          </a:solidFill>
+          <a:ln>
+            <a:noFill/>
+          </a:ln>
+        </p:spPr>
+        <p:style>
+          <a:lnRef idx="1">
+            <a:schemeClr val="accent1"/>
+          </a:lnRef>
+          <a:fillRef idx="3">
+            <a:schemeClr val="accent1"/>
+          </a:fillRef>
+          <a:effectRef idx="2">
+            <a:schemeClr val="accent1"/>
+          </a:effectRef>
+          <a:fontRef idx="minor">
+            <a:schemeClr val="lt1"/>
+          </a:fontRef>
+        </p:style>
+        <p:txBody>
+          <a:bodyPr rtlCol="0" anchor="ctr" wrap="none"/>
+          <a:lstStyle/>
+          <a:p>
+            <a:pPr algn="ctr"/>
+            <a:r>
+              <a:rPr sz="650" b="1">
+                <a:solidFill>
+                  <a:srgbClr val="FFFFFF"/>
+                </a:solidFill>
+              </a:rPr>
+              <a:t>05 · Resultats</a:t>
+            </a:r>
+          </a:p>
+        </p:txBody>
+      </p:sp>
+      <p:sp>
+        <p:nvSpPr>
+          <p:cNvPr id="31" name="Rectangle 30"/>
+          <p:cNvSpPr/>
+          <p:nvPr/>
+        </p:nvSpPr>
+        <p:spPr>
+          <a:xfrm>
+            <a:off x="7620000" y="0"/>
+            <a:ext cx="1524000" cy="301752"/>
+          </a:xfrm>
+          <a:prstGeom prst="rect">
+            <a:avLst/>
+          </a:prstGeom>
+          <a:solidFill>
+            <a:srgbClr val="D8E4F4"/>
+          </a:solidFill>
+          <a:ln>
+            <a:noFill/>
+          </a:ln>
+        </p:spPr>
+        <p:style>
+          <a:lnRef idx="1">
+            <a:schemeClr val="accent1"/>
+          </a:lnRef>
+          <a:fillRef idx="3">
+            <a:schemeClr val="accent1"/>
+          </a:fillRef>
+          <a:effectRef idx="2">
+            <a:schemeClr val="accent1"/>
+          </a:effectRef>
+          <a:fontRef idx="minor">
+            <a:schemeClr val="lt1"/>
+          </a:fontRef>
+        </p:style>
+        <p:txBody>
+          <a:bodyPr rtlCol="0" anchor="ctr" wrap="none"/>
+          <a:lstStyle/>
+          <a:p>
+            <a:pPr algn="ctr"/>
+            <a:r>
+              <a:rPr sz="650" b="0">
+                <a:solidFill>
+                  <a:srgbClr val="3A5278"/>
+                </a:solidFill>
+              </a:rPr>
+              <a:t>06 · Perspectives</a:t>
+            </a:r>
+          </a:p>
+        </p:txBody>
+      </p:sp>
     </p:spTree>
   </p:cSld>
   <p:clrMapOvr>
@@ -9740,6 +11882,312 @@
           </a:p>
         </p:txBody>
       </p:sp>
+      <p:sp>
+        <p:nvSpPr>
+          <p:cNvPr id="26" name="Rectangle 25"/>
+          <p:cNvSpPr/>
+          <p:nvPr/>
+        </p:nvSpPr>
+        <p:spPr>
+          <a:xfrm>
+            <a:off x="0" y="0"/>
+            <a:ext cx="1524000" cy="301752"/>
+          </a:xfrm>
+          <a:prstGeom prst="rect">
+            <a:avLst/>
+          </a:prstGeom>
+          <a:solidFill>
+            <a:srgbClr val="D8E4F4"/>
+          </a:solidFill>
+          <a:ln>
+            <a:noFill/>
+          </a:ln>
+        </p:spPr>
+        <p:style>
+          <a:lnRef idx="1">
+            <a:schemeClr val="accent1"/>
+          </a:lnRef>
+          <a:fillRef idx="3">
+            <a:schemeClr val="accent1"/>
+          </a:fillRef>
+          <a:effectRef idx="2">
+            <a:schemeClr val="accent1"/>
+          </a:effectRef>
+          <a:fontRef idx="minor">
+            <a:schemeClr val="lt1"/>
+          </a:fontRef>
+        </p:style>
+        <p:txBody>
+          <a:bodyPr rtlCol="0" anchor="ctr" wrap="none"/>
+          <a:lstStyle/>
+          <a:p>
+            <a:pPr algn="ctr"/>
+            <a:r>
+              <a:rPr sz="650" b="0">
+                <a:solidFill>
+                  <a:srgbClr val="3A5278"/>
+                </a:solidFill>
+              </a:rPr>
+              <a:t>01 · Contexte</a:t>
+            </a:r>
+          </a:p>
+        </p:txBody>
+      </p:sp>
+      <p:sp>
+        <p:nvSpPr>
+          <p:cNvPr id="27" name="Rectangle 26"/>
+          <p:cNvSpPr/>
+          <p:nvPr/>
+        </p:nvSpPr>
+        <p:spPr>
+          <a:xfrm>
+            <a:off x="1524000" y="0"/>
+            <a:ext cx="1524000" cy="301752"/>
+          </a:xfrm>
+          <a:prstGeom prst="rect">
+            <a:avLst/>
+          </a:prstGeom>
+          <a:solidFill>
+            <a:srgbClr val="D8E4F4"/>
+          </a:solidFill>
+          <a:ln>
+            <a:noFill/>
+          </a:ln>
+        </p:spPr>
+        <p:style>
+          <a:lnRef idx="1">
+            <a:schemeClr val="accent1"/>
+          </a:lnRef>
+          <a:fillRef idx="3">
+            <a:schemeClr val="accent1"/>
+          </a:fillRef>
+          <a:effectRef idx="2">
+            <a:schemeClr val="accent1"/>
+          </a:effectRef>
+          <a:fontRef idx="minor">
+            <a:schemeClr val="lt1"/>
+          </a:fontRef>
+        </p:style>
+        <p:txBody>
+          <a:bodyPr rtlCol="0" anchor="ctr" wrap="none"/>
+          <a:lstStyle/>
+          <a:p>
+            <a:pPr algn="ctr"/>
+            <a:r>
+              <a:rPr sz="650" b="0">
+                <a:solidFill>
+                  <a:srgbClr val="3A5278"/>
+                </a:solidFill>
+              </a:rPr>
+              <a:t>02 · Architecture</a:t>
+            </a:r>
+          </a:p>
+        </p:txBody>
+      </p:sp>
+      <p:sp>
+        <p:nvSpPr>
+          <p:cNvPr id="28" name="Rectangle 27"/>
+          <p:cNvSpPr/>
+          <p:nvPr/>
+        </p:nvSpPr>
+        <p:spPr>
+          <a:xfrm>
+            <a:off x="3048000" y="0"/>
+            <a:ext cx="1524000" cy="301752"/>
+          </a:xfrm>
+          <a:prstGeom prst="rect">
+            <a:avLst/>
+          </a:prstGeom>
+          <a:solidFill>
+            <a:srgbClr val="D8E4F4"/>
+          </a:solidFill>
+          <a:ln>
+            <a:noFill/>
+          </a:ln>
+        </p:spPr>
+        <p:style>
+          <a:lnRef idx="1">
+            <a:schemeClr val="accent1"/>
+          </a:lnRef>
+          <a:fillRef idx="3">
+            <a:schemeClr val="accent1"/>
+          </a:fillRef>
+          <a:effectRef idx="2">
+            <a:schemeClr val="accent1"/>
+          </a:effectRef>
+          <a:fontRef idx="minor">
+            <a:schemeClr val="lt1"/>
+          </a:fontRef>
+        </p:style>
+        <p:txBody>
+          <a:bodyPr rtlCol="0" anchor="ctr" wrap="none"/>
+          <a:lstStyle/>
+          <a:p>
+            <a:pPr algn="ctr"/>
+            <a:r>
+              <a:rPr sz="650" b="0">
+                <a:solidFill>
+                  <a:srgbClr val="3A5278"/>
+                </a:solidFill>
+              </a:rPr>
+              <a:t>03 · Suivi</a:t>
+            </a:r>
+          </a:p>
+        </p:txBody>
+      </p:sp>
+      <p:sp>
+        <p:nvSpPr>
+          <p:cNvPr id="29" name="Rectangle 28"/>
+          <p:cNvSpPr/>
+          <p:nvPr/>
+        </p:nvSpPr>
+        <p:spPr>
+          <a:xfrm>
+            <a:off x="4572000" y="0"/>
+            <a:ext cx="1524000" cy="301752"/>
+          </a:xfrm>
+          <a:prstGeom prst="rect">
+            <a:avLst/>
+          </a:prstGeom>
+          <a:solidFill>
+            <a:srgbClr val="D8E4F4"/>
+          </a:solidFill>
+          <a:ln>
+            <a:noFill/>
+          </a:ln>
+        </p:spPr>
+        <p:style>
+          <a:lnRef idx="1">
+            <a:schemeClr val="accent1"/>
+          </a:lnRef>
+          <a:fillRef idx="3">
+            <a:schemeClr val="accent1"/>
+          </a:fillRef>
+          <a:effectRef idx="2">
+            <a:schemeClr val="accent1"/>
+          </a:effectRef>
+          <a:fontRef idx="minor">
+            <a:schemeClr val="lt1"/>
+          </a:fontRef>
+        </p:style>
+        <p:txBody>
+          <a:bodyPr rtlCol="0" anchor="ctr" wrap="none"/>
+          <a:lstStyle/>
+          <a:p>
+            <a:pPr algn="ctr"/>
+            <a:r>
+              <a:rPr sz="650" b="0">
+                <a:solidFill>
+                  <a:srgbClr val="3A5278"/>
+                </a:solidFill>
+              </a:rPr>
+              <a:t>04 · Travaux</a:t>
+            </a:r>
+          </a:p>
+        </p:txBody>
+      </p:sp>
+      <p:sp>
+        <p:nvSpPr>
+          <p:cNvPr id="30" name="Rectangle 29"/>
+          <p:cNvSpPr/>
+          <p:nvPr/>
+        </p:nvSpPr>
+        <p:spPr>
+          <a:xfrm>
+            <a:off x="6096000" y="0"/>
+            <a:ext cx="1524000" cy="301752"/>
+          </a:xfrm>
+          <a:prstGeom prst="rect">
+            <a:avLst/>
+          </a:prstGeom>
+          <a:solidFill>
+            <a:srgbClr val="D8E4F4"/>
+          </a:solidFill>
+          <a:ln>
+            <a:noFill/>
+          </a:ln>
+        </p:spPr>
+        <p:style>
+          <a:lnRef idx="1">
+            <a:schemeClr val="accent1"/>
+          </a:lnRef>
+          <a:fillRef idx="3">
+            <a:schemeClr val="accent1"/>
+          </a:fillRef>
+          <a:effectRef idx="2">
+            <a:schemeClr val="accent1"/>
+          </a:effectRef>
+          <a:fontRef idx="minor">
+            <a:schemeClr val="lt1"/>
+          </a:fontRef>
+        </p:style>
+        <p:txBody>
+          <a:bodyPr rtlCol="0" anchor="ctr" wrap="none"/>
+          <a:lstStyle/>
+          <a:p>
+            <a:pPr algn="ctr"/>
+            <a:r>
+              <a:rPr sz="650" b="0">
+                <a:solidFill>
+                  <a:srgbClr val="3A5278"/>
+                </a:solidFill>
+              </a:rPr>
+              <a:t>05 · Resultats</a:t>
+            </a:r>
+          </a:p>
+        </p:txBody>
+      </p:sp>
+      <p:sp>
+        <p:nvSpPr>
+          <p:cNvPr id="31" name="Rectangle 30"/>
+          <p:cNvSpPr/>
+          <p:nvPr/>
+        </p:nvSpPr>
+        <p:spPr>
+          <a:xfrm>
+            <a:off x="7620000" y="0"/>
+            <a:ext cx="1524000" cy="301752"/>
+          </a:xfrm>
+          <a:prstGeom prst="rect">
+            <a:avLst/>
+          </a:prstGeom>
+          <a:solidFill>
+            <a:srgbClr val="1E408A"/>
+          </a:solidFill>
+          <a:ln>
+            <a:noFill/>
+          </a:ln>
+        </p:spPr>
+        <p:style>
+          <a:lnRef idx="1">
+            <a:schemeClr val="accent1"/>
+          </a:lnRef>
+          <a:fillRef idx="3">
+            <a:schemeClr val="accent1"/>
+          </a:fillRef>
+          <a:effectRef idx="2">
+            <a:schemeClr val="accent1"/>
+          </a:effectRef>
+          <a:fontRef idx="minor">
+            <a:schemeClr val="lt1"/>
+          </a:fontRef>
+        </p:style>
+        <p:txBody>
+          <a:bodyPr rtlCol="0" anchor="ctr" wrap="none"/>
+          <a:lstStyle/>
+          <a:p>
+            <a:pPr algn="ctr"/>
+            <a:r>
+              <a:rPr sz="650" b="1">
+                <a:solidFill>
+                  <a:srgbClr val="FFFFFF"/>
+                </a:solidFill>
+              </a:rPr>
+              <a:t>06 · Perspectives</a:t>
+            </a:r>
+          </a:p>
+        </p:txBody>
+      </p:sp>
     </p:spTree>
   </p:cSld>
   <p:clrMapOvr>
@@ -12107,6 +14555,312 @@
           </a:p>
         </p:txBody>
       </p:sp>
+      <p:sp>
+        <p:nvSpPr>
+          <p:cNvPr id="27" name="Rectangle 26"/>
+          <p:cNvSpPr/>
+          <p:nvPr/>
+        </p:nvSpPr>
+        <p:spPr>
+          <a:xfrm>
+            <a:off x="0" y="0"/>
+            <a:ext cx="1524000" cy="301752"/>
+          </a:xfrm>
+          <a:prstGeom prst="rect">
+            <a:avLst/>
+          </a:prstGeom>
+          <a:solidFill>
+            <a:srgbClr val="1E408A"/>
+          </a:solidFill>
+          <a:ln>
+            <a:noFill/>
+          </a:ln>
+        </p:spPr>
+        <p:style>
+          <a:lnRef idx="1">
+            <a:schemeClr val="accent1"/>
+          </a:lnRef>
+          <a:fillRef idx="3">
+            <a:schemeClr val="accent1"/>
+          </a:fillRef>
+          <a:effectRef idx="2">
+            <a:schemeClr val="accent1"/>
+          </a:effectRef>
+          <a:fontRef idx="minor">
+            <a:schemeClr val="lt1"/>
+          </a:fontRef>
+        </p:style>
+        <p:txBody>
+          <a:bodyPr rtlCol="0" anchor="ctr" wrap="none"/>
+          <a:lstStyle/>
+          <a:p>
+            <a:pPr algn="ctr"/>
+            <a:r>
+              <a:rPr sz="650" b="1">
+                <a:solidFill>
+                  <a:srgbClr val="FFFFFF"/>
+                </a:solidFill>
+              </a:rPr>
+              <a:t>01 · Contexte</a:t>
+            </a:r>
+          </a:p>
+        </p:txBody>
+      </p:sp>
+      <p:sp>
+        <p:nvSpPr>
+          <p:cNvPr id="28" name="Rectangle 27"/>
+          <p:cNvSpPr/>
+          <p:nvPr/>
+        </p:nvSpPr>
+        <p:spPr>
+          <a:xfrm>
+            <a:off x="1524000" y="0"/>
+            <a:ext cx="1524000" cy="301752"/>
+          </a:xfrm>
+          <a:prstGeom prst="rect">
+            <a:avLst/>
+          </a:prstGeom>
+          <a:solidFill>
+            <a:srgbClr val="D8E4F4"/>
+          </a:solidFill>
+          <a:ln>
+            <a:noFill/>
+          </a:ln>
+        </p:spPr>
+        <p:style>
+          <a:lnRef idx="1">
+            <a:schemeClr val="accent1"/>
+          </a:lnRef>
+          <a:fillRef idx="3">
+            <a:schemeClr val="accent1"/>
+          </a:fillRef>
+          <a:effectRef idx="2">
+            <a:schemeClr val="accent1"/>
+          </a:effectRef>
+          <a:fontRef idx="minor">
+            <a:schemeClr val="lt1"/>
+          </a:fontRef>
+        </p:style>
+        <p:txBody>
+          <a:bodyPr rtlCol="0" anchor="ctr" wrap="none"/>
+          <a:lstStyle/>
+          <a:p>
+            <a:pPr algn="ctr"/>
+            <a:r>
+              <a:rPr sz="650" b="0">
+                <a:solidFill>
+                  <a:srgbClr val="3A5278"/>
+                </a:solidFill>
+              </a:rPr>
+              <a:t>02 · Architecture</a:t>
+            </a:r>
+          </a:p>
+        </p:txBody>
+      </p:sp>
+      <p:sp>
+        <p:nvSpPr>
+          <p:cNvPr id="29" name="Rectangle 28"/>
+          <p:cNvSpPr/>
+          <p:nvPr/>
+        </p:nvSpPr>
+        <p:spPr>
+          <a:xfrm>
+            <a:off x="3048000" y="0"/>
+            <a:ext cx="1524000" cy="301752"/>
+          </a:xfrm>
+          <a:prstGeom prst="rect">
+            <a:avLst/>
+          </a:prstGeom>
+          <a:solidFill>
+            <a:srgbClr val="D8E4F4"/>
+          </a:solidFill>
+          <a:ln>
+            <a:noFill/>
+          </a:ln>
+        </p:spPr>
+        <p:style>
+          <a:lnRef idx="1">
+            <a:schemeClr val="accent1"/>
+          </a:lnRef>
+          <a:fillRef idx="3">
+            <a:schemeClr val="accent1"/>
+          </a:fillRef>
+          <a:effectRef idx="2">
+            <a:schemeClr val="accent1"/>
+          </a:effectRef>
+          <a:fontRef idx="minor">
+            <a:schemeClr val="lt1"/>
+          </a:fontRef>
+        </p:style>
+        <p:txBody>
+          <a:bodyPr rtlCol="0" anchor="ctr" wrap="none"/>
+          <a:lstStyle/>
+          <a:p>
+            <a:pPr algn="ctr"/>
+            <a:r>
+              <a:rPr sz="650" b="0">
+                <a:solidFill>
+                  <a:srgbClr val="3A5278"/>
+                </a:solidFill>
+              </a:rPr>
+              <a:t>03 · Suivi</a:t>
+            </a:r>
+          </a:p>
+        </p:txBody>
+      </p:sp>
+      <p:sp>
+        <p:nvSpPr>
+          <p:cNvPr id="30" name="Rectangle 29"/>
+          <p:cNvSpPr/>
+          <p:nvPr/>
+        </p:nvSpPr>
+        <p:spPr>
+          <a:xfrm>
+            <a:off x="4572000" y="0"/>
+            <a:ext cx="1524000" cy="301752"/>
+          </a:xfrm>
+          <a:prstGeom prst="rect">
+            <a:avLst/>
+          </a:prstGeom>
+          <a:solidFill>
+            <a:srgbClr val="D8E4F4"/>
+          </a:solidFill>
+          <a:ln>
+            <a:noFill/>
+          </a:ln>
+        </p:spPr>
+        <p:style>
+          <a:lnRef idx="1">
+            <a:schemeClr val="accent1"/>
+          </a:lnRef>
+          <a:fillRef idx="3">
+            <a:schemeClr val="accent1"/>
+          </a:fillRef>
+          <a:effectRef idx="2">
+            <a:schemeClr val="accent1"/>
+          </a:effectRef>
+          <a:fontRef idx="minor">
+            <a:schemeClr val="lt1"/>
+          </a:fontRef>
+        </p:style>
+        <p:txBody>
+          <a:bodyPr rtlCol="0" anchor="ctr" wrap="none"/>
+          <a:lstStyle/>
+          <a:p>
+            <a:pPr algn="ctr"/>
+            <a:r>
+              <a:rPr sz="650" b="0">
+                <a:solidFill>
+                  <a:srgbClr val="3A5278"/>
+                </a:solidFill>
+              </a:rPr>
+              <a:t>04 · Travaux</a:t>
+            </a:r>
+          </a:p>
+        </p:txBody>
+      </p:sp>
+      <p:sp>
+        <p:nvSpPr>
+          <p:cNvPr id="31" name="Rectangle 30"/>
+          <p:cNvSpPr/>
+          <p:nvPr/>
+        </p:nvSpPr>
+        <p:spPr>
+          <a:xfrm>
+            <a:off x="6096000" y="0"/>
+            <a:ext cx="1524000" cy="301752"/>
+          </a:xfrm>
+          <a:prstGeom prst="rect">
+            <a:avLst/>
+          </a:prstGeom>
+          <a:solidFill>
+            <a:srgbClr val="D8E4F4"/>
+          </a:solidFill>
+          <a:ln>
+            <a:noFill/>
+          </a:ln>
+        </p:spPr>
+        <p:style>
+          <a:lnRef idx="1">
+            <a:schemeClr val="accent1"/>
+          </a:lnRef>
+          <a:fillRef idx="3">
+            <a:schemeClr val="accent1"/>
+          </a:fillRef>
+          <a:effectRef idx="2">
+            <a:schemeClr val="accent1"/>
+          </a:effectRef>
+          <a:fontRef idx="minor">
+            <a:schemeClr val="lt1"/>
+          </a:fontRef>
+        </p:style>
+        <p:txBody>
+          <a:bodyPr rtlCol="0" anchor="ctr" wrap="none"/>
+          <a:lstStyle/>
+          <a:p>
+            <a:pPr algn="ctr"/>
+            <a:r>
+              <a:rPr sz="650" b="0">
+                <a:solidFill>
+                  <a:srgbClr val="3A5278"/>
+                </a:solidFill>
+              </a:rPr>
+              <a:t>05 · Resultats</a:t>
+            </a:r>
+          </a:p>
+        </p:txBody>
+      </p:sp>
+      <p:sp>
+        <p:nvSpPr>
+          <p:cNvPr id="32" name="Rectangle 31"/>
+          <p:cNvSpPr/>
+          <p:nvPr/>
+        </p:nvSpPr>
+        <p:spPr>
+          <a:xfrm>
+            <a:off x="7620000" y="0"/>
+            <a:ext cx="1524000" cy="301752"/>
+          </a:xfrm>
+          <a:prstGeom prst="rect">
+            <a:avLst/>
+          </a:prstGeom>
+          <a:solidFill>
+            <a:srgbClr val="D8E4F4"/>
+          </a:solidFill>
+          <a:ln>
+            <a:noFill/>
+          </a:ln>
+        </p:spPr>
+        <p:style>
+          <a:lnRef idx="1">
+            <a:schemeClr val="accent1"/>
+          </a:lnRef>
+          <a:fillRef idx="3">
+            <a:schemeClr val="accent1"/>
+          </a:fillRef>
+          <a:effectRef idx="2">
+            <a:schemeClr val="accent1"/>
+          </a:effectRef>
+          <a:fontRef idx="minor">
+            <a:schemeClr val="lt1"/>
+          </a:fontRef>
+        </p:style>
+        <p:txBody>
+          <a:bodyPr rtlCol="0" anchor="ctr" wrap="none"/>
+          <a:lstStyle/>
+          <a:p>
+            <a:pPr algn="ctr"/>
+            <a:r>
+              <a:rPr sz="650" b="0">
+                <a:solidFill>
+                  <a:srgbClr val="3A5278"/>
+                </a:solidFill>
+              </a:rPr>
+              <a:t>06 · Perspectives</a:t>
+            </a:r>
+          </a:p>
+        </p:txBody>
+      </p:sp>
     </p:spTree>
   </p:cSld>
   <p:clrMapOvr>
@@ -12952,6 +15706,312 @@
           </a:p>
         </p:txBody>
       </p:sp>
+      <p:sp>
+        <p:nvSpPr>
+          <p:cNvPr id="26" name="Rectangle 25"/>
+          <p:cNvSpPr/>
+          <p:nvPr/>
+        </p:nvSpPr>
+        <p:spPr>
+          <a:xfrm>
+            <a:off x="0" y="0"/>
+            <a:ext cx="1524000" cy="301752"/>
+          </a:xfrm>
+          <a:prstGeom prst="rect">
+            <a:avLst/>
+          </a:prstGeom>
+          <a:solidFill>
+            <a:srgbClr val="1E408A"/>
+          </a:solidFill>
+          <a:ln>
+            <a:noFill/>
+          </a:ln>
+        </p:spPr>
+        <p:style>
+          <a:lnRef idx="1">
+            <a:schemeClr val="accent1"/>
+          </a:lnRef>
+          <a:fillRef idx="3">
+            <a:schemeClr val="accent1"/>
+          </a:fillRef>
+          <a:effectRef idx="2">
+            <a:schemeClr val="accent1"/>
+          </a:effectRef>
+          <a:fontRef idx="minor">
+            <a:schemeClr val="lt1"/>
+          </a:fontRef>
+        </p:style>
+        <p:txBody>
+          <a:bodyPr rtlCol="0" anchor="ctr" wrap="none"/>
+          <a:lstStyle/>
+          <a:p>
+            <a:pPr algn="ctr"/>
+            <a:r>
+              <a:rPr sz="650" b="1">
+                <a:solidFill>
+                  <a:srgbClr val="FFFFFF"/>
+                </a:solidFill>
+              </a:rPr>
+              <a:t>01 · Contexte</a:t>
+            </a:r>
+          </a:p>
+        </p:txBody>
+      </p:sp>
+      <p:sp>
+        <p:nvSpPr>
+          <p:cNvPr id="27" name="Rectangle 26"/>
+          <p:cNvSpPr/>
+          <p:nvPr/>
+        </p:nvSpPr>
+        <p:spPr>
+          <a:xfrm>
+            <a:off x="1524000" y="0"/>
+            <a:ext cx="1524000" cy="301752"/>
+          </a:xfrm>
+          <a:prstGeom prst="rect">
+            <a:avLst/>
+          </a:prstGeom>
+          <a:solidFill>
+            <a:srgbClr val="D8E4F4"/>
+          </a:solidFill>
+          <a:ln>
+            <a:noFill/>
+          </a:ln>
+        </p:spPr>
+        <p:style>
+          <a:lnRef idx="1">
+            <a:schemeClr val="accent1"/>
+          </a:lnRef>
+          <a:fillRef idx="3">
+            <a:schemeClr val="accent1"/>
+          </a:fillRef>
+          <a:effectRef idx="2">
+            <a:schemeClr val="accent1"/>
+          </a:effectRef>
+          <a:fontRef idx="minor">
+            <a:schemeClr val="lt1"/>
+          </a:fontRef>
+        </p:style>
+        <p:txBody>
+          <a:bodyPr rtlCol="0" anchor="ctr" wrap="none"/>
+          <a:lstStyle/>
+          <a:p>
+            <a:pPr algn="ctr"/>
+            <a:r>
+              <a:rPr sz="650" b="0">
+                <a:solidFill>
+                  <a:srgbClr val="3A5278"/>
+                </a:solidFill>
+              </a:rPr>
+              <a:t>02 · Architecture</a:t>
+            </a:r>
+          </a:p>
+        </p:txBody>
+      </p:sp>
+      <p:sp>
+        <p:nvSpPr>
+          <p:cNvPr id="28" name="Rectangle 27"/>
+          <p:cNvSpPr/>
+          <p:nvPr/>
+        </p:nvSpPr>
+        <p:spPr>
+          <a:xfrm>
+            <a:off x="3048000" y="0"/>
+            <a:ext cx="1524000" cy="301752"/>
+          </a:xfrm>
+          <a:prstGeom prst="rect">
+            <a:avLst/>
+          </a:prstGeom>
+          <a:solidFill>
+            <a:srgbClr val="D8E4F4"/>
+          </a:solidFill>
+          <a:ln>
+            <a:noFill/>
+          </a:ln>
+        </p:spPr>
+        <p:style>
+          <a:lnRef idx="1">
+            <a:schemeClr val="accent1"/>
+          </a:lnRef>
+          <a:fillRef idx="3">
+            <a:schemeClr val="accent1"/>
+          </a:fillRef>
+          <a:effectRef idx="2">
+            <a:schemeClr val="accent1"/>
+          </a:effectRef>
+          <a:fontRef idx="minor">
+            <a:schemeClr val="lt1"/>
+          </a:fontRef>
+        </p:style>
+        <p:txBody>
+          <a:bodyPr rtlCol="0" anchor="ctr" wrap="none"/>
+          <a:lstStyle/>
+          <a:p>
+            <a:pPr algn="ctr"/>
+            <a:r>
+              <a:rPr sz="650" b="0">
+                <a:solidFill>
+                  <a:srgbClr val="3A5278"/>
+                </a:solidFill>
+              </a:rPr>
+              <a:t>03 · Suivi</a:t>
+            </a:r>
+          </a:p>
+        </p:txBody>
+      </p:sp>
+      <p:sp>
+        <p:nvSpPr>
+          <p:cNvPr id="29" name="Rectangle 28"/>
+          <p:cNvSpPr/>
+          <p:nvPr/>
+        </p:nvSpPr>
+        <p:spPr>
+          <a:xfrm>
+            <a:off x="4572000" y="0"/>
+            <a:ext cx="1524000" cy="301752"/>
+          </a:xfrm>
+          <a:prstGeom prst="rect">
+            <a:avLst/>
+          </a:prstGeom>
+          <a:solidFill>
+            <a:srgbClr val="D8E4F4"/>
+          </a:solidFill>
+          <a:ln>
+            <a:noFill/>
+          </a:ln>
+        </p:spPr>
+        <p:style>
+          <a:lnRef idx="1">
+            <a:schemeClr val="accent1"/>
+          </a:lnRef>
+          <a:fillRef idx="3">
+            <a:schemeClr val="accent1"/>
+          </a:fillRef>
+          <a:effectRef idx="2">
+            <a:schemeClr val="accent1"/>
+          </a:effectRef>
+          <a:fontRef idx="minor">
+            <a:schemeClr val="lt1"/>
+          </a:fontRef>
+        </p:style>
+        <p:txBody>
+          <a:bodyPr rtlCol="0" anchor="ctr" wrap="none"/>
+          <a:lstStyle/>
+          <a:p>
+            <a:pPr algn="ctr"/>
+            <a:r>
+              <a:rPr sz="650" b="0">
+                <a:solidFill>
+                  <a:srgbClr val="3A5278"/>
+                </a:solidFill>
+              </a:rPr>
+              <a:t>04 · Travaux</a:t>
+            </a:r>
+          </a:p>
+        </p:txBody>
+      </p:sp>
+      <p:sp>
+        <p:nvSpPr>
+          <p:cNvPr id="30" name="Rectangle 29"/>
+          <p:cNvSpPr/>
+          <p:nvPr/>
+        </p:nvSpPr>
+        <p:spPr>
+          <a:xfrm>
+            <a:off x="6096000" y="0"/>
+            <a:ext cx="1524000" cy="301752"/>
+          </a:xfrm>
+          <a:prstGeom prst="rect">
+            <a:avLst/>
+          </a:prstGeom>
+          <a:solidFill>
+            <a:srgbClr val="D8E4F4"/>
+          </a:solidFill>
+          <a:ln>
+            <a:noFill/>
+          </a:ln>
+        </p:spPr>
+        <p:style>
+          <a:lnRef idx="1">
+            <a:schemeClr val="accent1"/>
+          </a:lnRef>
+          <a:fillRef idx="3">
+            <a:schemeClr val="accent1"/>
+          </a:fillRef>
+          <a:effectRef idx="2">
+            <a:schemeClr val="accent1"/>
+          </a:effectRef>
+          <a:fontRef idx="minor">
+            <a:schemeClr val="lt1"/>
+          </a:fontRef>
+        </p:style>
+        <p:txBody>
+          <a:bodyPr rtlCol="0" anchor="ctr" wrap="none"/>
+          <a:lstStyle/>
+          <a:p>
+            <a:pPr algn="ctr"/>
+            <a:r>
+              <a:rPr sz="650" b="0">
+                <a:solidFill>
+                  <a:srgbClr val="3A5278"/>
+                </a:solidFill>
+              </a:rPr>
+              <a:t>05 · Resultats</a:t>
+            </a:r>
+          </a:p>
+        </p:txBody>
+      </p:sp>
+      <p:sp>
+        <p:nvSpPr>
+          <p:cNvPr id="31" name="Rectangle 30"/>
+          <p:cNvSpPr/>
+          <p:nvPr/>
+        </p:nvSpPr>
+        <p:spPr>
+          <a:xfrm>
+            <a:off x="7620000" y="0"/>
+            <a:ext cx="1524000" cy="301752"/>
+          </a:xfrm>
+          <a:prstGeom prst="rect">
+            <a:avLst/>
+          </a:prstGeom>
+          <a:solidFill>
+            <a:srgbClr val="D8E4F4"/>
+          </a:solidFill>
+          <a:ln>
+            <a:noFill/>
+          </a:ln>
+        </p:spPr>
+        <p:style>
+          <a:lnRef idx="1">
+            <a:schemeClr val="accent1"/>
+          </a:lnRef>
+          <a:fillRef idx="3">
+            <a:schemeClr val="accent1"/>
+          </a:fillRef>
+          <a:effectRef idx="2">
+            <a:schemeClr val="accent1"/>
+          </a:effectRef>
+          <a:fontRef idx="minor">
+            <a:schemeClr val="lt1"/>
+          </a:fontRef>
+        </p:style>
+        <p:txBody>
+          <a:bodyPr rtlCol="0" anchor="ctr" wrap="none"/>
+          <a:lstStyle/>
+          <a:p>
+            <a:pPr algn="ctr"/>
+            <a:r>
+              <a:rPr sz="650" b="0">
+                <a:solidFill>
+                  <a:srgbClr val="3A5278"/>
+                </a:solidFill>
+              </a:rPr>
+              <a:t>06 · Perspectives</a:t>
+            </a:r>
+          </a:p>
+        </p:txBody>
+      </p:sp>
     </p:spTree>
   </p:cSld>
   <p:clrMapOvr>
@@ -14869,6 +17929,312 @@
           </a:p>
         </p:txBody>
       </p:sp>
+      <p:sp>
+        <p:nvSpPr>
+          <p:cNvPr id="57" name="Rectangle 56"/>
+          <p:cNvSpPr/>
+          <p:nvPr/>
+        </p:nvSpPr>
+        <p:spPr>
+          <a:xfrm>
+            <a:off x="0" y="0"/>
+            <a:ext cx="1524000" cy="301752"/>
+          </a:xfrm>
+          <a:prstGeom prst="rect">
+            <a:avLst/>
+          </a:prstGeom>
+          <a:solidFill>
+            <a:srgbClr val="D8E4F4"/>
+          </a:solidFill>
+          <a:ln>
+            <a:noFill/>
+          </a:ln>
+        </p:spPr>
+        <p:style>
+          <a:lnRef idx="1">
+            <a:schemeClr val="accent1"/>
+          </a:lnRef>
+          <a:fillRef idx="3">
+            <a:schemeClr val="accent1"/>
+          </a:fillRef>
+          <a:effectRef idx="2">
+            <a:schemeClr val="accent1"/>
+          </a:effectRef>
+          <a:fontRef idx="minor">
+            <a:schemeClr val="lt1"/>
+          </a:fontRef>
+        </p:style>
+        <p:txBody>
+          <a:bodyPr rtlCol="0" anchor="ctr" wrap="none"/>
+          <a:lstStyle/>
+          <a:p>
+            <a:pPr algn="ctr"/>
+            <a:r>
+              <a:rPr sz="650" b="0">
+                <a:solidFill>
+                  <a:srgbClr val="3A5278"/>
+                </a:solidFill>
+              </a:rPr>
+              <a:t>01 · Contexte</a:t>
+            </a:r>
+          </a:p>
+        </p:txBody>
+      </p:sp>
+      <p:sp>
+        <p:nvSpPr>
+          <p:cNvPr id="58" name="Rectangle 57"/>
+          <p:cNvSpPr/>
+          <p:nvPr/>
+        </p:nvSpPr>
+        <p:spPr>
+          <a:xfrm>
+            <a:off x="1524000" y="0"/>
+            <a:ext cx="1524000" cy="301752"/>
+          </a:xfrm>
+          <a:prstGeom prst="rect">
+            <a:avLst/>
+          </a:prstGeom>
+          <a:solidFill>
+            <a:srgbClr val="1E408A"/>
+          </a:solidFill>
+          <a:ln>
+            <a:noFill/>
+          </a:ln>
+        </p:spPr>
+        <p:style>
+          <a:lnRef idx="1">
+            <a:schemeClr val="accent1"/>
+          </a:lnRef>
+          <a:fillRef idx="3">
+            <a:schemeClr val="accent1"/>
+          </a:fillRef>
+          <a:effectRef idx="2">
+            <a:schemeClr val="accent1"/>
+          </a:effectRef>
+          <a:fontRef idx="minor">
+            <a:schemeClr val="lt1"/>
+          </a:fontRef>
+        </p:style>
+        <p:txBody>
+          <a:bodyPr rtlCol="0" anchor="ctr" wrap="none"/>
+          <a:lstStyle/>
+          <a:p>
+            <a:pPr algn="ctr"/>
+            <a:r>
+              <a:rPr sz="650" b="1">
+                <a:solidFill>
+                  <a:srgbClr val="FFFFFF"/>
+                </a:solidFill>
+              </a:rPr>
+              <a:t>02 · Architecture</a:t>
+            </a:r>
+          </a:p>
+        </p:txBody>
+      </p:sp>
+      <p:sp>
+        <p:nvSpPr>
+          <p:cNvPr id="59" name="Rectangle 58"/>
+          <p:cNvSpPr/>
+          <p:nvPr/>
+        </p:nvSpPr>
+        <p:spPr>
+          <a:xfrm>
+            <a:off x="3048000" y="0"/>
+            <a:ext cx="1524000" cy="301752"/>
+          </a:xfrm>
+          <a:prstGeom prst="rect">
+            <a:avLst/>
+          </a:prstGeom>
+          <a:solidFill>
+            <a:srgbClr val="D8E4F4"/>
+          </a:solidFill>
+          <a:ln>
+            <a:noFill/>
+          </a:ln>
+        </p:spPr>
+        <p:style>
+          <a:lnRef idx="1">
+            <a:schemeClr val="accent1"/>
+          </a:lnRef>
+          <a:fillRef idx="3">
+            <a:schemeClr val="accent1"/>
+          </a:fillRef>
+          <a:effectRef idx="2">
+            <a:schemeClr val="accent1"/>
+          </a:effectRef>
+          <a:fontRef idx="minor">
+            <a:schemeClr val="lt1"/>
+          </a:fontRef>
+        </p:style>
+        <p:txBody>
+          <a:bodyPr rtlCol="0" anchor="ctr" wrap="none"/>
+          <a:lstStyle/>
+          <a:p>
+            <a:pPr algn="ctr"/>
+            <a:r>
+              <a:rPr sz="650" b="0">
+                <a:solidFill>
+                  <a:srgbClr val="3A5278"/>
+                </a:solidFill>
+              </a:rPr>
+              <a:t>03 · Suivi</a:t>
+            </a:r>
+          </a:p>
+        </p:txBody>
+      </p:sp>
+      <p:sp>
+        <p:nvSpPr>
+          <p:cNvPr id="60" name="Rectangle 59"/>
+          <p:cNvSpPr/>
+          <p:nvPr/>
+        </p:nvSpPr>
+        <p:spPr>
+          <a:xfrm>
+            <a:off x="4572000" y="0"/>
+            <a:ext cx="1524000" cy="301752"/>
+          </a:xfrm>
+          <a:prstGeom prst="rect">
+            <a:avLst/>
+          </a:prstGeom>
+          <a:solidFill>
+            <a:srgbClr val="D8E4F4"/>
+          </a:solidFill>
+          <a:ln>
+            <a:noFill/>
+          </a:ln>
+        </p:spPr>
+        <p:style>
+          <a:lnRef idx="1">
+            <a:schemeClr val="accent1"/>
+          </a:lnRef>
+          <a:fillRef idx="3">
+            <a:schemeClr val="accent1"/>
+          </a:fillRef>
+          <a:effectRef idx="2">
+            <a:schemeClr val="accent1"/>
+          </a:effectRef>
+          <a:fontRef idx="minor">
+            <a:schemeClr val="lt1"/>
+          </a:fontRef>
+        </p:style>
+        <p:txBody>
+          <a:bodyPr rtlCol="0" anchor="ctr" wrap="none"/>
+          <a:lstStyle/>
+          <a:p>
+            <a:pPr algn="ctr"/>
+            <a:r>
+              <a:rPr sz="650" b="0">
+                <a:solidFill>
+                  <a:srgbClr val="3A5278"/>
+                </a:solidFill>
+              </a:rPr>
+              <a:t>04 · Travaux</a:t>
+            </a:r>
+          </a:p>
+        </p:txBody>
+      </p:sp>
+      <p:sp>
+        <p:nvSpPr>
+          <p:cNvPr id="61" name="Rectangle 60"/>
+          <p:cNvSpPr/>
+          <p:nvPr/>
+        </p:nvSpPr>
+        <p:spPr>
+          <a:xfrm>
+            <a:off x="6096000" y="0"/>
+            <a:ext cx="1524000" cy="301752"/>
+          </a:xfrm>
+          <a:prstGeom prst="rect">
+            <a:avLst/>
+          </a:prstGeom>
+          <a:solidFill>
+            <a:srgbClr val="D8E4F4"/>
+          </a:solidFill>
+          <a:ln>
+            <a:noFill/>
+          </a:ln>
+        </p:spPr>
+        <p:style>
+          <a:lnRef idx="1">
+            <a:schemeClr val="accent1"/>
+          </a:lnRef>
+          <a:fillRef idx="3">
+            <a:schemeClr val="accent1"/>
+          </a:fillRef>
+          <a:effectRef idx="2">
+            <a:schemeClr val="accent1"/>
+          </a:effectRef>
+          <a:fontRef idx="minor">
+            <a:schemeClr val="lt1"/>
+          </a:fontRef>
+        </p:style>
+        <p:txBody>
+          <a:bodyPr rtlCol="0" anchor="ctr" wrap="none"/>
+          <a:lstStyle/>
+          <a:p>
+            <a:pPr algn="ctr"/>
+            <a:r>
+              <a:rPr sz="650" b="0">
+                <a:solidFill>
+                  <a:srgbClr val="3A5278"/>
+                </a:solidFill>
+              </a:rPr>
+              <a:t>05 · Resultats</a:t>
+            </a:r>
+          </a:p>
+        </p:txBody>
+      </p:sp>
+      <p:sp>
+        <p:nvSpPr>
+          <p:cNvPr id="62" name="Rectangle 61"/>
+          <p:cNvSpPr/>
+          <p:nvPr/>
+        </p:nvSpPr>
+        <p:spPr>
+          <a:xfrm>
+            <a:off x="7620000" y="0"/>
+            <a:ext cx="1524000" cy="301752"/>
+          </a:xfrm>
+          <a:prstGeom prst="rect">
+            <a:avLst/>
+          </a:prstGeom>
+          <a:solidFill>
+            <a:srgbClr val="D8E4F4"/>
+          </a:solidFill>
+          <a:ln>
+            <a:noFill/>
+          </a:ln>
+        </p:spPr>
+        <p:style>
+          <a:lnRef idx="1">
+            <a:schemeClr val="accent1"/>
+          </a:lnRef>
+          <a:fillRef idx="3">
+            <a:schemeClr val="accent1"/>
+          </a:fillRef>
+          <a:effectRef idx="2">
+            <a:schemeClr val="accent1"/>
+          </a:effectRef>
+          <a:fontRef idx="minor">
+            <a:schemeClr val="lt1"/>
+          </a:fontRef>
+        </p:style>
+        <p:txBody>
+          <a:bodyPr rtlCol="0" anchor="ctr" wrap="none"/>
+          <a:lstStyle/>
+          <a:p>
+            <a:pPr algn="ctr"/>
+            <a:r>
+              <a:rPr sz="650" b="0">
+                <a:solidFill>
+                  <a:srgbClr val="3A5278"/>
+                </a:solidFill>
+              </a:rPr>
+              <a:t>06 · Perspectives</a:t>
+            </a:r>
+          </a:p>
+        </p:txBody>
+      </p:sp>
     </p:spTree>
   </p:cSld>
   <p:clrMapOvr>
@@ -16048,6 +19414,312 @@
           </a:p>
         </p:txBody>
       </p:sp>
+      <p:sp>
+        <p:nvSpPr>
+          <p:cNvPr id="35" name="Rectangle 34"/>
+          <p:cNvSpPr/>
+          <p:nvPr/>
+        </p:nvSpPr>
+        <p:spPr>
+          <a:xfrm>
+            <a:off x="0" y="0"/>
+            <a:ext cx="1524000" cy="301752"/>
+          </a:xfrm>
+          <a:prstGeom prst="rect">
+            <a:avLst/>
+          </a:prstGeom>
+          <a:solidFill>
+            <a:srgbClr val="D8E4F4"/>
+          </a:solidFill>
+          <a:ln>
+            <a:noFill/>
+          </a:ln>
+        </p:spPr>
+        <p:style>
+          <a:lnRef idx="1">
+            <a:schemeClr val="accent1"/>
+          </a:lnRef>
+          <a:fillRef idx="3">
+            <a:schemeClr val="accent1"/>
+          </a:fillRef>
+          <a:effectRef idx="2">
+            <a:schemeClr val="accent1"/>
+          </a:effectRef>
+          <a:fontRef idx="minor">
+            <a:schemeClr val="lt1"/>
+          </a:fontRef>
+        </p:style>
+        <p:txBody>
+          <a:bodyPr rtlCol="0" anchor="ctr" wrap="none"/>
+          <a:lstStyle/>
+          <a:p>
+            <a:pPr algn="ctr"/>
+            <a:r>
+              <a:rPr sz="650" b="0">
+                <a:solidFill>
+                  <a:srgbClr val="3A5278"/>
+                </a:solidFill>
+              </a:rPr>
+              <a:t>01 · Contexte</a:t>
+            </a:r>
+          </a:p>
+        </p:txBody>
+      </p:sp>
+      <p:sp>
+        <p:nvSpPr>
+          <p:cNvPr id="36" name="Rectangle 35"/>
+          <p:cNvSpPr/>
+          <p:nvPr/>
+        </p:nvSpPr>
+        <p:spPr>
+          <a:xfrm>
+            <a:off x="1524000" y="0"/>
+            <a:ext cx="1524000" cy="301752"/>
+          </a:xfrm>
+          <a:prstGeom prst="rect">
+            <a:avLst/>
+          </a:prstGeom>
+          <a:solidFill>
+            <a:srgbClr val="1E408A"/>
+          </a:solidFill>
+          <a:ln>
+            <a:noFill/>
+          </a:ln>
+        </p:spPr>
+        <p:style>
+          <a:lnRef idx="1">
+            <a:schemeClr val="accent1"/>
+          </a:lnRef>
+          <a:fillRef idx="3">
+            <a:schemeClr val="accent1"/>
+          </a:fillRef>
+          <a:effectRef idx="2">
+            <a:schemeClr val="accent1"/>
+          </a:effectRef>
+          <a:fontRef idx="minor">
+            <a:schemeClr val="lt1"/>
+          </a:fontRef>
+        </p:style>
+        <p:txBody>
+          <a:bodyPr rtlCol="0" anchor="ctr" wrap="none"/>
+          <a:lstStyle/>
+          <a:p>
+            <a:pPr algn="ctr"/>
+            <a:r>
+              <a:rPr sz="650" b="1">
+                <a:solidFill>
+                  <a:srgbClr val="FFFFFF"/>
+                </a:solidFill>
+              </a:rPr>
+              <a:t>02 · Architecture</a:t>
+            </a:r>
+          </a:p>
+        </p:txBody>
+      </p:sp>
+      <p:sp>
+        <p:nvSpPr>
+          <p:cNvPr id="37" name="Rectangle 36"/>
+          <p:cNvSpPr/>
+          <p:nvPr/>
+        </p:nvSpPr>
+        <p:spPr>
+          <a:xfrm>
+            <a:off x="3048000" y="0"/>
+            <a:ext cx="1524000" cy="301752"/>
+          </a:xfrm>
+          <a:prstGeom prst="rect">
+            <a:avLst/>
+          </a:prstGeom>
+          <a:solidFill>
+            <a:srgbClr val="D8E4F4"/>
+          </a:solidFill>
+          <a:ln>
+            <a:noFill/>
+          </a:ln>
+        </p:spPr>
+        <p:style>
+          <a:lnRef idx="1">
+            <a:schemeClr val="accent1"/>
+          </a:lnRef>
+          <a:fillRef idx="3">
+            <a:schemeClr val="accent1"/>
+          </a:fillRef>
+          <a:effectRef idx="2">
+            <a:schemeClr val="accent1"/>
+          </a:effectRef>
+          <a:fontRef idx="minor">
+            <a:schemeClr val="lt1"/>
+          </a:fontRef>
+        </p:style>
+        <p:txBody>
+          <a:bodyPr rtlCol="0" anchor="ctr" wrap="none"/>
+          <a:lstStyle/>
+          <a:p>
+            <a:pPr algn="ctr"/>
+            <a:r>
+              <a:rPr sz="650" b="0">
+                <a:solidFill>
+                  <a:srgbClr val="3A5278"/>
+                </a:solidFill>
+              </a:rPr>
+              <a:t>03 · Suivi</a:t>
+            </a:r>
+          </a:p>
+        </p:txBody>
+      </p:sp>
+      <p:sp>
+        <p:nvSpPr>
+          <p:cNvPr id="38" name="Rectangle 37"/>
+          <p:cNvSpPr/>
+          <p:nvPr/>
+        </p:nvSpPr>
+        <p:spPr>
+          <a:xfrm>
+            <a:off x="4572000" y="0"/>
+            <a:ext cx="1524000" cy="301752"/>
+          </a:xfrm>
+          <a:prstGeom prst="rect">
+            <a:avLst/>
+          </a:prstGeom>
+          <a:solidFill>
+            <a:srgbClr val="D8E4F4"/>
+          </a:solidFill>
+          <a:ln>
+            <a:noFill/>
+          </a:ln>
+        </p:spPr>
+        <p:style>
+          <a:lnRef idx="1">
+            <a:schemeClr val="accent1"/>
+          </a:lnRef>
+          <a:fillRef idx="3">
+            <a:schemeClr val="accent1"/>
+          </a:fillRef>
+          <a:effectRef idx="2">
+            <a:schemeClr val="accent1"/>
+          </a:effectRef>
+          <a:fontRef idx="minor">
+            <a:schemeClr val="lt1"/>
+          </a:fontRef>
+        </p:style>
+        <p:txBody>
+          <a:bodyPr rtlCol="0" anchor="ctr" wrap="none"/>
+          <a:lstStyle/>
+          <a:p>
+            <a:pPr algn="ctr"/>
+            <a:r>
+              <a:rPr sz="650" b="0">
+                <a:solidFill>
+                  <a:srgbClr val="3A5278"/>
+                </a:solidFill>
+              </a:rPr>
+              <a:t>04 · Travaux</a:t>
+            </a:r>
+          </a:p>
+        </p:txBody>
+      </p:sp>
+      <p:sp>
+        <p:nvSpPr>
+          <p:cNvPr id="39" name="Rectangle 38"/>
+          <p:cNvSpPr/>
+          <p:nvPr/>
+        </p:nvSpPr>
+        <p:spPr>
+          <a:xfrm>
+            <a:off x="6096000" y="0"/>
+            <a:ext cx="1524000" cy="301752"/>
+          </a:xfrm>
+          <a:prstGeom prst="rect">
+            <a:avLst/>
+          </a:prstGeom>
+          <a:solidFill>
+            <a:srgbClr val="D8E4F4"/>
+          </a:solidFill>
+          <a:ln>
+            <a:noFill/>
+          </a:ln>
+        </p:spPr>
+        <p:style>
+          <a:lnRef idx="1">
+            <a:schemeClr val="accent1"/>
+          </a:lnRef>
+          <a:fillRef idx="3">
+            <a:schemeClr val="accent1"/>
+          </a:fillRef>
+          <a:effectRef idx="2">
+            <a:schemeClr val="accent1"/>
+          </a:effectRef>
+          <a:fontRef idx="minor">
+            <a:schemeClr val="lt1"/>
+          </a:fontRef>
+        </p:style>
+        <p:txBody>
+          <a:bodyPr rtlCol="0" anchor="ctr" wrap="none"/>
+          <a:lstStyle/>
+          <a:p>
+            <a:pPr algn="ctr"/>
+            <a:r>
+              <a:rPr sz="650" b="0">
+                <a:solidFill>
+                  <a:srgbClr val="3A5278"/>
+                </a:solidFill>
+              </a:rPr>
+              <a:t>05 · Resultats</a:t>
+            </a:r>
+          </a:p>
+        </p:txBody>
+      </p:sp>
+      <p:sp>
+        <p:nvSpPr>
+          <p:cNvPr id="40" name="Rectangle 39"/>
+          <p:cNvSpPr/>
+          <p:nvPr/>
+        </p:nvSpPr>
+        <p:spPr>
+          <a:xfrm>
+            <a:off x="7620000" y="0"/>
+            <a:ext cx="1524000" cy="301752"/>
+          </a:xfrm>
+          <a:prstGeom prst="rect">
+            <a:avLst/>
+          </a:prstGeom>
+          <a:solidFill>
+            <a:srgbClr val="D8E4F4"/>
+          </a:solidFill>
+          <a:ln>
+            <a:noFill/>
+          </a:ln>
+        </p:spPr>
+        <p:style>
+          <a:lnRef idx="1">
+            <a:schemeClr val="accent1"/>
+          </a:lnRef>
+          <a:fillRef idx="3">
+            <a:schemeClr val="accent1"/>
+          </a:fillRef>
+          <a:effectRef idx="2">
+            <a:schemeClr val="accent1"/>
+          </a:effectRef>
+          <a:fontRef idx="minor">
+            <a:schemeClr val="lt1"/>
+          </a:fontRef>
+        </p:style>
+        <p:txBody>
+          <a:bodyPr rtlCol="0" anchor="ctr" wrap="none"/>
+          <a:lstStyle/>
+          <a:p>
+            <a:pPr algn="ctr"/>
+            <a:r>
+              <a:rPr sz="650" b="0">
+                <a:solidFill>
+                  <a:srgbClr val="3A5278"/>
+                </a:solidFill>
+              </a:rPr>
+              <a:t>06 · Perspectives</a:t>
+            </a:r>
+          </a:p>
+        </p:txBody>
+      </p:sp>
     </p:spTree>
   </p:cSld>
   <p:clrMapOvr>
@@ -17571,6 +21243,312 @@
           </a:p>
         </p:txBody>
       </p:sp>
+      <p:sp>
+        <p:nvSpPr>
+          <p:cNvPr id="46" name="Rectangle 45"/>
+          <p:cNvSpPr/>
+          <p:nvPr/>
+        </p:nvSpPr>
+        <p:spPr>
+          <a:xfrm>
+            <a:off x="0" y="0"/>
+            <a:ext cx="1524000" cy="301752"/>
+          </a:xfrm>
+          <a:prstGeom prst="rect">
+            <a:avLst/>
+          </a:prstGeom>
+          <a:solidFill>
+            <a:srgbClr val="D8E4F4"/>
+          </a:solidFill>
+          <a:ln>
+            <a:noFill/>
+          </a:ln>
+        </p:spPr>
+        <p:style>
+          <a:lnRef idx="1">
+            <a:schemeClr val="accent1"/>
+          </a:lnRef>
+          <a:fillRef idx="3">
+            <a:schemeClr val="accent1"/>
+          </a:fillRef>
+          <a:effectRef idx="2">
+            <a:schemeClr val="accent1"/>
+          </a:effectRef>
+          <a:fontRef idx="minor">
+            <a:schemeClr val="lt1"/>
+          </a:fontRef>
+        </p:style>
+        <p:txBody>
+          <a:bodyPr rtlCol="0" anchor="ctr" wrap="none"/>
+          <a:lstStyle/>
+          <a:p>
+            <a:pPr algn="ctr"/>
+            <a:r>
+              <a:rPr sz="650" b="0">
+                <a:solidFill>
+                  <a:srgbClr val="3A5278"/>
+                </a:solidFill>
+              </a:rPr>
+              <a:t>01 · Contexte</a:t>
+            </a:r>
+          </a:p>
+        </p:txBody>
+      </p:sp>
+      <p:sp>
+        <p:nvSpPr>
+          <p:cNvPr id="47" name="Rectangle 46"/>
+          <p:cNvSpPr/>
+          <p:nvPr/>
+        </p:nvSpPr>
+        <p:spPr>
+          <a:xfrm>
+            <a:off x="1524000" y="0"/>
+            <a:ext cx="1524000" cy="301752"/>
+          </a:xfrm>
+          <a:prstGeom prst="rect">
+            <a:avLst/>
+          </a:prstGeom>
+          <a:solidFill>
+            <a:srgbClr val="D8E4F4"/>
+          </a:solidFill>
+          <a:ln>
+            <a:noFill/>
+          </a:ln>
+        </p:spPr>
+        <p:style>
+          <a:lnRef idx="1">
+            <a:schemeClr val="accent1"/>
+          </a:lnRef>
+          <a:fillRef idx="3">
+            <a:schemeClr val="accent1"/>
+          </a:fillRef>
+          <a:effectRef idx="2">
+            <a:schemeClr val="accent1"/>
+          </a:effectRef>
+          <a:fontRef idx="minor">
+            <a:schemeClr val="lt1"/>
+          </a:fontRef>
+        </p:style>
+        <p:txBody>
+          <a:bodyPr rtlCol="0" anchor="ctr" wrap="none"/>
+          <a:lstStyle/>
+          <a:p>
+            <a:pPr algn="ctr"/>
+            <a:r>
+              <a:rPr sz="650" b="0">
+                <a:solidFill>
+                  <a:srgbClr val="3A5278"/>
+                </a:solidFill>
+              </a:rPr>
+              <a:t>02 · Architecture</a:t>
+            </a:r>
+          </a:p>
+        </p:txBody>
+      </p:sp>
+      <p:sp>
+        <p:nvSpPr>
+          <p:cNvPr id="48" name="Rectangle 47"/>
+          <p:cNvSpPr/>
+          <p:nvPr/>
+        </p:nvSpPr>
+        <p:spPr>
+          <a:xfrm>
+            <a:off x="3048000" y="0"/>
+            <a:ext cx="1524000" cy="301752"/>
+          </a:xfrm>
+          <a:prstGeom prst="rect">
+            <a:avLst/>
+          </a:prstGeom>
+          <a:solidFill>
+            <a:srgbClr val="1E408A"/>
+          </a:solidFill>
+          <a:ln>
+            <a:noFill/>
+          </a:ln>
+        </p:spPr>
+        <p:style>
+          <a:lnRef idx="1">
+            <a:schemeClr val="accent1"/>
+          </a:lnRef>
+          <a:fillRef idx="3">
+            <a:schemeClr val="accent1"/>
+          </a:fillRef>
+          <a:effectRef idx="2">
+            <a:schemeClr val="accent1"/>
+          </a:effectRef>
+          <a:fontRef idx="minor">
+            <a:schemeClr val="lt1"/>
+          </a:fontRef>
+        </p:style>
+        <p:txBody>
+          <a:bodyPr rtlCol="0" anchor="ctr" wrap="none"/>
+          <a:lstStyle/>
+          <a:p>
+            <a:pPr algn="ctr"/>
+            <a:r>
+              <a:rPr sz="650" b="1">
+                <a:solidFill>
+                  <a:srgbClr val="FFFFFF"/>
+                </a:solidFill>
+              </a:rPr>
+              <a:t>03 · Suivi</a:t>
+            </a:r>
+          </a:p>
+        </p:txBody>
+      </p:sp>
+      <p:sp>
+        <p:nvSpPr>
+          <p:cNvPr id="49" name="Rectangle 48"/>
+          <p:cNvSpPr/>
+          <p:nvPr/>
+        </p:nvSpPr>
+        <p:spPr>
+          <a:xfrm>
+            <a:off x="4572000" y="0"/>
+            <a:ext cx="1524000" cy="301752"/>
+          </a:xfrm>
+          <a:prstGeom prst="rect">
+            <a:avLst/>
+          </a:prstGeom>
+          <a:solidFill>
+            <a:srgbClr val="D8E4F4"/>
+          </a:solidFill>
+          <a:ln>
+            <a:noFill/>
+          </a:ln>
+        </p:spPr>
+        <p:style>
+          <a:lnRef idx="1">
+            <a:schemeClr val="accent1"/>
+          </a:lnRef>
+          <a:fillRef idx="3">
+            <a:schemeClr val="accent1"/>
+          </a:fillRef>
+          <a:effectRef idx="2">
+            <a:schemeClr val="accent1"/>
+          </a:effectRef>
+          <a:fontRef idx="minor">
+            <a:schemeClr val="lt1"/>
+          </a:fontRef>
+        </p:style>
+        <p:txBody>
+          <a:bodyPr rtlCol="0" anchor="ctr" wrap="none"/>
+          <a:lstStyle/>
+          <a:p>
+            <a:pPr algn="ctr"/>
+            <a:r>
+              <a:rPr sz="650" b="0">
+                <a:solidFill>
+                  <a:srgbClr val="3A5278"/>
+                </a:solidFill>
+              </a:rPr>
+              <a:t>04 · Travaux</a:t>
+            </a:r>
+          </a:p>
+        </p:txBody>
+      </p:sp>
+      <p:sp>
+        <p:nvSpPr>
+          <p:cNvPr id="50" name="Rectangle 49"/>
+          <p:cNvSpPr/>
+          <p:nvPr/>
+        </p:nvSpPr>
+        <p:spPr>
+          <a:xfrm>
+            <a:off x="6096000" y="0"/>
+            <a:ext cx="1524000" cy="301752"/>
+          </a:xfrm>
+          <a:prstGeom prst="rect">
+            <a:avLst/>
+          </a:prstGeom>
+          <a:solidFill>
+            <a:srgbClr val="D8E4F4"/>
+          </a:solidFill>
+          <a:ln>
+            <a:noFill/>
+          </a:ln>
+        </p:spPr>
+        <p:style>
+          <a:lnRef idx="1">
+            <a:schemeClr val="accent1"/>
+          </a:lnRef>
+          <a:fillRef idx="3">
+            <a:schemeClr val="accent1"/>
+          </a:fillRef>
+          <a:effectRef idx="2">
+            <a:schemeClr val="accent1"/>
+          </a:effectRef>
+          <a:fontRef idx="minor">
+            <a:schemeClr val="lt1"/>
+          </a:fontRef>
+        </p:style>
+        <p:txBody>
+          <a:bodyPr rtlCol="0" anchor="ctr" wrap="none"/>
+          <a:lstStyle/>
+          <a:p>
+            <a:pPr algn="ctr"/>
+            <a:r>
+              <a:rPr sz="650" b="0">
+                <a:solidFill>
+                  <a:srgbClr val="3A5278"/>
+                </a:solidFill>
+              </a:rPr>
+              <a:t>05 · Resultats</a:t>
+            </a:r>
+          </a:p>
+        </p:txBody>
+      </p:sp>
+      <p:sp>
+        <p:nvSpPr>
+          <p:cNvPr id="51" name="Rectangle 50"/>
+          <p:cNvSpPr/>
+          <p:nvPr/>
+        </p:nvSpPr>
+        <p:spPr>
+          <a:xfrm>
+            <a:off x="7620000" y="0"/>
+            <a:ext cx="1524000" cy="301752"/>
+          </a:xfrm>
+          <a:prstGeom prst="rect">
+            <a:avLst/>
+          </a:prstGeom>
+          <a:solidFill>
+            <a:srgbClr val="D8E4F4"/>
+          </a:solidFill>
+          <a:ln>
+            <a:noFill/>
+          </a:ln>
+        </p:spPr>
+        <p:style>
+          <a:lnRef idx="1">
+            <a:schemeClr val="accent1"/>
+          </a:lnRef>
+          <a:fillRef idx="3">
+            <a:schemeClr val="accent1"/>
+          </a:fillRef>
+          <a:effectRef idx="2">
+            <a:schemeClr val="accent1"/>
+          </a:effectRef>
+          <a:fontRef idx="minor">
+            <a:schemeClr val="lt1"/>
+          </a:fontRef>
+        </p:style>
+        <p:txBody>
+          <a:bodyPr rtlCol="0" anchor="ctr" wrap="none"/>
+          <a:lstStyle/>
+          <a:p>
+            <a:pPr algn="ctr"/>
+            <a:r>
+              <a:rPr sz="650" b="0">
+                <a:solidFill>
+                  <a:srgbClr val="3A5278"/>
+                </a:solidFill>
+              </a:rPr>
+              <a:t>06 · Perspectives</a:t>
+            </a:r>
+          </a:p>
+        </p:txBody>
+      </p:sp>
     </p:spTree>
   </p:cSld>
   <p:clrMapOvr>
@@ -19392,6 +23370,312 @@
           </a:p>
         </p:txBody>
       </p:sp>
+      <p:sp>
+        <p:nvSpPr>
+          <p:cNvPr id="54" name="Rectangle 53"/>
+          <p:cNvSpPr/>
+          <p:nvPr/>
+        </p:nvSpPr>
+        <p:spPr>
+          <a:xfrm>
+            <a:off x="0" y="0"/>
+            <a:ext cx="1524000" cy="301752"/>
+          </a:xfrm>
+          <a:prstGeom prst="rect">
+            <a:avLst/>
+          </a:prstGeom>
+          <a:solidFill>
+            <a:srgbClr val="D8E4F4"/>
+          </a:solidFill>
+          <a:ln>
+            <a:noFill/>
+          </a:ln>
+        </p:spPr>
+        <p:style>
+          <a:lnRef idx="1">
+            <a:schemeClr val="accent1"/>
+          </a:lnRef>
+          <a:fillRef idx="3">
+            <a:schemeClr val="accent1"/>
+          </a:fillRef>
+          <a:effectRef idx="2">
+            <a:schemeClr val="accent1"/>
+          </a:effectRef>
+          <a:fontRef idx="minor">
+            <a:schemeClr val="lt1"/>
+          </a:fontRef>
+        </p:style>
+        <p:txBody>
+          <a:bodyPr rtlCol="0" anchor="ctr" wrap="none"/>
+          <a:lstStyle/>
+          <a:p>
+            <a:pPr algn="ctr"/>
+            <a:r>
+              <a:rPr sz="650" b="0">
+                <a:solidFill>
+                  <a:srgbClr val="3A5278"/>
+                </a:solidFill>
+              </a:rPr>
+              <a:t>01 · Contexte</a:t>
+            </a:r>
+          </a:p>
+        </p:txBody>
+      </p:sp>
+      <p:sp>
+        <p:nvSpPr>
+          <p:cNvPr id="55" name="Rectangle 54"/>
+          <p:cNvSpPr/>
+          <p:nvPr/>
+        </p:nvSpPr>
+        <p:spPr>
+          <a:xfrm>
+            <a:off x="1524000" y="0"/>
+            <a:ext cx="1524000" cy="301752"/>
+          </a:xfrm>
+          <a:prstGeom prst="rect">
+            <a:avLst/>
+          </a:prstGeom>
+          <a:solidFill>
+            <a:srgbClr val="D8E4F4"/>
+          </a:solidFill>
+          <a:ln>
+            <a:noFill/>
+          </a:ln>
+        </p:spPr>
+        <p:style>
+          <a:lnRef idx="1">
+            <a:schemeClr val="accent1"/>
+          </a:lnRef>
+          <a:fillRef idx="3">
+            <a:schemeClr val="accent1"/>
+          </a:fillRef>
+          <a:effectRef idx="2">
+            <a:schemeClr val="accent1"/>
+          </a:effectRef>
+          <a:fontRef idx="minor">
+            <a:schemeClr val="lt1"/>
+          </a:fontRef>
+        </p:style>
+        <p:txBody>
+          <a:bodyPr rtlCol="0" anchor="ctr" wrap="none"/>
+          <a:lstStyle/>
+          <a:p>
+            <a:pPr algn="ctr"/>
+            <a:r>
+              <a:rPr sz="650" b="0">
+                <a:solidFill>
+                  <a:srgbClr val="3A5278"/>
+                </a:solidFill>
+              </a:rPr>
+              <a:t>02 · Architecture</a:t>
+            </a:r>
+          </a:p>
+        </p:txBody>
+      </p:sp>
+      <p:sp>
+        <p:nvSpPr>
+          <p:cNvPr id="56" name="Rectangle 55"/>
+          <p:cNvSpPr/>
+          <p:nvPr/>
+        </p:nvSpPr>
+        <p:spPr>
+          <a:xfrm>
+            <a:off x="3048000" y="0"/>
+            <a:ext cx="1524000" cy="301752"/>
+          </a:xfrm>
+          <a:prstGeom prst="rect">
+            <a:avLst/>
+          </a:prstGeom>
+          <a:solidFill>
+            <a:srgbClr val="1E408A"/>
+          </a:solidFill>
+          <a:ln>
+            <a:noFill/>
+          </a:ln>
+        </p:spPr>
+        <p:style>
+          <a:lnRef idx="1">
+            <a:schemeClr val="accent1"/>
+          </a:lnRef>
+          <a:fillRef idx="3">
+            <a:schemeClr val="accent1"/>
+          </a:fillRef>
+          <a:effectRef idx="2">
+            <a:schemeClr val="accent1"/>
+          </a:effectRef>
+          <a:fontRef idx="minor">
+            <a:schemeClr val="lt1"/>
+          </a:fontRef>
+        </p:style>
+        <p:txBody>
+          <a:bodyPr rtlCol="0" anchor="ctr" wrap="none"/>
+          <a:lstStyle/>
+          <a:p>
+            <a:pPr algn="ctr"/>
+            <a:r>
+              <a:rPr sz="650" b="1">
+                <a:solidFill>
+                  <a:srgbClr val="FFFFFF"/>
+                </a:solidFill>
+              </a:rPr>
+              <a:t>03 · Suivi</a:t>
+            </a:r>
+          </a:p>
+        </p:txBody>
+      </p:sp>
+      <p:sp>
+        <p:nvSpPr>
+          <p:cNvPr id="57" name="Rectangle 56"/>
+          <p:cNvSpPr/>
+          <p:nvPr/>
+        </p:nvSpPr>
+        <p:spPr>
+          <a:xfrm>
+            <a:off x="4572000" y="0"/>
+            <a:ext cx="1524000" cy="301752"/>
+          </a:xfrm>
+          <a:prstGeom prst="rect">
+            <a:avLst/>
+          </a:prstGeom>
+          <a:solidFill>
+            <a:srgbClr val="D8E4F4"/>
+          </a:solidFill>
+          <a:ln>
+            <a:noFill/>
+          </a:ln>
+        </p:spPr>
+        <p:style>
+          <a:lnRef idx="1">
+            <a:schemeClr val="accent1"/>
+          </a:lnRef>
+          <a:fillRef idx="3">
+            <a:schemeClr val="accent1"/>
+          </a:fillRef>
+          <a:effectRef idx="2">
+            <a:schemeClr val="accent1"/>
+          </a:effectRef>
+          <a:fontRef idx="minor">
+            <a:schemeClr val="lt1"/>
+          </a:fontRef>
+        </p:style>
+        <p:txBody>
+          <a:bodyPr rtlCol="0" anchor="ctr" wrap="none"/>
+          <a:lstStyle/>
+          <a:p>
+            <a:pPr algn="ctr"/>
+            <a:r>
+              <a:rPr sz="650" b="0">
+                <a:solidFill>
+                  <a:srgbClr val="3A5278"/>
+                </a:solidFill>
+              </a:rPr>
+              <a:t>04 · Travaux</a:t>
+            </a:r>
+          </a:p>
+        </p:txBody>
+      </p:sp>
+      <p:sp>
+        <p:nvSpPr>
+          <p:cNvPr id="58" name="Rectangle 57"/>
+          <p:cNvSpPr/>
+          <p:nvPr/>
+        </p:nvSpPr>
+        <p:spPr>
+          <a:xfrm>
+            <a:off x="6096000" y="0"/>
+            <a:ext cx="1524000" cy="301752"/>
+          </a:xfrm>
+          <a:prstGeom prst="rect">
+            <a:avLst/>
+          </a:prstGeom>
+          <a:solidFill>
+            <a:srgbClr val="D8E4F4"/>
+          </a:solidFill>
+          <a:ln>
+            <a:noFill/>
+          </a:ln>
+        </p:spPr>
+        <p:style>
+          <a:lnRef idx="1">
+            <a:schemeClr val="accent1"/>
+          </a:lnRef>
+          <a:fillRef idx="3">
+            <a:schemeClr val="accent1"/>
+          </a:fillRef>
+          <a:effectRef idx="2">
+            <a:schemeClr val="accent1"/>
+          </a:effectRef>
+          <a:fontRef idx="minor">
+            <a:schemeClr val="lt1"/>
+          </a:fontRef>
+        </p:style>
+        <p:txBody>
+          <a:bodyPr rtlCol="0" anchor="ctr" wrap="none"/>
+          <a:lstStyle/>
+          <a:p>
+            <a:pPr algn="ctr"/>
+            <a:r>
+              <a:rPr sz="650" b="0">
+                <a:solidFill>
+                  <a:srgbClr val="3A5278"/>
+                </a:solidFill>
+              </a:rPr>
+              <a:t>05 · Resultats</a:t>
+            </a:r>
+          </a:p>
+        </p:txBody>
+      </p:sp>
+      <p:sp>
+        <p:nvSpPr>
+          <p:cNvPr id="59" name="Rectangle 58"/>
+          <p:cNvSpPr/>
+          <p:nvPr/>
+        </p:nvSpPr>
+        <p:spPr>
+          <a:xfrm>
+            <a:off x="7620000" y="0"/>
+            <a:ext cx="1524000" cy="301752"/>
+          </a:xfrm>
+          <a:prstGeom prst="rect">
+            <a:avLst/>
+          </a:prstGeom>
+          <a:solidFill>
+            <a:srgbClr val="D8E4F4"/>
+          </a:solidFill>
+          <a:ln>
+            <a:noFill/>
+          </a:ln>
+        </p:spPr>
+        <p:style>
+          <a:lnRef idx="1">
+            <a:schemeClr val="accent1"/>
+          </a:lnRef>
+          <a:fillRef idx="3">
+            <a:schemeClr val="accent1"/>
+          </a:fillRef>
+          <a:effectRef idx="2">
+            <a:schemeClr val="accent1"/>
+          </a:effectRef>
+          <a:fontRef idx="minor">
+            <a:schemeClr val="lt1"/>
+          </a:fontRef>
+        </p:style>
+        <p:txBody>
+          <a:bodyPr rtlCol="0" anchor="ctr" wrap="none"/>
+          <a:lstStyle/>
+          <a:p>
+            <a:pPr algn="ctr"/>
+            <a:r>
+              <a:rPr sz="650" b="0">
+                <a:solidFill>
+                  <a:srgbClr val="3A5278"/>
+                </a:solidFill>
+              </a:rPr>
+              <a:t>06 · Perspectives</a:t>
+            </a:r>
+          </a:p>
+        </p:txBody>
+      </p:sp>
     </p:spTree>
   </p:cSld>
   <p:clrMapOvr>
@@ -20325,6 +24609,312 @@
               <a:t>Thumalien</a:t>
             </a:r>
             <a:endParaRPr lang="en-US" sz="1000" dirty="0"/>
+          </a:p>
+        </p:txBody>
+      </p:sp>
+      <p:sp>
+        <p:nvSpPr>
+          <p:cNvPr id="26" name="Rectangle 25"/>
+          <p:cNvSpPr/>
+          <p:nvPr/>
+        </p:nvSpPr>
+        <p:spPr>
+          <a:xfrm>
+            <a:off x="0" y="0"/>
+            <a:ext cx="1524000" cy="301752"/>
+          </a:xfrm>
+          <a:prstGeom prst="rect">
+            <a:avLst/>
+          </a:prstGeom>
+          <a:solidFill>
+            <a:srgbClr val="D8E4F4"/>
+          </a:solidFill>
+          <a:ln>
+            <a:noFill/>
+          </a:ln>
+        </p:spPr>
+        <p:style>
+          <a:lnRef idx="1">
+            <a:schemeClr val="accent1"/>
+          </a:lnRef>
+          <a:fillRef idx="3">
+            <a:schemeClr val="accent1"/>
+          </a:fillRef>
+          <a:effectRef idx="2">
+            <a:schemeClr val="accent1"/>
+          </a:effectRef>
+          <a:fontRef idx="minor">
+            <a:schemeClr val="lt1"/>
+          </a:fontRef>
+        </p:style>
+        <p:txBody>
+          <a:bodyPr rtlCol="0" anchor="ctr" wrap="none"/>
+          <a:lstStyle/>
+          <a:p>
+            <a:pPr algn="ctr"/>
+            <a:r>
+              <a:rPr sz="650" b="0">
+                <a:solidFill>
+                  <a:srgbClr val="3A5278"/>
+                </a:solidFill>
+              </a:rPr>
+              <a:t>01 · Contexte</a:t>
+            </a:r>
+          </a:p>
+        </p:txBody>
+      </p:sp>
+      <p:sp>
+        <p:nvSpPr>
+          <p:cNvPr id="27" name="Rectangle 26"/>
+          <p:cNvSpPr/>
+          <p:nvPr/>
+        </p:nvSpPr>
+        <p:spPr>
+          <a:xfrm>
+            <a:off x="1524000" y="0"/>
+            <a:ext cx="1524000" cy="301752"/>
+          </a:xfrm>
+          <a:prstGeom prst="rect">
+            <a:avLst/>
+          </a:prstGeom>
+          <a:solidFill>
+            <a:srgbClr val="D8E4F4"/>
+          </a:solidFill>
+          <a:ln>
+            <a:noFill/>
+          </a:ln>
+        </p:spPr>
+        <p:style>
+          <a:lnRef idx="1">
+            <a:schemeClr val="accent1"/>
+          </a:lnRef>
+          <a:fillRef idx="3">
+            <a:schemeClr val="accent1"/>
+          </a:fillRef>
+          <a:effectRef idx="2">
+            <a:schemeClr val="accent1"/>
+          </a:effectRef>
+          <a:fontRef idx="minor">
+            <a:schemeClr val="lt1"/>
+          </a:fontRef>
+        </p:style>
+        <p:txBody>
+          <a:bodyPr rtlCol="0" anchor="ctr" wrap="none"/>
+          <a:lstStyle/>
+          <a:p>
+            <a:pPr algn="ctr"/>
+            <a:r>
+              <a:rPr sz="650" b="0">
+                <a:solidFill>
+                  <a:srgbClr val="3A5278"/>
+                </a:solidFill>
+              </a:rPr>
+              <a:t>02 · Architecture</a:t>
+            </a:r>
+          </a:p>
+        </p:txBody>
+      </p:sp>
+      <p:sp>
+        <p:nvSpPr>
+          <p:cNvPr id="28" name="Rectangle 27"/>
+          <p:cNvSpPr/>
+          <p:nvPr/>
+        </p:nvSpPr>
+        <p:spPr>
+          <a:xfrm>
+            <a:off x="3048000" y="0"/>
+            <a:ext cx="1524000" cy="301752"/>
+          </a:xfrm>
+          <a:prstGeom prst="rect">
+            <a:avLst/>
+          </a:prstGeom>
+          <a:solidFill>
+            <a:srgbClr val="D8E4F4"/>
+          </a:solidFill>
+          <a:ln>
+            <a:noFill/>
+          </a:ln>
+        </p:spPr>
+        <p:style>
+          <a:lnRef idx="1">
+            <a:schemeClr val="accent1"/>
+          </a:lnRef>
+          <a:fillRef idx="3">
+            <a:schemeClr val="accent1"/>
+          </a:fillRef>
+          <a:effectRef idx="2">
+            <a:schemeClr val="accent1"/>
+          </a:effectRef>
+          <a:fontRef idx="minor">
+            <a:schemeClr val="lt1"/>
+          </a:fontRef>
+        </p:style>
+        <p:txBody>
+          <a:bodyPr rtlCol="0" anchor="ctr" wrap="none"/>
+          <a:lstStyle/>
+          <a:p>
+            <a:pPr algn="ctr"/>
+            <a:r>
+              <a:rPr sz="650" b="0">
+                <a:solidFill>
+                  <a:srgbClr val="3A5278"/>
+                </a:solidFill>
+              </a:rPr>
+              <a:t>03 · Suivi</a:t>
+            </a:r>
+          </a:p>
+        </p:txBody>
+      </p:sp>
+      <p:sp>
+        <p:nvSpPr>
+          <p:cNvPr id="29" name="Rectangle 28"/>
+          <p:cNvSpPr/>
+          <p:nvPr/>
+        </p:nvSpPr>
+        <p:spPr>
+          <a:xfrm>
+            <a:off x="4572000" y="0"/>
+            <a:ext cx="1524000" cy="301752"/>
+          </a:xfrm>
+          <a:prstGeom prst="rect">
+            <a:avLst/>
+          </a:prstGeom>
+          <a:solidFill>
+            <a:srgbClr val="1E408A"/>
+          </a:solidFill>
+          <a:ln>
+            <a:noFill/>
+          </a:ln>
+        </p:spPr>
+        <p:style>
+          <a:lnRef idx="1">
+            <a:schemeClr val="accent1"/>
+          </a:lnRef>
+          <a:fillRef idx="3">
+            <a:schemeClr val="accent1"/>
+          </a:fillRef>
+          <a:effectRef idx="2">
+            <a:schemeClr val="accent1"/>
+          </a:effectRef>
+          <a:fontRef idx="minor">
+            <a:schemeClr val="lt1"/>
+          </a:fontRef>
+        </p:style>
+        <p:txBody>
+          <a:bodyPr rtlCol="0" anchor="ctr" wrap="none"/>
+          <a:lstStyle/>
+          <a:p>
+            <a:pPr algn="ctr"/>
+            <a:r>
+              <a:rPr sz="650" b="1">
+                <a:solidFill>
+                  <a:srgbClr val="FFFFFF"/>
+                </a:solidFill>
+              </a:rPr>
+              <a:t>04 · Travaux</a:t>
+            </a:r>
+          </a:p>
+        </p:txBody>
+      </p:sp>
+      <p:sp>
+        <p:nvSpPr>
+          <p:cNvPr id="30" name="Rectangle 29"/>
+          <p:cNvSpPr/>
+          <p:nvPr/>
+        </p:nvSpPr>
+        <p:spPr>
+          <a:xfrm>
+            <a:off x="6096000" y="0"/>
+            <a:ext cx="1524000" cy="301752"/>
+          </a:xfrm>
+          <a:prstGeom prst="rect">
+            <a:avLst/>
+          </a:prstGeom>
+          <a:solidFill>
+            <a:srgbClr val="D8E4F4"/>
+          </a:solidFill>
+          <a:ln>
+            <a:noFill/>
+          </a:ln>
+        </p:spPr>
+        <p:style>
+          <a:lnRef idx="1">
+            <a:schemeClr val="accent1"/>
+          </a:lnRef>
+          <a:fillRef idx="3">
+            <a:schemeClr val="accent1"/>
+          </a:fillRef>
+          <a:effectRef idx="2">
+            <a:schemeClr val="accent1"/>
+          </a:effectRef>
+          <a:fontRef idx="minor">
+            <a:schemeClr val="lt1"/>
+          </a:fontRef>
+        </p:style>
+        <p:txBody>
+          <a:bodyPr rtlCol="0" anchor="ctr" wrap="none"/>
+          <a:lstStyle/>
+          <a:p>
+            <a:pPr algn="ctr"/>
+            <a:r>
+              <a:rPr sz="650" b="0">
+                <a:solidFill>
+                  <a:srgbClr val="3A5278"/>
+                </a:solidFill>
+              </a:rPr>
+              <a:t>05 · Resultats</a:t>
+            </a:r>
+          </a:p>
+        </p:txBody>
+      </p:sp>
+      <p:sp>
+        <p:nvSpPr>
+          <p:cNvPr id="31" name="Rectangle 30"/>
+          <p:cNvSpPr/>
+          <p:nvPr/>
+        </p:nvSpPr>
+        <p:spPr>
+          <a:xfrm>
+            <a:off x="7620000" y="0"/>
+            <a:ext cx="1524000" cy="301752"/>
+          </a:xfrm>
+          <a:prstGeom prst="rect">
+            <a:avLst/>
+          </a:prstGeom>
+          <a:solidFill>
+            <a:srgbClr val="D8E4F4"/>
+          </a:solidFill>
+          <a:ln>
+            <a:noFill/>
+          </a:ln>
+        </p:spPr>
+        <p:style>
+          <a:lnRef idx="1">
+            <a:schemeClr val="accent1"/>
+          </a:lnRef>
+          <a:fillRef idx="3">
+            <a:schemeClr val="accent1"/>
+          </a:fillRef>
+          <a:effectRef idx="2">
+            <a:schemeClr val="accent1"/>
+          </a:effectRef>
+          <a:fontRef idx="minor">
+            <a:schemeClr val="lt1"/>
+          </a:fontRef>
+        </p:style>
+        <p:txBody>
+          <a:bodyPr rtlCol="0" anchor="ctr" wrap="none"/>
+          <a:lstStyle/>
+          <a:p>
+            <a:pPr algn="ctr"/>
+            <a:r>
+              <a:rPr sz="650" b="0">
+                <a:solidFill>
+                  <a:srgbClr val="3A5278"/>
+                </a:solidFill>
+              </a:rPr>
+              <a:t>06 · Perspectives</a:t>
+            </a:r>
           </a:p>
         </p:txBody>
       </p:sp>

</xml_diff>